<commit_message>
Apresenta a região de Ilha Solteira com fotos e sazonalidade na abertura
</commit_message>
<xml_diff>
--- a/output/apresentacao_ilha_solteira.pptx
+++ b/output/apresentacao_ilha_solteira.pptx
@@ -2,30 +2,29 @@
 <file path=ppt/presentation.xml><?xml version="1.0" encoding="utf-8"?>
 <p:presentation xmlns:p="http://schemas.openxmlformats.org/presentationml/2006/main">
   <p:sldMasterIdLst>
-    <p:sldMasterId xmlns:r="http://schemas.openxmlformats.org/officeDocument/2006/relationships" id="2147483648" r:id="R89059fd27fec49bc"/>
+    <p:sldMasterId xmlns:r="http://schemas.openxmlformats.org/officeDocument/2006/relationships" id="2147483648" r:id="R43051ef24ee240c9"/>
   </p:sldMasterIdLst>
   <p:notesMasterIdLst>
-    <p:notesMasterId xmlns:r="http://schemas.openxmlformats.org/officeDocument/2006/relationships" r:id="R94e767404f764d26"/>
+    <p:notesMasterId xmlns:r="http://schemas.openxmlformats.org/officeDocument/2006/relationships" r:id="R72721b50d272450b"/>
   </p:notesMasterIdLst>
   <p:sldIdLst>
-    <p:sldId xmlns:r="http://schemas.openxmlformats.org/officeDocument/2006/relationships" id="256" r:id="Red5f32306e2341e4"/>
-    <p:sldId xmlns:r="http://schemas.openxmlformats.org/officeDocument/2006/relationships" id="257" r:id="R013b01dc131342ac"/>
-    <p:sldId xmlns:r="http://schemas.openxmlformats.org/officeDocument/2006/relationships" id="258" r:id="R1230732ca3854098"/>
-    <p:sldId xmlns:r="http://schemas.openxmlformats.org/officeDocument/2006/relationships" id="259" r:id="Re6e64f96edbf4b8e"/>
-    <p:sldId xmlns:r="http://schemas.openxmlformats.org/officeDocument/2006/relationships" id="260" r:id="Rf82b1c5b9dfd4bde"/>
-    <p:sldId xmlns:r="http://schemas.openxmlformats.org/officeDocument/2006/relationships" id="261" r:id="Rc0f8748fe297466b"/>
-    <p:sldId xmlns:r="http://schemas.openxmlformats.org/officeDocument/2006/relationships" id="262" r:id="R47296d1b905648c5"/>
-    <p:sldId xmlns:r="http://schemas.openxmlformats.org/officeDocument/2006/relationships" id="263" r:id="Rfd63c8c058cd4ff3"/>
-    <p:sldId xmlns:r="http://schemas.openxmlformats.org/officeDocument/2006/relationships" id="264" r:id="R5bd44c90b456445e"/>
-    <p:sldId xmlns:r="http://schemas.openxmlformats.org/officeDocument/2006/relationships" id="265" r:id="Rffedda0baad04fa5"/>
-    <p:sldId xmlns:r="http://schemas.openxmlformats.org/officeDocument/2006/relationships" id="266" r:id="R0187ccafc34a421a"/>
-    <p:sldId xmlns:r="http://schemas.openxmlformats.org/officeDocument/2006/relationships" id="267" r:id="R95c7d30b5948435b"/>
-    <p:sldId xmlns:r="http://schemas.openxmlformats.org/officeDocument/2006/relationships" id="268" r:id="R7e0a90e17af24d2e"/>
-    <p:sldId xmlns:r="http://schemas.openxmlformats.org/officeDocument/2006/relationships" id="269" r:id="R4578cfe3b39e433c"/>
-    <p:sldId xmlns:r="http://schemas.openxmlformats.org/officeDocument/2006/relationships" id="270" r:id="Re1d879c038ce40ff"/>
-    <p:sldId xmlns:r="http://schemas.openxmlformats.org/officeDocument/2006/relationships" id="271" r:id="R534eb47533664907"/>
-    <p:sldId xmlns:r="http://schemas.openxmlformats.org/officeDocument/2006/relationships" id="272" r:id="R9c1c4827a144439b"/>
-    <p:sldId xmlns:r="http://schemas.openxmlformats.org/officeDocument/2006/relationships" id="273" r:id="R9111fc0e31124d10"/>
+    <p:sldId xmlns:r="http://schemas.openxmlformats.org/officeDocument/2006/relationships" id="256" r:id="Rf9fe43a5f6b54741"/>
+    <p:sldId xmlns:r="http://schemas.openxmlformats.org/officeDocument/2006/relationships" id="257" r:id="R1b19fd7f7ba84d65"/>
+    <p:sldId xmlns:r="http://schemas.openxmlformats.org/officeDocument/2006/relationships" id="258" r:id="Rc49baf8f89b14c80"/>
+    <p:sldId xmlns:r="http://schemas.openxmlformats.org/officeDocument/2006/relationships" id="259" r:id="Rcb0329d5d04c4865"/>
+    <p:sldId xmlns:r="http://schemas.openxmlformats.org/officeDocument/2006/relationships" id="260" r:id="Rf127d7c8191d446e"/>
+    <p:sldId xmlns:r="http://schemas.openxmlformats.org/officeDocument/2006/relationships" id="261" r:id="R9aa3df235b6a4b25"/>
+    <p:sldId xmlns:r="http://schemas.openxmlformats.org/officeDocument/2006/relationships" id="262" r:id="R65666869868b45d4"/>
+    <p:sldId xmlns:r="http://schemas.openxmlformats.org/officeDocument/2006/relationships" id="263" r:id="R5a9eb8935ea94fd5"/>
+    <p:sldId xmlns:r="http://schemas.openxmlformats.org/officeDocument/2006/relationships" id="264" r:id="Rc03c4d052dd245d5"/>
+    <p:sldId xmlns:r="http://schemas.openxmlformats.org/officeDocument/2006/relationships" id="265" r:id="Ra71a32a14a3140d2"/>
+    <p:sldId xmlns:r="http://schemas.openxmlformats.org/officeDocument/2006/relationships" id="266" r:id="R075715af4ad743c8"/>
+    <p:sldId xmlns:r="http://schemas.openxmlformats.org/officeDocument/2006/relationships" id="267" r:id="Rcdcb1fe0293d4a6a"/>
+    <p:sldId xmlns:r="http://schemas.openxmlformats.org/officeDocument/2006/relationships" id="268" r:id="R8c147b3119064e41"/>
+    <p:sldId xmlns:r="http://schemas.openxmlformats.org/officeDocument/2006/relationships" id="269" r:id="Rc30d3a850b3a4554"/>
+    <p:sldId xmlns:r="http://schemas.openxmlformats.org/officeDocument/2006/relationships" id="270" r:id="R04d84f0889574b8d"/>
+    <p:sldId xmlns:r="http://schemas.openxmlformats.org/officeDocument/2006/relationships" id="271" r:id="Redaadac3d5534246"/>
+    <p:sldId xmlns:r="http://schemas.openxmlformats.org/officeDocument/2006/relationships" id="272" r:id="Rcabd4a7291664b5b"/>
   </p:sldIdLst>
   <p:sldSz cx="12192000" cy="6858000"/>
   <p:notesSz cx="6858000" cy="9144000"/>
@@ -459,7 +458,7 @@
           <a:lstStyle xmlns:a="http://schemas.openxmlformats.org/drawingml/2006/main"/>
           <a:p xmlns:a="http://schemas.openxmlformats.org/drawingml/2006/main">
             <a:r>
-              <a:t>Tempo: 40 segundos. Apresente o objetivo: comparar ARIMA e SARIMA e quantificar a incerteza. A base termina em dezembro de 2016. Todas as projeções para 2017 são históricas. Fonte: data/processed/ilha_solteira_mensal.csv, extraído de ILHA_SOLTEIRA.pdf.</a:t>
+              <a:t>Tempo: 85 segundos. Comece pela região. A Usina Ilha Solteira fica no rio Paraná, entre Ilha Solteira, em São Paulo, e Selvíria, em Mato Grosso do Sul. A foto mostra seu vertedouro. Passe ao gráfico: cada coluna reúne a média daquele mês nos 86 anos da série. Fevereiro tem a maior média e setembro a menor. Essa sazonalidade motiva considerar um ciclo de 12 meses. O gráfico descreve a base completa e não participa da seleção de parâmetros. A unidade e a natureza da vazão não foram informadas no PDF. A série começa antes da construção da usina, portanto não a apresente como uma série de medições da operação da usina. Fontes: https://www.ctgbr.com.br/unidade/uhe-ilha-solteira/ ; data/processed/ilha_solteira_mensal.csv. Foto: Carlos Alves, Wikimedia Commons, https://commons.wikimedia.org/wiki/File:Usina_UHE_Ilha_Solteira_-_panoramio_-_Carlos_Alves_(2).jpg . Licença CC BY 3.0, https://creativecommons.org/licenses/by/3.0/ . Foto recortada para o enquadramento do slide.</a:t>
             </a:r>
           </a:p>
         </p:txBody>
@@ -529,7 +528,7 @@
           <a:lstStyle xmlns:a="http://schemas.openxmlformats.org/drawingml/2006/main"/>
           <a:p xmlns:a="http://schemas.openxmlformats.org/drawingml/2006/main">
             <a:r>
-              <a:t>Tempo: 70 segundos. Menor RMSE é melhor, e a medida penaliza erros grandes. O ingênuo sazonal repete os últimos 12 meses disponíveis, de 2013, para os três anos do teste. A média por mês usa todo o histórico até 2013. Ambos superam os modelos nesta janela. Isso impede concluir que maior complexidade produziu melhor previsão. Fonte: output/tables/metricas_teste.csv.</a:t>
+              <a:t>Tempo: 70 segundos. A linha escura mostra os 36 valores observados. Compare a oscilação sazonal do SARIMA à trajetória do ARIMA. Durante parte do teste, os valores previstos ficam acima dos observados. A média do teste é menor que a média do período de ajuste. Isso é uma descrição, não uma prova de mudança estrutural ou causa climática. Fonte: output/tables/previsoes_teste.csv e output/resumo.json.</a:t>
             </a:r>
           </a:p>
         </p:txBody>
@@ -599,7 +598,7 @@
           <a:lstStyle xmlns:a="http://schemas.openxmlformats.org/drawingml/2006/main"/>
           <a:p xmlns:a="http://schemas.openxmlformats.org/drawingml/2006/main">
             <a:r>
-              <a:t>Tempo: 70 segundos. A linha escura mostra os 36 valores observados. Compare a oscilação sazonal do SARIMA à trajetória do ARIMA. Durante parte do teste, os valores previstos ficam acima dos observados. A média do teste é menor que a média do período de ajuste. Isso é uma descrição, não uma prova de mudança estrutural ou causa climática. Fonte: output/tables/previsoes_teste.csv e output/resumo.json.</a:t>
+              <a:t>Tempo: 60 segundos. Os limites representam quantis condicionais do modelo para cada mês, e não garantem cobertura de toda a trajetória. A linha central é a média com correção de viés ao voltar do log: exp(mu + variância/2). A mediana seria exp(mu). Os limites vêm de exp dos limites no log. A largura na escala original depende também do nível previsto. Fonte: output/tables/previsoes_teste.csv. Fórmulas: src/modelos.py, prever.</a:t>
             </a:r>
           </a:p>
         </p:txBody>
@@ -669,7 +668,7 @@
           <a:lstStyle xmlns:a="http://schemas.openxmlformats.org/drawingml/2006/main"/>
           <a:p xmlns:a="http://schemas.openxmlformats.org/drawingml/2006/main">
             <a:r>
-              <a:t>Tempo: 60 segundos. Os limites representam quantis condicionais do modelo para cada mês, e não garantem cobertura de toda a trajetória. A linha central é a média com correção de viés ao voltar do log: exp(mu + variância/2). A mediana seria exp(mu). Os limites vêm de exp dos limites no log. A largura na escala original depende também do nível previsto. Fonte: output/tables/previsoes_teste.csv. Fórmulas: src/modelos.py, prever.</a:t>
+              <a:t>Tempo: 60 segundos. A sazonalidade também altera os limites do SARIMA. Compare a faixa nos meses de valores altos. Uma faixa larga pode cobrir observações mesmo com previsão central ruim. Por isso lemos cobertura junto com a largura e o erro. Fonte: output/tables/previsoes_teste.csv.</a:t>
             </a:r>
           </a:p>
         </p:txBody>
@@ -739,7 +738,7 @@
           <a:lstStyle xmlns:a="http://schemas.openxmlformats.org/drawingml/2006/main"/>
           <a:p xmlns:a="http://schemas.openxmlformats.org/drawingml/2006/main">
             <a:r>
-              <a:t>Tempo: 60 segundos. A sazonalidade também altera os limites do SARIMA. Compare a faixa nos meses de valores altos. Uma faixa larga pode cobrir observações mesmo com previsão central ruim. Por isso lemos cobertura junto com a largura e o erro. Fonte: output/tables/previsoes_teste.csv.</a:t>
+              <a:t>Tempo: 65 segundos. O ARIMA cobriu 91,7% dos meses e o SARIMA cobriu 83,3%. O nominal é 95%, mas 36 observações são poucas e dependentes. Não afirmamos calibração apenas por esse número. A largura média foi maior no ARIMA. Não há intervalo calculado para as baselines neste projeto. Fonte: output/tables/metricas_teste.csv.</a:t>
             </a:r>
           </a:p>
         </p:txBody>
@@ -809,7 +808,7 @@
           <a:lstStyle xmlns:a="http://schemas.openxmlformats.org/drawingml/2006/main"/>
           <a:p xmlns:a="http://schemas.openxmlformats.org/drawingml/2006/main">
             <a:r>
-              <a:t>Tempo: 65 segundos. O ARIMA cobriu 91,7% dos meses e o SARIMA cobriu 83,3%. O nominal é 95%, mas 36 observações são poucas e dependentes. Não afirmamos calibração apenas por esse número. A largura média foi maior no ARIMA. Não há intervalo calculado para as baselines neste projeto. Fonte: output/tables/metricas_teste.csv.</a:t>
+              <a:t>Tempo: 70 segundos. Ljung–Box verifica se resta autocorrelação conjunta. Os p-valores abaixo de 0,05 em 12 e 24 defasagens rejeitam a hipótese de ausência dessa dependência nos dois modelos. Jarque–Bera também rejeita normalidade nos dois. Esses resultados limitam a confiança nos intervalos paramétricos. Não escondemos os diagnósticos desfavoráveis. Fonte: output/tables/diagnosticos.csv.</a:t>
             </a:r>
           </a:p>
         </p:txBody>
@@ -879,7 +878,7 @@
           <a:lstStyle xmlns:a="http://schemas.openxmlformats.org/drawingml/2006/main"/>
           <a:p xmlns:a="http://schemas.openxmlformats.org/drawingml/2006/main">
             <a:r>
-              <a:t>Tempo: 70 segundos. Ljung–Box verifica se resta autocorrelação conjunta. Os p-valores abaixo de 0,05 em 12 e 24 defasagens rejeitam a hipótese de ausência dessa dependência nos dois modelos. Jarque–Bera também rejeita normalidade nos dois. Esses resultados limitam a confiança nos intervalos paramétricos. Não escondemos os diagnósticos desfavoráveis. Fonte: output/tables/diagnosticos.csv.</a:t>
+              <a:t>Tempo: 75 segundos. Depois de medir o desempenho, reajustamos as estruturas selecionadas usando todos os dados até dezembro de 2016. O gráfico mostra SARIMA com seus limites e a média ARIMA para comparação. Os valores observados de 2017 não estão no arquivo. Portanto, esta é uma projeção histórica sem avaliação externa e nunca deve ser apresentada como previsão atual. Fonte: output/tables/previsoes_2017.csv.</a:t>
             </a:r>
           </a:p>
         </p:txBody>
@@ -949,7 +948,7 @@
           <a:lstStyle xmlns:a="http://schemas.openxmlformats.org/drawingml/2006/main"/>
           <a:p xmlns:a="http://schemas.openxmlformats.org/drawingml/2006/main">
             <a:r>
-              <a:t>Tempo: 75 segundos. Depois de medir o desempenho, reajustamos as estruturas selecionadas usando todos os dados até dezembro de 2016. O gráfico mostra SARIMA com seus limites e a média ARIMA para comparação. Os valores observados de 2017 não estão no arquivo. Portanto, esta é uma projeção histórica sem avaliação externa e nunca deve ser apresentada como previsão atual. Fonte: output/tables/previsoes_2017.csv.</a:t>
+              <a:t>Tempo: 70 segundos. Resuma com transparência. Há sazonalidade anual, mas isso não garante que o SARIMA escolhido seja o melhor em qualquer período. A validação favoreceu SARIMA e o teste favoreceu o ingênuo sazonal. Os resíduos mostram inadequação dos modelos e os intervalos são largos. Melhorias futuras incluem validação com horizontes comparáveis e modelos com covariáveis, desde que dados adicionais existam. Fontes: métricas, diagnósticos e ranking em output/tables.</a:t>
             </a:r>
           </a:p>
         </p:txBody>
@@ -980,76 +979,6 @@
 </file>
 
 <file path=ppt/notesSlides/notesSlide17.xml><?xml version="1.0" encoding="utf-8"?>
-<p:notes xmlns:p="http://schemas.openxmlformats.org/presentationml/2006/main">
-  <p:cSld>
-    <p:spTree>
-      <p:nvGrpSpPr>
-        <p:cNvPr id="1" name=""/>
-        <p:cNvGrpSpPr/>
-        <p:nvPr/>
-      </p:nvGrpSpPr>
-      <p:grpSpPr>
-        <a:xfrm xmlns:a="http://schemas.openxmlformats.org/drawingml/2006/main"/>
-      </p:grpSpPr>
-      <p:sp>
-        <p:nvSpPr>
-          <p:cNvPr id="2" name="Slide Image Placeholder 1"/>
-          <p:cNvSpPr>
-            <a:spLocks xmlns:a="http://schemas.openxmlformats.org/drawingml/2006/main" noGrp="1"/>
-          </p:cNvSpPr>
-          <p:nvPr>
-            <p:ph type="sldImg" idx="0"/>
-          </p:nvPr>
-        </p:nvSpPr>
-        <p:spPr/>
-      </p:sp>
-      <p:sp>
-        <p:nvSpPr>
-          <p:cNvPr id="3" name="Notes Placeholder 2"/>
-          <p:cNvSpPr>
-            <a:spLocks xmlns:a="http://schemas.openxmlformats.org/drawingml/2006/main" noGrp="1"/>
-          </p:cNvSpPr>
-          <p:nvPr>
-            <p:ph type="body" idx="1"/>
-          </p:nvPr>
-        </p:nvSpPr>
-        <p:spPr/>
-        <p:txBody>
-          <a:bodyPr xmlns:a="http://schemas.openxmlformats.org/drawingml/2006/main"/>
-          <a:lstStyle xmlns:a="http://schemas.openxmlformats.org/drawingml/2006/main"/>
-          <a:p xmlns:a="http://schemas.openxmlformats.org/drawingml/2006/main">
-            <a:r>
-              <a:t>Tempo: 70 segundos. Resuma com transparência. Há sazonalidade anual, mas isso não garante que o SARIMA escolhido seja o melhor em qualquer período. A validação favoreceu SARIMA e o teste favoreceu o ingênuo sazonal. Os resíduos mostram inadequação dos modelos e os intervalos são largos. Melhorias futuras incluem validação com horizontes comparáveis e modelos com covariáveis, desde que dados adicionais existam. Fontes: métricas, diagnósticos e ranking em output/tables.</a:t>
-            </a:r>
-          </a:p>
-        </p:txBody>
-      </p:sp>
-      <p:sp>
-        <p:nvSpPr>
-          <p:cNvPr id="4" name="Slide Number Placeholder 3"/>
-          <p:cNvSpPr>
-            <a:spLocks xmlns:a="http://schemas.openxmlformats.org/drawingml/2006/main" noGrp="1"/>
-          </p:cNvSpPr>
-          <p:nvPr>
-            <p:ph type="sldNum" idx="5"/>
-          </p:nvPr>
-        </p:nvSpPr>
-        <p:spPr/>
-        <p:txBody>
-          <a:bodyPr xmlns:a="http://schemas.openxmlformats.org/drawingml/2006/main"/>
-          <a:lstStyle xmlns:a="http://schemas.openxmlformats.org/drawingml/2006/main"/>
-          <a:p xmlns:a="http://schemas.openxmlformats.org/drawingml/2006/main"/>
-        </p:txBody>
-      </p:sp>
-    </p:spTree>
-  </p:cSld>
-  <p:clrMapOvr>
-    <a:masterClrMapping xmlns:a="http://schemas.openxmlformats.org/drawingml/2006/main"/>
-  </p:clrMapOvr>
-</p:notes>
-</file>
-
-<file path=ppt/notesSlides/notesSlide18.xml><?xml version="1.0" encoding="utf-8"?>
 <p:notes xmlns:p="http://schemas.openxmlformats.org/presentationml/2006/main">
   <p:cSld>
     <p:spTree>
@@ -1159,7 +1088,7 @@
           <a:lstStyle xmlns:a="http://schemas.openxmlformats.org/drawingml/2006/main"/>
           <a:p xmlns:a="http://schemas.openxmlformats.org/drawingml/2006/main">
             <a:r>
-              <a:t>Tempo: 45 segundos. Queremos antecipar vazões mensais usando apenas o passado e apresentar uma faixa de valores plausíveis. Os intervalos são preditivos, pois se referem a novas observações. Um intervalo de confiança de coeficiente responde a outra pergunta. Os exemplos fornecidos orientam a exploração, diferenciação e modelagem, com APIs atuais. Fontes: EXEMPLO.pdf, EXEMPLO_01.pdf e statsmodels SARIMAXResults.get_forecast.</a:t>
+              <a:t>Tempo: 60 segundos. Use a foto da Praça Paiaguás para apresentar a cidade. Ilha Solteira surgiu em 1968 para abrigar trabalhadores da construção da hidrelétrica. Em 18 de julho de 1973, a primeira unidade geradora entrou em operação. A relação entre cidade, rio e geração de energia dá contexto ao estudo. Faça a transição: agora vamos conhecer a série de vazões que o grupo recebeu. Fonte: https://www.ctgbr.com.br/unidade/uhe-ilha-solteira/ . Foto: Praça Paiaguás em Ilha Solteira-SP, Brasil, Mof0, 25 de agosto de 2008, https://commons.wikimedia.org/wiki/File:Pra%C3%A7a_Paiagu%C3%A1s_em_Ilha_Solteira-SP,_Brasil.jpg . Licença CC BY-SA 2.0, https://creativecommons.org/licenses/by-sa/2.0/ . Imagem integral, redimensionada, sem recorte. As fotografias ilustram os locais e não representam um registro atual de 2026.</a:t>
             </a:r>
           </a:p>
         </p:txBody>
@@ -1369,7 +1298,7 @@
           <a:lstStyle xmlns:a="http://schemas.openxmlformats.org/drawingml/2006/main"/>
           <a:p xmlns:a="http://schemas.openxmlformats.org/drawingml/2006/main">
             <a:r>
-              <a:t>Tempo: 55 segundos. Cada coluna é a média de todas as observações daquele mês, calculada apenas para descrição da base completa. Fevereiro tem a maior média e setembro a menor. A repetição anual de dados mensais justifica período sazonal 12. Este gráfico não participa da seleção de parâmetros, que usa treino e validação. Fonte: data/processed/ilha_solteira_mensal.csv, extraído de ILHA_SOLTEIRA.pdf.</a:t>
+              <a:t>Tempo: 75 segundos. No treino inicial, estimamos candidatos até 2008. Na validação, usamos cinco origens anuais e prevemos os próximos 12 meses de 2009 a 2013, expandindo o histórico. Depois fixamos um modelo de cada família. O teste usa uma única origem em dezembro de 2013 e 36 meses à frente. Assim nenhum valor de 2014–2016 escolhe parâmetros. O horizonte de teste é maior que o de validação. Fonte: src/modelos.py, selecionar e avaliar_e_prever.</a:t>
             </a:r>
           </a:p>
         </p:txBody>
@@ -1439,7 +1368,7 @@
           <a:lstStyle xmlns:a="http://schemas.openxmlformats.org/drawingml/2006/main"/>
           <a:p xmlns:a="http://schemas.openxmlformats.org/drawingml/2006/main">
             <a:r>
-              <a:t>Tempo: 75 segundos. No treino inicial, estimamos candidatos até 2008. Na validação, usamos cinco origens anuais e prevemos os próximos 12 meses de 2009 a 2013, expandindo o histórico. Depois fixamos um modelo de cada família. O teste usa uma única origem em dezembro de 2013 e 36 meses à frente. Assim nenhum valor de 2014–2016 escolhe parâmetros. O horizonte de teste é maior que o de validação. Fonte: src/modelos.py, selecionar e avaliar_e_prever.</a:t>
+              <a:t>Tempo: 70 segundos. AR representa dependência de valores passados, I representa diferenças e MA representa erros passados. SARIMA acrescenta dependência sazonal. p e q controlam ordens não sazonais, d as diferenças. P, D e Q são os equivalentes sazonais. O 12 corresponde ao ciclo anual. A constante aparece nos dois modelos selecionados. Fonte: statsmodels.tsa.statespace.sarimax.SARIMAX e src/modelos.py.</a:t>
             </a:r>
           </a:p>
         </p:txBody>
@@ -1509,7 +1438,7 @@
           <a:lstStyle xmlns:a="http://schemas.openxmlformats.org/drawingml/2006/main"/>
           <a:p xmlns:a="http://schemas.openxmlformats.org/drawingml/2006/main">
             <a:r>
-              <a:t>Tempo: 70 segundos. AR representa dependência de valores passados, I representa diferenças e MA representa erros passados. SARIMA acrescenta dependência sazonal. p e q controlam ordens não sazonais, d as diferenças. P, D e Q são os equivalentes sazonais. O 12 corresponde ao ciclo anual. A constante aparece nos dois modelos selecionados. Fonte: statsmodels.tsa.statespace.sarimax.SARIMAX e src/modelos.py.</a:t>
+              <a:t>Tempo: 75 segundos. Ajustamos log da vazão porque todos os valores são positivos. Isso reduz assimetria e permite intervalos positivos após exponenciar. Subtraímos a média do log calculada apenas no histórico de cada ajuste para melhorar a estabilidade numérica, e somamos esse centro antes de voltar à escala original. Diferença de ordem 1 compara meses consecutivos. Diferença sazonal compara o mês ao mesmo mês do ano anterior. No treino, ADF rejeita raiz unitária, mas KPSS rejeita estacionariedade em nível e log. Esse desacordo exige cautela. Comparamos d igual a zero ou um no ARIMA. No SARIMA, fixamos d=0 e comparamos D igual a zero ou um. A validação escolheu zero nas diferenças dos dois modelos. Fonte: output/tables/estacionariedade.csv e src/modelos.py.</a:t>
             </a:r>
           </a:p>
         </p:txBody>
@@ -1579,7 +1508,7 @@
           <a:lstStyle xmlns:a="http://schemas.openxmlformats.org/drawingml/2006/main"/>
           <a:p xmlns:a="http://schemas.openxmlformats.org/drawingml/2006/main">
             <a:r>
-              <a:t>Tempo: 75 segundos. Ajustamos log da vazão porque todos os valores são positivos. Isso reduz assimetria e permite intervalos positivos após exponenciar. Subtraímos a média do log calculada apenas no histórico de cada ajuste para melhorar a estabilidade numérica, e somamos esse centro antes de voltar à escala original. Diferença de ordem 1 compara meses consecutivos. Diferença sazonal compara o mês ao mesmo mês do ano anterior. No treino, ADF rejeita raiz unitária, mas KPSS rejeita estacionariedade em nível e log. Esse desacordo exige cautela. Comparamos d igual a zero ou um no ARIMA. No SARIMA, fixamos d=0 e comparamos D igual a zero ou um. A validação escolheu zero nas diferenças dos dois modelos. Fonte: output/tables/estacionariedade.csv e src/modelos.py.</a:t>
+              <a:t>Tempo: 65 segundos. AIC faz uma triagem dentro de grupos com a mesma família e as mesmas diferenças d e D. Os dois melhores convergentes de cada grupo seguem para validação. O RMSE médio das cinco origens escolhe um por família. O SARIMA ganha na validação, mas ainda precisa enfrentar o teste reservado. Fonte: output/tables/busca_modelos.csv e ranking_validacao.csv.</a:t>
             </a:r>
           </a:p>
         </p:txBody>
@@ -1649,7 +1578,7 @@
           <a:lstStyle xmlns:a="http://schemas.openxmlformats.org/drawingml/2006/main"/>
           <a:p xmlns:a="http://schemas.openxmlformats.org/drawingml/2006/main">
             <a:r>
-              <a:t>Tempo: 65 segundos. AIC faz uma triagem dentro de grupos com a mesma família e as mesmas diferenças d e D. Os dois melhores convergentes de cada grupo seguem para validação. O RMSE médio das cinco origens escolhe um por família. O SARIMA ganha na validação, mas ainda precisa enfrentar o teste reservado. Fonte: output/tables/busca_modelos.csv e ranking_validacao.csv.</a:t>
+              <a:t>Tempo: 70 segundos. Menor RMSE é melhor, e a medida penaliza erros grandes. O ingênuo sazonal repete os últimos 12 meses disponíveis, de 2013, para os três anos do teste. A média por mês usa todo o histórico até 2013. Ambos superam os modelos nesta janela. Isso impede concluir que maior complexidade produziu melhor previsão. Fonte: output/tables/metricas_teste.csv.</a:t>
             </a:r>
           </a:p>
         </p:txBody>
@@ -1717,7 +1646,7 @@
   </p:cSld>
   <p:clrMap bg1="lt1" tx1="dk1" bg2="lt2" tx2="dk2" accent1="accent1" accent2="accent2" accent3="accent3" accent4="accent4" accent5="accent5" accent6="accent6" hlink="hlink" folHlink="folHlink"/>
   <p:sldLayoutIdLst>
-    <p:sldLayoutId xmlns:r="http://schemas.openxmlformats.org/officeDocument/2006/relationships" id="2147483649" r:id="Rf6eb6fc1dd534697"/>
+    <p:sldLayoutId xmlns:r="http://schemas.openxmlformats.org/officeDocument/2006/relationships" id="2147483649" r:id="Rd9791ed121514622"/>
   </p:sldLayoutIdLst>
   <p:txStyles>
     <p:titleStyle>
@@ -2249,6 +2178,225 @@
   <c:lang val="en-US"/>
   <c:chart>
     <c:plotArea>
+      <c:barChart>
+        <c:barDir val="col"/>
+        <c:grouping val="clustered"/>
+        <c:varyColors val="0"/>
+        <c:ser>
+          <c:idx val="0"/>
+          <c:order val="0"/>
+          <c:tx>
+            <c:v>Média mensal histórica</c:v>
+          </c:tx>
+          <c:spPr>
+            <a:solidFill xmlns:a="http://schemas.openxmlformats.org/drawingml/2006/main">
+              <a:srgbClr val="007F80"/>
+            </a:solidFill>
+          </c:spPr>
+          <c:invertIfNegative val="0"/>
+          <c:cat>
+            <c:strRef>
+              <c:f>'Chart Data'!$A$2:$A$13</c:f>
+              <c:strCache>
+                <c:ptCount val="12"/>
+                <c:pt idx="0">
+                  <c:v>Jan</c:v>
+                </c:pt>
+                <c:pt idx="1">
+                  <c:v>Fev</c:v>
+                </c:pt>
+                <c:pt idx="2">
+                  <c:v>Mar</c:v>
+                </c:pt>
+                <c:pt idx="3">
+                  <c:v>Abr</c:v>
+                </c:pt>
+                <c:pt idx="4">
+                  <c:v>Mai</c:v>
+                </c:pt>
+                <c:pt idx="5">
+                  <c:v>Jun</c:v>
+                </c:pt>
+                <c:pt idx="6">
+                  <c:v>Jul</c:v>
+                </c:pt>
+                <c:pt idx="7">
+                  <c:v>Ago</c:v>
+                </c:pt>
+                <c:pt idx="8">
+                  <c:v>Set</c:v>
+                </c:pt>
+                <c:pt idx="9">
+                  <c:v>Out</c:v>
+                </c:pt>
+                <c:pt idx="10">
+                  <c:v>Nov</c:v>
+                </c:pt>
+                <c:pt idx="11">
+                  <c:v>Dez</c:v>
+                </c:pt>
+              </c:strCache>
+            </c:strRef>
+          </c:cat>
+          <c:val>
+            <c:numRef>
+              <c:f>'Chart Data'!$B$2:$B$13</c:f>
+              <c:numCache>
+                <c:formatCode>0</c:formatCode>
+                <c:ptCount val="12"/>
+                <c:pt idx="0">
+                  <c:v>8846.8488</c:v>
+                </c:pt>
+                <c:pt idx="1">
+                  <c:v>9271.7674</c:v>
+                </c:pt>
+                <c:pt idx="2">
+                  <c:v>8925.2209</c:v>
+                </c:pt>
+                <c:pt idx="3">
+                  <c:v>6728.5814</c:v>
+                </c:pt>
+                <c:pt idx="4">
+                  <c:v>4615.1163</c:v>
+                </c:pt>
+                <c:pt idx="5">
+                  <c:v>3780.0814</c:v>
+                </c:pt>
+                <c:pt idx="6">
+                  <c:v>3088.4651</c:v>
+                </c:pt>
+                <c:pt idx="7">
+                  <c:v>2586.2674</c:v>
+                </c:pt>
+                <c:pt idx="8">
+                  <c:v>2464.8372</c:v>
+                </c:pt>
+                <c:pt idx="9">
+                  <c:v>2831.3721</c:v>
+                </c:pt>
+                <c:pt idx="10">
+                  <c:v>3882.3256</c:v>
+                </c:pt>
+                <c:pt idx="11">
+                  <c:v>6238.9186</c:v>
+                </c:pt>
+              </c:numCache>
+            </c:numRef>
+          </c:val>
+        </c:ser>
+        <c:gapWidth val="65"/>
+        <c:axId val="48650112"/>
+        <c:axId val="48672768"/>
+      </c:barChart>
+      <c:catAx>
+        <c:axId val="48650112"/>
+        <c:scaling>
+          <c:orientation val="minMax"/>
+        </c:scaling>
+        <c:delete val="0"/>
+        <c:axPos val="b"/>
+        <c:numFmt formatCode="General"/>
+        <c:majorTickMark val="none"/>
+        <c:minorTickMark val="none"/>
+        <c:spPr>
+          <a:ln xmlns:a="http://schemas.openxmlformats.org/drawingml/2006/main" w="9525">
+            <a:solidFill>
+              <a:srgbClr val="D7DDD8"/>
+            </a:solidFill>
+          </a:ln>
+        </c:spPr>
+        <c:txPr>
+          <a:bodyPr xmlns:a="http://schemas.openxmlformats.org/drawingml/2006/main" anchorCtr="1"/>
+          <a:lstStyle xmlns:a="http://schemas.openxmlformats.org/drawingml/2006/main"/>
+          <a:p xmlns:a="http://schemas.openxmlformats.org/drawingml/2006/main">
+            <a:pPr>
+              <a:defRPr sz="1200">
+                <a:solidFill>
+                  <a:srgbClr val="18343E"/>
+                </a:solidFill>
+                <a:latin typeface="Arial"/>
+                <a:ea typeface="Arial"/>
+                <a:cs typeface="Arial"/>
+              </a:defRPr>
+            </a:pPr>
+          </a:p>
+        </c:txPr>
+        <c:crossAx val="48672768"/>
+        <c:tickLblSkip val="1"/>
+        <c:tickMarkSkip val="1"/>
+      </c:catAx>
+      <c:valAx>
+        <c:axId val="48672768"/>
+        <c:scaling>
+          <c:orientation val="minMax"/>
+          <c:max val="10000"/>
+          <c:min val="0"/>
+        </c:scaling>
+        <c:delete val="0"/>
+        <c:axPos val="l"/>
+        <c:majorGridlines>
+          <c:spPr>
+            <a:ln xmlns:a="http://schemas.openxmlformats.org/drawingml/2006/main" w="9525">
+              <a:solidFill>
+                <a:srgbClr val="D7DDD8"/>
+              </a:solidFill>
+            </a:ln>
+          </c:spPr>
+        </c:majorGridlines>
+        <c:numFmt formatCode="0"/>
+        <c:majorTickMark val="none"/>
+        <c:minorTickMark val="none"/>
+        <c:spPr>
+          <a:ln xmlns:a="http://schemas.openxmlformats.org/drawingml/2006/main" w="9525">
+            <a:solidFill>
+              <a:srgbClr val="D4D4D4"/>
+            </a:solidFill>
+            <a:prstDash val="solid"/>
+          </a:ln>
+        </c:spPr>
+        <c:txPr>
+          <a:bodyPr xmlns:a="http://schemas.openxmlformats.org/drawingml/2006/main" anchorCtr="1"/>
+          <a:lstStyle xmlns:a="http://schemas.openxmlformats.org/drawingml/2006/main"/>
+          <a:p xmlns:a="http://schemas.openxmlformats.org/drawingml/2006/main">
+            <a:pPr>
+              <a:defRPr sz="1275">
+                <a:solidFill>
+                  <a:srgbClr val="18343E"/>
+                </a:solidFill>
+                <a:latin typeface="Arial"/>
+                <a:ea typeface="Arial"/>
+                <a:cs typeface="Arial"/>
+              </a:defRPr>
+            </a:pPr>
+          </a:p>
+        </c:txPr>
+        <c:crossAx val="48650112"/>
+        <c:crossBetween val="between"/>
+      </c:valAx>
+      <c:spPr>
+        <a:solidFill xmlns:a="http://schemas.openxmlformats.org/drawingml/2006/main">
+          <a:srgbClr val="F6F3EB"/>
+        </a:solidFill>
+      </c:spPr>
+    </c:plotArea>
+    <c:plotVisOnly val="1"/>
+  </c:chart>
+  <c:spPr>
+    <a:solidFill xmlns:a="http://schemas.openxmlformats.org/drawingml/2006/main">
+      <a:srgbClr val="F6F3EB"/>
+    </a:solidFill>
+  </c:spPr>
+  <c:externalData r:id="rIdChartSnapshot1">
+    <c:autoUpdate val="0"/>
+  </c:externalData>
+</c:chartSpace>
+</file>
+
+<file path=ppt/slides/charts/chart2.xml><?xml version="1.0" encoding="utf-8"?>
+<c:chartSpace xmlns:c="http://schemas.openxmlformats.org/drawingml/2006/chart">
+  <c:lang val="en-US"/>
+  <c:chart>
+    <c:plotArea>
       <c:lineChart>
         <c:grouping val="standard"/>
         <c:varyColors val="0"/>
@@ -8521,6 +8669,8 @@
         <c:numFmt formatCode="General"/>
         <c:majorTickMark val="none"/>
         <c:minorTickMark val="none"/>
+        <c:tickLblSkip val="120"/>
+        <c:tickMarkSkip val="120"/>
         <c:spPr>
           <a:ln xmlns:a="http://schemas.openxmlformats.org/drawingml/2006/main" w="9525">
             <a:solidFill>
@@ -8608,257 +8758,14 @@
       <a:srgbClr val="F6F3EB"/>
     </a:solidFill>
   </c:spPr>
-  <c:externalData r:id="rIdChartSnapshot1">
-    <c:autoUpdate val="0"/>
-  </c:externalData>
-</c:chartSpace>
-</file>
-
-<file path=ppt/slides/charts/chart2.xml><?xml version="1.0" encoding="utf-8"?>
-<c:chartSpace xmlns:c="http://schemas.openxmlformats.org/drawingml/2006/chart" xmlns:r="http://schemas.openxmlformats.org/officeDocument/2006/relationships">
-  <c:lang val="en-US"/>
-  <c:chart>
-    <c:plotArea>
-      <c:barChart>
-        <c:barDir val="col"/>
-        <c:grouping val="clustered"/>
-        <c:varyColors val="0"/>
-        <c:ser>
-          <c:idx val="0"/>
-          <c:order val="0"/>
-          <c:tx>
-            <c:v>Média mensal histórica</c:v>
-          </c:tx>
-          <c:spPr>
-            <a:solidFill xmlns:a="http://schemas.openxmlformats.org/drawingml/2006/main">
-              <a:srgbClr val="007F80"/>
-            </a:solidFill>
-          </c:spPr>
-          <c:cat>
-            <c:strRef>
-              <c:f>'Chart Data'!$A$2:$A$13</c:f>
-              <c:strCache>
-                <c:ptCount val="12"/>
-                <c:pt idx="0">
-                  <c:v>Jan</c:v>
-                </c:pt>
-                <c:pt idx="1">
-                  <c:v>Fev</c:v>
-                </c:pt>
-                <c:pt idx="2">
-                  <c:v>Mar</c:v>
-                </c:pt>
-                <c:pt idx="3">
-                  <c:v>Abr</c:v>
-                </c:pt>
-                <c:pt idx="4">
-                  <c:v>Mai</c:v>
-                </c:pt>
-                <c:pt idx="5">
-                  <c:v>Jun</c:v>
-                </c:pt>
-                <c:pt idx="6">
-                  <c:v>Jul</c:v>
-                </c:pt>
-                <c:pt idx="7">
-                  <c:v>Ago</c:v>
-                </c:pt>
-                <c:pt idx="8">
-                  <c:v>Set</c:v>
-                </c:pt>
-                <c:pt idx="9">
-                  <c:v>Out</c:v>
-                </c:pt>
-                <c:pt idx="10">
-                  <c:v>Nov</c:v>
-                </c:pt>
-                <c:pt idx="11">
-                  <c:v>Dez</c:v>
-                </c:pt>
-              </c:strCache>
-            </c:strRef>
-          </c:cat>
-          <c:val>
-            <c:numRef>
-              <c:f>'Chart Data'!$B$2:$B$13</c:f>
-              <c:numCache>
-                <c:formatCode>0</c:formatCode>
-                <c:ptCount val="12"/>
-                <c:pt idx="0">
-                  <c:v>8846.8488</c:v>
-                </c:pt>
-                <c:pt idx="1">
-                  <c:v>9271.7674</c:v>
-                </c:pt>
-                <c:pt idx="2">
-                  <c:v>8925.2209</c:v>
-                </c:pt>
-                <c:pt idx="3">
-                  <c:v>6728.5814</c:v>
-                </c:pt>
-                <c:pt idx="4">
-                  <c:v>4615.1163</c:v>
-                </c:pt>
-                <c:pt idx="5">
-                  <c:v>3780.0814</c:v>
-                </c:pt>
-                <c:pt idx="6">
-                  <c:v>3088.4651</c:v>
-                </c:pt>
-                <c:pt idx="7">
-                  <c:v>2586.2674</c:v>
-                </c:pt>
-                <c:pt idx="8">
-                  <c:v>2464.8372</c:v>
-                </c:pt>
-                <c:pt idx="9">
-                  <c:v>2831.3721</c:v>
-                </c:pt>
-                <c:pt idx="10">
-                  <c:v>3882.3256</c:v>
-                </c:pt>
-                <c:pt idx="11">
-                  <c:v>6238.9186</c:v>
-                </c:pt>
-              </c:numCache>
-            </c:numRef>
-          </c:val>
-        </c:ser>
-        <c:dLbls>
-          <c:txPr>
-            <a:bodyPr xmlns:a="http://schemas.openxmlformats.org/drawingml/2006/main" anchorCtr="1"/>
-            <a:lstStyle xmlns:a="http://schemas.openxmlformats.org/drawingml/2006/main"/>
-            <a:p xmlns:a="http://schemas.openxmlformats.org/drawingml/2006/main">
-              <a:pPr>
-                <a:defRPr sz="1500">
-                  <a:solidFill>
-                    <a:srgbClr val="18343E"/>
-                  </a:solidFill>
-                  <a:latin typeface="Arial"/>
-                  <a:ea typeface="Arial"/>
-                  <a:cs typeface="Arial"/>
-                </a:defRPr>
-              </a:pPr>
-            </a:p>
-          </c:txPr>
-          <c:dLblPos val="outEnd"/>
-          <c:showLegendKey val="0"/>
-          <c:showVal val="0"/>
-          <c:showCatName val="0"/>
-          <c:showSerName val="0"/>
-          <c:showPercent val="0"/>
-          <c:showBubbleSize val="0"/>
-          <c:showLeaderLines val="0"/>
-        </c:dLbls>
-        <c:gapWidth val="65"/>
-        <c:axId val="48650112"/>
-        <c:axId val="48672768"/>
-      </c:barChart>
-      <c:catAx>
-        <c:axId val="48650112"/>
-        <c:scaling>
-          <c:orientation val="minMax"/>
-        </c:scaling>
-        <c:delete val="0"/>
-        <c:axPos val="b"/>
-        <c:numFmt formatCode="General"/>
-        <c:majorTickMark val="none"/>
-        <c:minorTickMark val="none"/>
-        <c:spPr>
-          <a:ln xmlns:a="http://schemas.openxmlformats.org/drawingml/2006/main" w="9525">
-            <a:solidFill>
-              <a:srgbClr val="D7DDD8"/>
-            </a:solidFill>
-          </a:ln>
-        </c:spPr>
-        <c:txPr>
-          <a:bodyPr xmlns:a="http://schemas.openxmlformats.org/drawingml/2006/main" anchorCtr="1"/>
-          <a:lstStyle xmlns:a="http://schemas.openxmlformats.org/drawingml/2006/main"/>
-          <a:p xmlns:a="http://schemas.openxmlformats.org/drawingml/2006/main">
-            <a:pPr>
-              <a:defRPr sz="1275">
-                <a:solidFill>
-                  <a:srgbClr val="18343E"/>
-                </a:solidFill>
-                <a:latin typeface="Arial"/>
-                <a:ea typeface="Arial"/>
-                <a:cs typeface="Arial"/>
-              </a:defRPr>
-            </a:pPr>
-          </a:p>
-        </c:txPr>
-        <c:crossAx val="48672768"/>
-        <c:tickLblSkip val="1"/>
-        <c:tickMarkSkip val="1"/>
-      </c:catAx>
-      <c:valAx>
-        <c:axId val="48672768"/>
-        <c:scaling>
-          <c:orientation val="minMax"/>
-          <c:min val="0"/>
-        </c:scaling>
-        <c:delete val="0"/>
-        <c:axPos val="l"/>
-        <c:majorGridlines>
-          <c:spPr>
-            <a:ln xmlns:a="http://schemas.openxmlformats.org/drawingml/2006/main" w="9525">
-              <a:solidFill>
-                <a:srgbClr val="D7DDD8"/>
-              </a:solidFill>
-            </a:ln>
-          </c:spPr>
-        </c:majorGridlines>
-        <c:numFmt formatCode="0"/>
-        <c:majorTickMark val="none"/>
-        <c:minorTickMark val="none"/>
-        <c:spPr>
-          <a:ln xmlns:a="http://schemas.openxmlformats.org/drawingml/2006/main" w="9525">
-            <a:solidFill>
-              <a:srgbClr val="D4D4D4"/>
-            </a:solidFill>
-            <a:prstDash val="solid"/>
-          </a:ln>
-        </c:spPr>
-        <c:txPr>
-          <a:bodyPr xmlns:a="http://schemas.openxmlformats.org/drawingml/2006/main" anchorCtr="1"/>
-          <a:lstStyle xmlns:a="http://schemas.openxmlformats.org/drawingml/2006/main"/>
-          <a:p xmlns:a="http://schemas.openxmlformats.org/drawingml/2006/main">
-            <a:pPr>
-              <a:defRPr sz="1350">
-                <a:solidFill>
-                  <a:srgbClr val="18343E"/>
-                </a:solidFill>
-                <a:latin typeface="Arial"/>
-                <a:ea typeface="Arial"/>
-                <a:cs typeface="Arial"/>
-              </a:defRPr>
-            </a:pPr>
-          </a:p>
-        </c:txPr>
-        <c:crossAx val="48650112"/>
-        <c:crossBetween val="between"/>
-      </c:valAx>
-      <c:spPr>
-        <a:solidFill xmlns:a="http://schemas.openxmlformats.org/drawingml/2006/main">
-          <a:srgbClr val="F6F3EB"/>
-        </a:solidFill>
-      </c:spPr>
-    </c:plotArea>
-    <c:plotVisOnly val="1"/>
-  </c:chart>
-  <c:spPr>
-    <a:solidFill xmlns:a="http://schemas.openxmlformats.org/drawingml/2006/main">
-      <a:srgbClr val="F6F3EB"/>
-    </a:solidFill>
-  </c:spPr>
-  <c:externalData r:id="rIdChartSnapshot1">
+  <c:externalData xmlns:r="http://schemas.openxmlformats.org/officeDocument/2006/relationships" r:id="rIdChartSnapshot1">
     <c:autoUpdate val="0"/>
   </c:externalData>
 </c:chartSpace>
 </file>
 
 <file path=ppt/slides/charts/chart3.xml><?xml version="1.0" encoding="utf-8"?>
-<c:chartSpace xmlns:c="http://schemas.openxmlformats.org/drawingml/2006/chart" xmlns:r="http://schemas.openxmlformats.org/officeDocument/2006/relationships">
+<c:chartSpace xmlns:c="http://schemas.openxmlformats.org/drawingml/2006/chart">
   <c:lang val="en-US"/>
   <c:chart>
     <c:plotArea>
@@ -8959,6 +8866,8 @@
         <c:numFmt formatCode="General"/>
         <c:majorTickMark val="none"/>
         <c:minorTickMark val="none"/>
+        <c:tickLblSkip val="1"/>
+        <c:tickMarkSkip val="1"/>
         <c:spPr>
           <a:ln xmlns:a="http://schemas.openxmlformats.org/drawingml/2006/main" w="9525">
             <a:solidFill>
@@ -9046,14 +8955,14 @@
       <a:srgbClr val="F6F3EB"/>
     </a:solidFill>
   </c:spPr>
-  <c:externalData r:id="rIdChartSnapshot1">
+  <c:externalData xmlns:r="http://schemas.openxmlformats.org/officeDocument/2006/relationships" r:id="rIdChartSnapshot1">
     <c:autoUpdate val="0"/>
   </c:externalData>
 </c:chartSpace>
 </file>
 
 <file path=ppt/slides/charts/chart4.xml><?xml version="1.0" encoding="utf-8"?>
-<c:chartSpace xmlns:c="http://schemas.openxmlformats.org/drawingml/2006/chart" xmlns:r="http://schemas.openxmlformats.org/officeDocument/2006/relationships">
+<c:chartSpace xmlns:c="http://schemas.openxmlformats.org/drawingml/2006/chart">
   <c:lang val="en-US"/>
   <c:chart>
     <c:plotArea>
@@ -9861,6 +9770,8 @@
         <c:numFmt formatCode="General"/>
         <c:majorTickMark val="none"/>
         <c:minorTickMark val="none"/>
+        <c:tickLblSkip val="3"/>
+        <c:tickMarkSkip val="3"/>
         <c:spPr>
           <a:ln xmlns:a="http://schemas.openxmlformats.org/drawingml/2006/main" w="9525">
             <a:solidFill>
@@ -9968,14 +9879,14 @@
       <a:srgbClr val="F6F3EB"/>
     </a:solidFill>
   </c:spPr>
-  <c:externalData r:id="rIdChartSnapshot1">
+  <c:externalData xmlns:r="http://schemas.openxmlformats.org/officeDocument/2006/relationships" r:id="rIdChartSnapshot1">
     <c:autoUpdate val="0"/>
   </c:externalData>
 </c:chartSpace>
 </file>
 
 <file path=ppt/slides/charts/chart5.xml><?xml version="1.0" encoding="utf-8"?>
-<c:chartSpace xmlns:c="http://schemas.openxmlformats.org/drawingml/2006/chart" xmlns:r="http://schemas.openxmlformats.org/officeDocument/2006/relationships">
+<c:chartSpace xmlns:c="http://schemas.openxmlformats.org/drawingml/2006/chart">
   <c:lang val="en-US"/>
   <c:chart>
     <c:plotArea>
@@ -11037,6 +10948,8 @@
         <c:numFmt formatCode="General"/>
         <c:majorTickMark val="none"/>
         <c:minorTickMark val="none"/>
+        <c:tickLblSkip val="3"/>
+        <c:tickMarkSkip val="3"/>
         <c:spPr>
           <a:ln xmlns:a="http://schemas.openxmlformats.org/drawingml/2006/main" w="9525">
             <a:solidFill>
@@ -11144,14 +11057,14 @@
       <a:srgbClr val="F6F3EB"/>
     </a:solidFill>
   </c:spPr>
-  <c:externalData r:id="rIdChartSnapshot1">
+  <c:externalData xmlns:r="http://schemas.openxmlformats.org/officeDocument/2006/relationships" r:id="rIdChartSnapshot1">
     <c:autoUpdate val="0"/>
   </c:externalData>
 </c:chartSpace>
 </file>
 
 <file path=ppt/slides/charts/chart6.xml><?xml version="1.0" encoding="utf-8"?>
-<c:chartSpace xmlns:c="http://schemas.openxmlformats.org/drawingml/2006/chart" xmlns:r="http://schemas.openxmlformats.org/officeDocument/2006/relationships">
+<c:chartSpace xmlns:c="http://schemas.openxmlformats.org/drawingml/2006/chart">
   <c:lang val="en-US"/>
   <c:chart>
     <c:plotArea>
@@ -12213,6 +12126,8 @@
         <c:numFmt formatCode="General"/>
         <c:majorTickMark val="none"/>
         <c:minorTickMark val="none"/>
+        <c:tickLblSkip val="3"/>
+        <c:tickMarkSkip val="3"/>
         <c:spPr>
           <a:ln xmlns:a="http://schemas.openxmlformats.org/drawingml/2006/main" w="9525">
             <a:solidFill>
@@ -12320,14 +12235,14 @@
       <a:srgbClr val="F6F3EB"/>
     </a:solidFill>
   </c:spPr>
-  <c:externalData r:id="rIdChartSnapshot1">
+  <c:externalData xmlns:r="http://schemas.openxmlformats.org/officeDocument/2006/relationships" r:id="rIdChartSnapshot1">
     <c:autoUpdate val="0"/>
   </c:externalData>
 </c:chartSpace>
 </file>
 
 <file path=ppt/slides/charts/chart7.xml><?xml version="1.0" encoding="utf-8"?>
-<c:chartSpace xmlns:c="http://schemas.openxmlformats.org/drawingml/2006/chart" xmlns:r="http://schemas.openxmlformats.org/officeDocument/2006/relationships">
+<c:chartSpace xmlns:c="http://schemas.openxmlformats.org/drawingml/2006/chart">
   <c:lang val="en-US"/>
   <c:chart>
     <c:plotArea>
@@ -12813,6 +12728,8 @@
         <c:numFmt formatCode="General"/>
         <c:majorTickMark val="none"/>
         <c:minorTickMark val="none"/>
+        <c:tickLblSkip val="1"/>
+        <c:tickMarkSkip val="1"/>
         <c:spPr>
           <a:ln xmlns:a="http://schemas.openxmlformats.org/drawingml/2006/main" w="9525">
             <a:solidFill>
@@ -12920,7 +12837,7 @@
       <a:srgbClr val="F6F3EB"/>
     </a:solidFill>
   </c:spPr>
-  <c:externalData r:id="rIdChartSnapshot1">
+  <c:externalData xmlns:r="http://schemas.openxmlformats.org/officeDocument/2006/relationships" r:id="rIdChartSnapshot1">
     <c:autoUpdate val="0"/>
   </c:externalData>
 </c:chartSpace>
@@ -12932,7 +12849,7 @@
     <p:bg>
       <p:bgPr>
         <a:solidFill xmlns:a="http://schemas.openxmlformats.org/drawingml/2006/main">
-          <a:srgbClr val="102E3A"/>
+          <a:srgbClr val="F6F3EB"/>
         </a:solidFill>
       </p:bgPr>
     </p:bg>
@@ -12947,10 +12864,10 @@
       </p:grpSpPr>
       <p:sp>
         <p:nvSpPr>
-          <p:cNvPr id="6" name="">
+          <p:cNvPr id="12" name="">
             <a:extLst xmlns:a="http://schemas.openxmlformats.org/drawingml/2006/main">
               <a:ext uri="{FF2B5EF4-FFF2-40B4-BE49-F238E27FC236}">
-                <a16:creationId xmlns:a16="http://schemas.microsoft.com/office/drawing/2014/main" id="{404DE834-7878-407F-9A5F-DB1F7815E44F}"/>
+                <a16:creationId xmlns:a16="http://schemas.microsoft.com/office/drawing/2014/main" id="{E3BB9FE7-4CE6-48B8-BEF6-9F16CDBBE0D7}"/>
               </a:ext>
             </a:extLst>
           </p:cNvPr>
@@ -12962,7 +12879,7 @@
         <p:spPr>
           <a:xfrm xmlns:a="http://schemas.openxmlformats.org/drawingml/2006/main">
             <a:off x="609600" y="419100"/>
-            <a:ext cx="10934700" cy="952500"/>
+            <a:ext cx="10934700" cy="666750"/>
           </a:xfrm>
           <a:prstGeom xmlns:a="http://schemas.openxmlformats.org/drawingml/2006/main" prst="rect">
             <a:avLst/>
@@ -12976,12 +12893,23 @@
           <a:bodyPr xmlns:a="http://schemas.openxmlformats.org/drawingml/2006/main">
             <a:noAutofit/>
           </a:bodyPr>
-          <a:lstStyle xmlns:a="http://schemas.openxmlformats.org/drawingml/2006/main"/>
+          <a:lstStyle xmlns:a="http://schemas.openxmlformats.org/drawingml/2006/main">
+            <a:defPPr>
+              <a:defRPr sz="3300" b="1">
+                <a:solidFill>
+                  <a:srgbClr val="18343E"/>
+                </a:solidFill>
+                <a:latin typeface="Arial"/>
+                <a:ea typeface="Arial"/>
+                <a:cs typeface="Arial"/>
+              </a:defRPr>
+            </a:defPPr>
+          </a:lstStyle>
           <a:p xmlns:a="http://schemas.openxmlformats.org/drawingml/2006/main">
             <a:pPr>
               <a:defRPr sz="3300" b="1">
                 <a:solidFill>
-                  <a:srgbClr val="F8FAF7"/>
+                  <a:srgbClr val="18343E"/>
                 </a:solidFill>
                 <a:latin typeface="Arial"/>
                 <a:ea typeface="Arial"/>
@@ -12991,13 +12919,13 @@
             <a:r>
               <a:rPr sz="3300" b="1">
                 <a:solidFill>
-                  <a:srgbClr val="F8FAF7"/>
+                  <a:srgbClr val="18343E"/>
                 </a:solidFill>
                 <a:latin typeface="Arial"/>
                 <a:ea typeface="Arial"/>
                 <a:cs typeface="Arial"/>
               </a:rPr>
-              <a:t>Vazões de Ilha Solteira</a:t>
+              <a:t>Ilha Solteira e o rio Paraná</a:t>
             </a:r>
           </a:p>
         </p:txBody>
@@ -13007,7 +12935,559 @@
           <p:cNvPr id="2" name="">
             <a:extLst xmlns:a="http://schemas.openxmlformats.org/drawingml/2006/main">
               <a:ext uri="{FF2B5EF4-FFF2-40B4-BE49-F238E27FC236}">
-                <a16:creationId xmlns:a16="http://schemas.microsoft.com/office/drawing/2014/main" id="{B280B78F-386D-48AA-AEBE-44743906AA60}"/>
+                <a16:creationId xmlns:a16="http://schemas.microsoft.com/office/drawing/2014/main" id="{C2EE03D1-C18E-41D5-A1DA-D37E10BFAECA}"/>
+              </a:ext>
+            </a:extLst>
+          </p:cNvPr>
+          <p:cNvSpPr>
+            <a:spLocks xmlns:a="http://schemas.openxmlformats.org/drawingml/2006/main" noGrp="1"/>
+          </p:cNvSpPr>
+          <p:nvPr/>
+        </p:nvSpPr>
+        <p:spPr>
+          <a:xfrm xmlns:a="http://schemas.openxmlformats.org/drawingml/2006/main">
+            <a:off x="647700" y="1114425"/>
+            <a:ext cx="10820400" cy="400050"/>
+          </a:xfrm>
+          <a:prstGeom xmlns:a="http://schemas.openxmlformats.org/drawingml/2006/main" prst="rect">
+            <a:avLst/>
+          </a:prstGeom>
+          <a:noFill xmlns:a="http://schemas.openxmlformats.org/drawingml/2006/main"/>
+          <a:ln xmlns:a="http://schemas.openxmlformats.org/drawingml/2006/main" w="0">
+            <a:noFill/>
+          </a:ln>
+        </p:spPr>
+        <p:txBody>
+          <a:bodyPr xmlns:a="http://schemas.openxmlformats.org/drawingml/2006/main">
+            <a:noAutofit/>
+          </a:bodyPr>
+          <a:lstStyle xmlns:a="http://schemas.openxmlformats.org/drawingml/2006/main">
+            <a:defPPr>
+              <a:defRPr sz="1950" b="0">
+                <a:solidFill>
+                  <a:srgbClr val="5B7177"/>
+                </a:solidFill>
+                <a:latin typeface="Arial"/>
+                <a:ea typeface="Arial"/>
+                <a:cs typeface="Arial"/>
+              </a:defRPr>
+            </a:defPPr>
+          </a:lstStyle>
+          <a:p xmlns:a="http://schemas.openxmlformats.org/drawingml/2006/main">
+            <a:pPr>
+              <a:defRPr sz="1950" b="0">
+                <a:solidFill>
+                  <a:srgbClr val="5B7177"/>
+                </a:solidFill>
+                <a:latin typeface="Arial"/>
+                <a:ea typeface="Arial"/>
+                <a:cs typeface="Arial"/>
+              </a:defRPr>
+            </a:pPr>
+            <a:r>
+              <a:rPr sz="1950" b="0">
+                <a:solidFill>
+                  <a:srgbClr val="5B7177"/>
+                </a:solidFill>
+                <a:latin typeface="Arial"/>
+                <a:ea typeface="Arial"/>
+                <a:cs typeface="Arial"/>
+              </a:rPr>
+              <a:t>Vazões mensais de 1931 a 2016</a:t>
+            </a:r>
+          </a:p>
+        </p:txBody>
+      </p:sp>
+      <p:pic>
+        <p:nvPicPr>
+          <p:cNvPr id="3" name="">
+            <a:extLst xmlns:a="http://schemas.openxmlformats.org/drawingml/2006/main">
+              <a:ext uri="{FF2B5EF4-FFF2-40B4-BE49-F238E27FC236}">
+                <a16:creationId xmlns:a16="http://schemas.microsoft.com/office/drawing/2014/main" id="{BD68EBDF-BD06-4DB0-8A08-2AD48C4E09C1}"/>
+              </a:ext>
+            </a:extLst>
+          </p:cNvPr>
+          <p:cNvPicPr>
+            <a:picLocks xmlns:a="http://schemas.openxmlformats.org/drawingml/2006/main" noChangeAspect="1"/>
+          </p:cNvPicPr>
+          <p:nvPr/>
+        </p:nvPicPr>
+        <p:blipFill>
+          <a:blip xmlns:r="http://schemas.openxmlformats.org/officeDocument/2006/relationships" xmlns:a="http://schemas.openxmlformats.org/drawingml/2006/main" r:embed="Rc799fbf650384d2a"/>
+          <a:srcRect xmlns:a="http://schemas.openxmlformats.org/drawingml/2006/main" l="0" t="2381" r="0" b="2381"/>
+          <a:stretch xmlns:a="http://schemas.openxmlformats.org/drawingml/2006/main">
+            <a:fillRect l="0" t="0" r="0" b="0"/>
+          </a:stretch>
+        </p:blipFill>
+        <p:spPr>
+          <a:xfrm xmlns:a="http://schemas.openxmlformats.org/drawingml/2006/main">
+            <a:off x="685800" y="1752600"/>
+            <a:ext cx="4000500" cy="2857500"/>
+          </a:xfrm>
+          <a:prstGeom xmlns:a="http://schemas.openxmlformats.org/drawingml/2006/main" prst="rect">
+            <a:avLst/>
+          </a:prstGeom>
+        </p:spPr>
+      </p:pic>
+      <p:sp>
+        <p:nvSpPr>
+          <p:cNvPr id="4" name="">
+            <a:extLst xmlns:a="http://schemas.openxmlformats.org/drawingml/2006/main">
+              <a:ext uri="{FF2B5EF4-FFF2-40B4-BE49-F238E27FC236}">
+                <a16:creationId xmlns:a16="http://schemas.microsoft.com/office/drawing/2014/main" id="{CD4AA026-29C6-4C6F-9301-8152DFE192FC}"/>
+              </a:ext>
+            </a:extLst>
+          </p:cNvPr>
+          <p:cNvSpPr>
+            <a:spLocks xmlns:a="http://schemas.openxmlformats.org/drawingml/2006/main" noGrp="1"/>
+          </p:cNvSpPr>
+          <p:nvPr/>
+        </p:nvSpPr>
+        <p:spPr>
+          <a:xfrm xmlns:a="http://schemas.openxmlformats.org/drawingml/2006/main">
+            <a:off x="666750" y="4762500"/>
+            <a:ext cx="4333875" cy="800100"/>
+          </a:xfrm>
+          <a:prstGeom xmlns:a="http://schemas.openxmlformats.org/drawingml/2006/main" prst="rect">
+            <a:avLst/>
+          </a:prstGeom>
+          <a:noFill xmlns:a="http://schemas.openxmlformats.org/drawingml/2006/main"/>
+          <a:ln xmlns:a="http://schemas.openxmlformats.org/drawingml/2006/main" w="0">
+            <a:noFill/>
+          </a:ln>
+        </p:spPr>
+        <p:txBody>
+          <a:bodyPr xmlns:a="http://schemas.openxmlformats.org/drawingml/2006/main">
+            <a:noAutofit/>
+          </a:bodyPr>
+          <a:lstStyle xmlns:a="http://schemas.openxmlformats.org/drawingml/2006/main">
+            <a:defPPr>
+              <a:defRPr sz="1875" b="0">
+                <a:solidFill>
+                  <a:srgbClr val="18343E"/>
+                </a:solidFill>
+                <a:latin typeface="Arial"/>
+                <a:ea typeface="Arial"/>
+                <a:cs typeface="Arial"/>
+              </a:defRPr>
+            </a:defPPr>
+          </a:lstStyle>
+          <a:p xmlns:a="http://schemas.openxmlformats.org/drawingml/2006/main">
+            <a:pPr>
+              <a:defRPr sz="1875" b="0">
+                <a:solidFill>
+                  <a:srgbClr val="18343E"/>
+                </a:solidFill>
+                <a:latin typeface="Arial"/>
+                <a:ea typeface="Arial"/>
+                <a:cs typeface="Arial"/>
+              </a:defRPr>
+            </a:pPr>
+            <a:r>
+              <a:rPr sz="1875" b="0">
+                <a:solidFill>
+                  <a:srgbClr val="18343E"/>
+                </a:solidFill>
+                <a:latin typeface="Arial"/>
+                <a:ea typeface="Arial"/>
+                <a:cs typeface="Arial"/>
+              </a:rPr>
+              <a:t>A usina fica entre Ilha Solteira (SP)</a:t>
+            </a:r>
+          </a:p>
+          <a:p xmlns:a="http://schemas.openxmlformats.org/drawingml/2006/main">
+            <a:pPr>
+              <a:defRPr sz="1875" b="0">
+                <a:solidFill>
+                  <a:srgbClr val="18343E"/>
+                </a:solidFill>
+                <a:latin typeface="Arial"/>
+                <a:ea typeface="Arial"/>
+                <a:cs typeface="Arial"/>
+              </a:defRPr>
+            </a:pPr>
+            <a:r>
+              <a:rPr sz="1875" b="0">
+                <a:solidFill>
+                  <a:srgbClr val="18343E"/>
+                </a:solidFill>
+                <a:latin typeface="Arial"/>
+                <a:ea typeface="Arial"/>
+                <a:cs typeface="Arial"/>
+              </a:rPr>
+              <a:t>e Selvíria (MS), no rio Paraná.</a:t>
+            </a:r>
+          </a:p>
+        </p:txBody>
+      </p:sp>
+      <p:sp>
+        <p:nvSpPr>
+          <p:cNvPr id="5" name="">
+            <a:extLst xmlns:a="http://schemas.openxmlformats.org/drawingml/2006/main">
+              <a:ext uri="{FF2B5EF4-FFF2-40B4-BE49-F238E27FC236}">
+                <a16:creationId xmlns:a16="http://schemas.microsoft.com/office/drawing/2014/main" id="{C01BAC67-6149-481A-9518-4326813A67F7}"/>
+              </a:ext>
+            </a:extLst>
+          </p:cNvPr>
+          <p:cNvSpPr>
+            <a:spLocks xmlns:a="http://schemas.openxmlformats.org/drawingml/2006/main" noGrp="1"/>
+          </p:cNvSpPr>
+          <p:nvPr/>
+        </p:nvSpPr>
+        <p:spPr>
+          <a:xfrm xmlns:a="http://schemas.openxmlformats.org/drawingml/2006/main">
+            <a:off x="685800" y="5695950"/>
+            <a:ext cx="4333875" cy="295275"/>
+          </a:xfrm>
+          <a:prstGeom xmlns:a="http://schemas.openxmlformats.org/drawingml/2006/main" prst="rect">
+            <a:avLst/>
+          </a:prstGeom>
+          <a:noFill xmlns:a="http://schemas.openxmlformats.org/drawingml/2006/main"/>
+          <a:ln xmlns:a="http://schemas.openxmlformats.org/drawingml/2006/main" w="0">
+            <a:noFill/>
+          </a:ln>
+        </p:spPr>
+        <p:txBody>
+          <a:bodyPr xmlns:a="http://schemas.openxmlformats.org/drawingml/2006/main">
+            <a:noAutofit/>
+          </a:bodyPr>
+          <a:lstStyle xmlns:a="http://schemas.openxmlformats.org/drawingml/2006/main">
+            <a:defPPr>
+              <a:defRPr sz="1200" b="0">
+                <a:solidFill>
+                  <a:srgbClr val="5B7177"/>
+                </a:solidFill>
+                <a:latin typeface="Arial"/>
+                <a:ea typeface="Arial"/>
+                <a:cs typeface="Arial"/>
+              </a:defRPr>
+            </a:defPPr>
+          </a:lstStyle>
+          <a:p xmlns:a="http://schemas.openxmlformats.org/drawingml/2006/main">
+            <a:pPr>
+              <a:defRPr sz="1200" b="0">
+                <a:solidFill>
+                  <a:srgbClr val="5B7177"/>
+                </a:solidFill>
+                <a:latin typeface="Arial"/>
+                <a:ea typeface="Arial"/>
+                <a:cs typeface="Arial"/>
+              </a:defRPr>
+            </a:pPr>
+            <a:r>
+              <a:rPr sz="1200" b="0">
+                <a:solidFill>
+                  <a:srgbClr val="5B7177"/>
+                </a:solidFill>
+                <a:latin typeface="Arial"/>
+                <a:ea typeface="Arial"/>
+                <a:cs typeface="Arial"/>
+              </a:rPr>
+              <a:t>Foto: Carlos Alves / CC BY 3.0</a:t>
+            </a:r>
+          </a:p>
+        </p:txBody>
+      </p:sp>
+      <p:sp>
+        <p:nvSpPr>
+          <p:cNvPr id="6" name="">
+            <a:extLst xmlns:a="http://schemas.openxmlformats.org/drawingml/2006/main">
+              <a:ext uri="{FF2B5EF4-FFF2-40B4-BE49-F238E27FC236}">
+                <a16:creationId xmlns:a16="http://schemas.microsoft.com/office/drawing/2014/main" id="{F16AC675-F489-480D-97F1-647E0E7BE815}"/>
+              </a:ext>
+            </a:extLst>
+          </p:cNvPr>
+          <p:cNvSpPr>
+            <a:spLocks xmlns:a="http://schemas.openxmlformats.org/drawingml/2006/main" noGrp="1"/>
+          </p:cNvSpPr>
+          <p:nvPr/>
+        </p:nvSpPr>
+        <p:spPr>
+          <a:xfrm xmlns:a="http://schemas.openxmlformats.org/drawingml/2006/main">
+            <a:off x="5238750" y="1695450"/>
+            <a:ext cx="6286500" cy="457200"/>
+          </a:xfrm>
+          <a:prstGeom xmlns:a="http://schemas.openxmlformats.org/drawingml/2006/main" prst="rect">
+            <a:avLst/>
+          </a:prstGeom>
+          <a:noFill xmlns:a="http://schemas.openxmlformats.org/drawingml/2006/main"/>
+          <a:ln xmlns:a="http://schemas.openxmlformats.org/drawingml/2006/main" w="0">
+            <a:noFill/>
+          </a:ln>
+        </p:spPr>
+        <p:txBody>
+          <a:bodyPr xmlns:a="http://schemas.openxmlformats.org/drawingml/2006/main">
+            <a:noAutofit/>
+          </a:bodyPr>
+          <a:lstStyle xmlns:a="http://schemas.openxmlformats.org/drawingml/2006/main">
+            <a:defPPr>
+              <a:defRPr sz="2250" b="1">
+                <a:solidFill>
+                  <a:srgbClr val="007F80"/>
+                </a:solidFill>
+                <a:latin typeface="Arial"/>
+                <a:ea typeface="Arial"/>
+                <a:cs typeface="Arial"/>
+              </a:defRPr>
+            </a:defPPr>
+          </a:lstStyle>
+          <a:p xmlns:a="http://schemas.openxmlformats.org/drawingml/2006/main">
+            <a:pPr>
+              <a:defRPr sz="2250" b="1">
+                <a:solidFill>
+                  <a:srgbClr val="007F80"/>
+                </a:solidFill>
+                <a:latin typeface="Arial"/>
+                <a:ea typeface="Arial"/>
+                <a:cs typeface="Arial"/>
+              </a:defRPr>
+            </a:pPr>
+            <a:r>
+              <a:rPr sz="2250" b="1">
+                <a:solidFill>
+                  <a:srgbClr val="007F80"/>
+                </a:solidFill>
+                <a:latin typeface="Arial"/>
+                <a:ea typeface="Arial"/>
+                <a:cs typeface="Arial"/>
+              </a:rPr>
+              <a:t>Sazonalidade das vazões</a:t>
+            </a:r>
+          </a:p>
+        </p:txBody>
+      </p:sp>
+      <p:graphicFrame>
+        <p:nvGraphicFramePr>
+          <p:cNvPr id="7" name="Chart">
+            <a:extLst xmlns:a="http://schemas.openxmlformats.org/drawingml/2006/main">
+              <a:ext uri="{FF2B5EF4-FFF2-40B4-BE49-F238E27FC236}">
+                <a16:creationId xmlns:a16="http://schemas.microsoft.com/office/drawing/2014/main" id="{5823122B-488C-45C9-AEB0-CE0617B895D8}"/>
+              </a:ext>
+            </a:extLst>
+          </p:cNvPr>
+          <p:cNvGraphicFramePr/>
+          <p:nvPr/>
+        </p:nvGraphicFramePr>
+        <p:xfrm>
+          <a:off xmlns:a="http://schemas.openxmlformats.org/drawingml/2006/main" x="5191125" y="2257425"/>
+          <a:ext xmlns:a="http://schemas.openxmlformats.org/drawingml/2006/main" cx="6381750" cy="2952750"/>
+        </p:xfrm>
+        <a:graphic xmlns:a="http://schemas.openxmlformats.org/drawingml/2006/main">
+          <a:graphicData uri="http://schemas.openxmlformats.org/drawingml/2006/chart">
+            <c:chart xmlns:r="http://schemas.openxmlformats.org/officeDocument/2006/relationships" xmlns:c="http://schemas.openxmlformats.org/drawingml/2006/chart" r:id="Rf5fcb34877f84100"/>
+          </a:graphicData>
+        </a:graphic>
+      </p:graphicFrame>
+      <p:sp>
+        <p:nvSpPr>
+          <p:cNvPr id="8" name="">
+            <a:extLst xmlns:a="http://schemas.openxmlformats.org/drawingml/2006/main">
+              <a:ext uri="{FF2B5EF4-FFF2-40B4-BE49-F238E27FC236}">
+                <a16:creationId xmlns:a16="http://schemas.microsoft.com/office/drawing/2014/main" id="{E9B4CFAC-86A9-4611-AB44-7826B95A4AE8}"/>
+              </a:ext>
+            </a:extLst>
+          </p:cNvPr>
+          <p:cNvSpPr>
+            <a:spLocks xmlns:a="http://schemas.openxmlformats.org/drawingml/2006/main" noGrp="1"/>
+          </p:cNvSpPr>
+          <p:nvPr/>
+        </p:nvSpPr>
+        <p:spPr>
+          <a:xfrm xmlns:a="http://schemas.openxmlformats.org/drawingml/2006/main">
+            <a:off x="5267325" y="5305425"/>
+            <a:ext cx="6286500" cy="381000"/>
+          </a:xfrm>
+          <a:prstGeom xmlns:a="http://schemas.openxmlformats.org/drawingml/2006/main" prst="rect">
+            <a:avLst/>
+          </a:prstGeom>
+          <a:noFill xmlns:a="http://schemas.openxmlformats.org/drawingml/2006/main"/>
+          <a:ln xmlns:a="http://schemas.openxmlformats.org/drawingml/2006/main" w="0">
+            <a:noFill/>
+          </a:ln>
+        </p:spPr>
+        <p:txBody>
+          <a:bodyPr xmlns:a="http://schemas.openxmlformats.org/drawingml/2006/main">
+            <a:noAutofit/>
+          </a:bodyPr>
+          <a:lstStyle xmlns:a="http://schemas.openxmlformats.org/drawingml/2006/main">
+            <a:defPPr>
+              <a:defRPr sz="1650" b="1">
+                <a:solidFill>
+                  <a:srgbClr val="007F80"/>
+                </a:solidFill>
+                <a:latin typeface="Arial"/>
+                <a:ea typeface="Arial"/>
+                <a:cs typeface="Arial"/>
+              </a:defRPr>
+            </a:defPPr>
+          </a:lstStyle>
+          <a:p xmlns:a="http://schemas.openxmlformats.org/drawingml/2006/main">
+            <a:pPr>
+              <a:defRPr sz="1650" b="1">
+                <a:solidFill>
+                  <a:srgbClr val="007F80"/>
+                </a:solidFill>
+                <a:latin typeface="Arial"/>
+                <a:ea typeface="Arial"/>
+                <a:cs typeface="Arial"/>
+              </a:defRPr>
+            </a:pPr>
+            <a:r>
+              <a:rPr sz="1650" b="1">
+                <a:solidFill>
+                  <a:srgbClr val="007F80"/>
+                </a:solidFill>
+                <a:latin typeface="Arial"/>
+                <a:ea typeface="Arial"/>
+                <a:cs typeface="Arial"/>
+              </a:rPr>
+              <a:t>Maior média em fevereiro, menor em setembro.</a:t>
+            </a:r>
+          </a:p>
+        </p:txBody>
+      </p:sp>
+      <p:sp>
+        <p:nvSpPr>
+          <p:cNvPr id="9" name="">
+            <a:extLst xmlns:a="http://schemas.openxmlformats.org/drawingml/2006/main">
+              <a:ext uri="{FF2B5EF4-FFF2-40B4-BE49-F238E27FC236}">
+                <a16:creationId xmlns:a16="http://schemas.microsoft.com/office/drawing/2014/main" id="{0D9F3288-B990-4679-8E46-43C5F4C6586E}"/>
+              </a:ext>
+            </a:extLst>
+          </p:cNvPr>
+          <p:cNvSpPr>
+            <a:spLocks xmlns:a="http://schemas.openxmlformats.org/drawingml/2006/main" noGrp="1"/>
+          </p:cNvSpPr>
+          <p:nvPr/>
+        </p:nvSpPr>
+        <p:spPr>
+          <a:xfrm xmlns:a="http://schemas.openxmlformats.org/drawingml/2006/main">
+            <a:off x="5267325" y="5734050"/>
+            <a:ext cx="6286500" cy="314325"/>
+          </a:xfrm>
+          <a:prstGeom xmlns:a="http://schemas.openxmlformats.org/drawingml/2006/main" prst="rect">
+            <a:avLst/>
+          </a:prstGeom>
+          <a:noFill xmlns:a="http://schemas.openxmlformats.org/drawingml/2006/main"/>
+          <a:ln xmlns:a="http://schemas.openxmlformats.org/drawingml/2006/main" w="0">
+            <a:noFill/>
+          </a:ln>
+        </p:spPr>
+        <p:txBody>
+          <a:bodyPr xmlns:a="http://schemas.openxmlformats.org/drawingml/2006/main">
+            <a:noAutofit/>
+          </a:bodyPr>
+          <a:lstStyle xmlns:a="http://schemas.openxmlformats.org/drawingml/2006/main">
+            <a:defPPr>
+              <a:defRPr sz="1350" b="0">
+                <a:solidFill>
+                  <a:srgbClr val="5B7177"/>
+                </a:solidFill>
+                <a:latin typeface="Arial"/>
+                <a:ea typeface="Arial"/>
+                <a:cs typeface="Arial"/>
+              </a:defRPr>
+            </a:defPPr>
+          </a:lstStyle>
+          <a:p xmlns:a="http://schemas.openxmlformats.org/drawingml/2006/main">
+            <a:pPr>
+              <a:defRPr sz="1350" b="0">
+                <a:solidFill>
+                  <a:srgbClr val="5B7177"/>
+                </a:solidFill>
+                <a:latin typeface="Arial"/>
+                <a:ea typeface="Arial"/>
+                <a:cs typeface="Arial"/>
+              </a:defRPr>
+            </a:pPr>
+            <a:r>
+              <a:rPr sz="1350" b="0">
+                <a:solidFill>
+                  <a:srgbClr val="5B7177"/>
+                </a:solidFill>
+                <a:latin typeface="Arial"/>
+                <a:ea typeface="Arial"/>
+                <a:cs typeface="Arial"/>
+              </a:rPr>
+              <a:t>Média por mês, 1931–2016. Unidade da tabela.</a:t>
+            </a:r>
+          </a:p>
+        </p:txBody>
+      </p:sp>
+      <p:sp>
+        <p:nvSpPr>
+          <p:cNvPr id="10" name="">
+            <a:extLst xmlns:a="http://schemas.openxmlformats.org/drawingml/2006/main">
+              <a:ext uri="{FF2B5EF4-FFF2-40B4-BE49-F238E27FC236}">
+                <a16:creationId xmlns:a16="http://schemas.microsoft.com/office/drawing/2014/main" id="{6AC42D99-D14C-45DE-A442-DF1456D5A3AE}"/>
+              </a:ext>
+            </a:extLst>
+          </p:cNvPr>
+          <p:cNvSpPr>
+            <a:spLocks xmlns:a="http://schemas.openxmlformats.org/drawingml/2006/main" noGrp="1"/>
+          </p:cNvSpPr>
+          <p:nvPr/>
+        </p:nvSpPr>
+        <p:spPr>
+          <a:xfrm xmlns:a="http://schemas.openxmlformats.org/drawingml/2006/main">
+            <a:off x="9477375" y="6400800"/>
+            <a:ext cx="2047875" cy="228600"/>
+          </a:xfrm>
+          <a:prstGeom xmlns:a="http://schemas.openxmlformats.org/drawingml/2006/main" prst="rect">
+            <a:avLst/>
+          </a:prstGeom>
+          <a:noFill xmlns:a="http://schemas.openxmlformats.org/drawingml/2006/main"/>
+          <a:ln xmlns:a="http://schemas.openxmlformats.org/drawingml/2006/main" w="0">
+            <a:noFill/>
+          </a:ln>
+        </p:spPr>
+        <p:txBody>
+          <a:bodyPr xmlns:a="http://schemas.openxmlformats.org/drawingml/2006/main">
+            <a:noAutofit/>
+          </a:bodyPr>
+          <a:lstStyle xmlns:a="http://schemas.openxmlformats.org/drawingml/2006/main">
+            <a:defPPr>
+              <a:defRPr sz="1200" b="0">
+                <a:solidFill>
+                  <a:srgbClr val="5B7177"/>
+                </a:solidFill>
+                <a:latin typeface="Arial"/>
+                <a:ea typeface="Arial"/>
+                <a:cs typeface="Arial"/>
+              </a:defRPr>
+            </a:defPPr>
+          </a:lstStyle>
+          <a:p xmlns:a="http://schemas.openxmlformats.org/drawingml/2006/main">
+            <a:pPr>
+              <a:defRPr sz="1200" b="0">
+                <a:solidFill>
+                  <a:srgbClr val="5B7177"/>
+                </a:solidFill>
+                <a:latin typeface="Arial"/>
+                <a:ea typeface="Arial"/>
+                <a:cs typeface="Arial"/>
+              </a:defRPr>
+            </a:pPr>
+            <a:r>
+              <a:rPr sz="1200" b="0">
+                <a:solidFill>
+                  <a:srgbClr val="5B7177"/>
+                </a:solidFill>
+                <a:latin typeface="Arial"/>
+                <a:ea typeface="Arial"/>
+                <a:cs typeface="Arial"/>
+              </a:rPr>
+              <a:t>ARIMA e SARIMA</a:t>
+            </a:r>
+          </a:p>
+        </p:txBody>
+      </p:sp>
+      <p:sp>
+        <p:nvSpPr>
+          <p:cNvPr id="11" name="">
+            <a:extLst xmlns:a="http://schemas.openxmlformats.org/drawingml/2006/main">
+              <a:ext uri="{FF2B5EF4-FFF2-40B4-BE49-F238E27FC236}">
+                <a16:creationId xmlns:a16="http://schemas.microsoft.com/office/drawing/2014/main" id="{F5140B3C-02AD-4DBC-ACB0-F23326F46393}"/>
               </a:ext>
             </a:extLst>
           </p:cNvPr>
@@ -13033,12 +13513,23 @@
           <a:bodyPr xmlns:a="http://schemas.openxmlformats.org/drawingml/2006/main">
             <a:noAutofit/>
           </a:bodyPr>
-          <a:lstStyle xmlns:a="http://schemas.openxmlformats.org/drawingml/2006/main"/>
+          <a:lstStyle xmlns:a="http://schemas.openxmlformats.org/drawingml/2006/main">
+            <a:defPPr>
+              <a:defRPr sz="1200" b="0">
+                <a:solidFill>
+                  <a:srgbClr val="5B7177"/>
+                </a:solidFill>
+                <a:latin typeface="Arial"/>
+                <a:ea typeface="Arial"/>
+                <a:cs typeface="Arial"/>
+              </a:defRPr>
+            </a:defPPr>
+          </a:lstStyle>
           <a:p xmlns:a="http://schemas.openxmlformats.org/drawingml/2006/main">
             <a:pPr>
               <a:defRPr sz="1200" b="0">
                 <a:solidFill>
-                  <a:srgbClr val="A5C8CB"/>
+                  <a:srgbClr val="5B7177"/>
                 </a:solidFill>
                 <a:latin typeface="Arial"/>
                 <a:ea typeface="Arial"/>
@@ -13048,184 +13539,13 @@
             <a:r>
               <a:rPr sz="1200" b="0">
                 <a:solidFill>
-                  <a:srgbClr val="A5C8CB"/>
+                  <a:srgbClr val="5B7177"/>
                 </a:solidFill>
                 <a:latin typeface="Arial"/>
                 <a:ea typeface="Arial"/>
                 <a:cs typeface="Arial"/>
               </a:rPr>
               <a:t>01  Ilha Solteira</a:t>
-            </a:r>
-          </a:p>
-        </p:txBody>
-      </p:sp>
-      <p:sp>
-        <p:nvSpPr>
-          <p:cNvPr id="3" name="">
-            <a:extLst xmlns:a="http://schemas.openxmlformats.org/drawingml/2006/main">
-              <a:ext uri="{FF2B5EF4-FFF2-40B4-BE49-F238E27FC236}">
-                <a16:creationId xmlns:a16="http://schemas.microsoft.com/office/drawing/2014/main" id="{712275FC-BE3D-43A8-9CC9-6F658A739C76}"/>
-              </a:ext>
-            </a:extLst>
-          </p:cNvPr>
-          <p:cNvSpPr>
-            <a:spLocks xmlns:a="http://schemas.openxmlformats.org/drawingml/2006/main" noGrp="1"/>
-          </p:cNvSpPr>
-          <p:nvPr/>
-        </p:nvSpPr>
-        <p:spPr>
-          <a:xfrm xmlns:a="http://schemas.openxmlformats.org/drawingml/2006/main">
-            <a:off x="619125" y="2066925"/>
-            <a:ext cx="10477500" cy="952500"/>
-          </a:xfrm>
-          <a:prstGeom xmlns:a="http://schemas.openxmlformats.org/drawingml/2006/main" prst="rect">
-            <a:avLst/>
-          </a:prstGeom>
-          <a:noFill xmlns:a="http://schemas.openxmlformats.org/drawingml/2006/main"/>
-          <a:ln xmlns:a="http://schemas.openxmlformats.org/drawingml/2006/main" w="0">
-            <a:noFill/>
-          </a:ln>
-        </p:spPr>
-        <p:txBody>
-          <a:bodyPr xmlns:a="http://schemas.openxmlformats.org/drawingml/2006/main">
-            <a:noAutofit/>
-          </a:bodyPr>
-          <a:lstStyle xmlns:a="http://schemas.openxmlformats.org/drawingml/2006/main"/>
-          <a:p xmlns:a="http://schemas.openxmlformats.org/drawingml/2006/main">
-            <a:pPr>
-              <a:defRPr sz="5400" b="1">
-                <a:solidFill>
-                  <a:srgbClr val="F8FAF7"/>
-                </a:solidFill>
-                <a:latin typeface="Arial"/>
-                <a:ea typeface="Arial"/>
-                <a:cs typeface="Arial"/>
-              </a:defRPr>
-            </a:pPr>
-            <a:r>
-              <a:rPr sz="5400" b="1">
-                <a:solidFill>
-                  <a:srgbClr val="F8FAF7"/>
-                </a:solidFill>
-                <a:latin typeface="Arial"/>
-                <a:ea typeface="Arial"/>
-                <a:cs typeface="Arial"/>
-              </a:rPr>
-              <a:t>ARIMA e SARIMA</a:t>
-            </a:r>
-          </a:p>
-        </p:txBody>
-      </p:sp>
-      <p:sp>
-        <p:nvSpPr>
-          <p:cNvPr id="4" name="">
-            <a:extLst xmlns:a="http://schemas.openxmlformats.org/drawingml/2006/main">
-              <a:ext uri="{FF2B5EF4-FFF2-40B4-BE49-F238E27FC236}">
-                <a16:creationId xmlns:a16="http://schemas.microsoft.com/office/drawing/2014/main" id="{7A67BBF6-5F53-48A3-A7F7-E8C99B8A9B3A}"/>
-              </a:ext>
-            </a:extLst>
-          </p:cNvPr>
-          <p:cNvSpPr>
-            <a:spLocks xmlns:a="http://schemas.openxmlformats.org/drawingml/2006/main" noGrp="1"/>
-          </p:cNvSpPr>
-          <p:nvPr/>
-        </p:nvSpPr>
-        <p:spPr>
-          <a:xfrm xmlns:a="http://schemas.openxmlformats.org/drawingml/2006/main">
-            <a:off x="666750" y="3238500"/>
-            <a:ext cx="10001250" cy="666750"/>
-          </a:xfrm>
-          <a:prstGeom xmlns:a="http://schemas.openxmlformats.org/drawingml/2006/main" prst="rect">
-            <a:avLst/>
-          </a:prstGeom>
-          <a:noFill xmlns:a="http://schemas.openxmlformats.org/drawingml/2006/main"/>
-          <a:ln xmlns:a="http://schemas.openxmlformats.org/drawingml/2006/main" w="0">
-            <a:noFill/>
-          </a:ln>
-        </p:spPr>
-        <p:txBody>
-          <a:bodyPr xmlns:a="http://schemas.openxmlformats.org/drawingml/2006/main">
-            <a:noAutofit/>
-          </a:bodyPr>
-          <a:lstStyle xmlns:a="http://schemas.openxmlformats.org/drawingml/2006/main"/>
-          <a:p xmlns:a="http://schemas.openxmlformats.org/drawingml/2006/main">
-            <a:pPr>
-              <a:defRPr sz="2625" b="0">
-                <a:solidFill>
-                  <a:srgbClr val="A5C8CB"/>
-                </a:solidFill>
-                <a:latin typeface="Arial"/>
-                <a:ea typeface="Arial"/>
-                <a:cs typeface="Arial"/>
-              </a:defRPr>
-            </a:pPr>
-            <a:r>
-              <a:rPr sz="2625" b="0">
-                <a:solidFill>
-                  <a:srgbClr val="A5C8CB"/>
-                </a:solidFill>
-                <a:latin typeface="Arial"/>
-                <a:ea typeface="Arial"/>
-                <a:cs typeface="Arial"/>
-              </a:rPr>
-              <a:t>Previsões mensais com intervalos de 95%</a:t>
-            </a:r>
-          </a:p>
-        </p:txBody>
-      </p:sp>
-      <p:sp>
-        <p:nvSpPr>
-          <p:cNvPr id="5" name="">
-            <a:extLst xmlns:a="http://schemas.openxmlformats.org/drawingml/2006/main">
-              <a:ext uri="{FF2B5EF4-FFF2-40B4-BE49-F238E27FC236}">
-                <a16:creationId xmlns:a16="http://schemas.microsoft.com/office/drawing/2014/main" id="{AF716ACC-7C16-46A7-B79A-C0E64F36E5F6}"/>
-              </a:ext>
-            </a:extLst>
-          </p:cNvPr>
-          <p:cNvSpPr>
-            <a:spLocks xmlns:a="http://schemas.openxmlformats.org/drawingml/2006/main" noGrp="1"/>
-          </p:cNvSpPr>
-          <p:nvPr/>
-        </p:nvSpPr>
-        <p:spPr>
-          <a:xfrm xmlns:a="http://schemas.openxmlformats.org/drawingml/2006/main">
-            <a:off x="666750" y="4857750"/>
-            <a:ext cx="6191250" cy="714375"/>
-          </a:xfrm>
-          <a:prstGeom xmlns:a="http://schemas.openxmlformats.org/drawingml/2006/main" prst="rect">
-            <a:avLst/>
-          </a:prstGeom>
-          <a:noFill xmlns:a="http://schemas.openxmlformats.org/drawingml/2006/main"/>
-          <a:ln xmlns:a="http://schemas.openxmlformats.org/drawingml/2006/main" w="0">
-            <a:noFill/>
-          </a:ln>
-        </p:spPr>
-        <p:txBody>
-          <a:bodyPr xmlns:a="http://schemas.openxmlformats.org/drawingml/2006/main">
-            <a:noAutofit/>
-          </a:bodyPr>
-          <a:lstStyle xmlns:a="http://schemas.openxmlformats.org/drawingml/2006/main"/>
-          <a:p xmlns:a="http://schemas.openxmlformats.org/drawingml/2006/main">
-            <a:pPr>
-              <a:defRPr sz="3600" b="0">
-                <a:solidFill>
-                  <a:srgbClr val="D9AC69"/>
-                </a:solidFill>
-                <a:latin typeface="Arial"/>
-                <a:ea typeface="Arial"/>
-                <a:cs typeface="Arial"/>
-              </a:defRPr>
-            </a:pPr>
-            <a:r>
-              <a:rPr sz="3600" b="0">
-                <a:solidFill>
-                  <a:srgbClr val="D9AC69"/>
-                </a:solidFill>
-                <a:latin typeface="Arial"/>
-                <a:ea typeface="Arial"/>
-                <a:cs typeface="Arial"/>
-              </a:rPr>
-              <a:t>1931–2016</a:t>
             </a:r>
           </a:p>
         </p:txBody>
@@ -13241,222 +13561,6 @@
 </file>
 
 <file path=ppt/slides/slide10.xml><?xml version="1.0" encoding="utf-8"?>
-<p:sld xmlns:p="http://schemas.openxmlformats.org/presentationml/2006/main">
-  <p:cSld>
-    <p:bg>
-      <p:bgPr>
-        <a:solidFill xmlns:a="http://schemas.openxmlformats.org/drawingml/2006/main">
-          <a:srgbClr val="F6F3EB"/>
-        </a:solidFill>
-      </p:bgPr>
-    </p:bg>
-    <p:spTree>
-      <p:nvGrpSpPr>
-        <p:cNvPr id="1" name=""/>
-        <p:cNvGrpSpPr/>
-        <p:nvPr/>
-      </p:nvGrpSpPr>
-      <p:grpSpPr>
-        <a:xfrm xmlns:a="http://schemas.openxmlformats.org/drawingml/2006/main"/>
-      </p:grpSpPr>
-      <p:sp>
-        <p:nvSpPr>
-          <p:cNvPr id="5" name="">
-            <a:extLst xmlns:a="http://schemas.openxmlformats.org/drawingml/2006/main">
-              <a:ext uri="{FF2B5EF4-FFF2-40B4-BE49-F238E27FC236}">
-                <a16:creationId xmlns:a16="http://schemas.microsoft.com/office/drawing/2014/main" id="{E288CB17-6EB2-4119-BBC2-91FB79972D74}"/>
-              </a:ext>
-            </a:extLst>
-          </p:cNvPr>
-          <p:cNvSpPr>
-            <a:spLocks xmlns:a="http://schemas.openxmlformats.org/drawingml/2006/main" noGrp="1"/>
-          </p:cNvSpPr>
-          <p:nvPr/>
-        </p:nvSpPr>
-        <p:spPr>
-          <a:xfrm xmlns:a="http://schemas.openxmlformats.org/drawingml/2006/main">
-            <a:off x="609600" y="419100"/>
-            <a:ext cx="10934700" cy="952500"/>
-          </a:xfrm>
-          <a:prstGeom xmlns:a="http://schemas.openxmlformats.org/drawingml/2006/main" prst="rect">
-            <a:avLst/>
-          </a:prstGeom>
-          <a:noFill xmlns:a="http://schemas.openxmlformats.org/drawingml/2006/main"/>
-          <a:ln xmlns:a="http://schemas.openxmlformats.org/drawingml/2006/main" w="0">
-            <a:noFill/>
-          </a:ln>
-        </p:spPr>
-        <p:txBody>
-          <a:bodyPr xmlns:a="http://schemas.openxmlformats.org/drawingml/2006/main">
-            <a:noAutofit/>
-          </a:bodyPr>
-          <a:lstStyle xmlns:a="http://schemas.openxmlformats.org/drawingml/2006/main"/>
-          <a:p xmlns:a="http://schemas.openxmlformats.org/drawingml/2006/main">
-            <a:pPr>
-              <a:defRPr sz="3300" b="1">
-                <a:solidFill>
-                  <a:srgbClr val="18343E"/>
-                </a:solidFill>
-                <a:latin typeface="Arial"/>
-                <a:ea typeface="Arial"/>
-                <a:cs typeface="Arial"/>
-              </a:defRPr>
-            </a:pPr>
-            <a:r>
-              <a:rPr sz="3300" b="1">
-                <a:solidFill>
-                  <a:srgbClr val="18343E"/>
-                </a:solidFill>
-                <a:latin typeface="Arial"/>
-                <a:ea typeface="Arial"/>
-                <a:cs typeface="Arial"/>
-              </a:rPr>
-              <a:t>O ingênuo sazonal tem o menor erro no teste</a:t>
-            </a:r>
-          </a:p>
-        </p:txBody>
-      </p:sp>
-      <p:sp>
-        <p:nvSpPr>
-          <p:cNvPr id="2" name="">
-            <a:extLst xmlns:a="http://schemas.openxmlformats.org/drawingml/2006/main">
-              <a:ext uri="{FF2B5EF4-FFF2-40B4-BE49-F238E27FC236}">
-                <a16:creationId xmlns:a16="http://schemas.microsoft.com/office/drawing/2014/main" id="{FC92EB08-8AD3-4627-87E0-5A23F33CFDCA}"/>
-              </a:ext>
-            </a:extLst>
-          </p:cNvPr>
-          <p:cNvSpPr>
-            <a:spLocks xmlns:a="http://schemas.openxmlformats.org/drawingml/2006/main" noGrp="1"/>
-          </p:cNvSpPr>
-          <p:nvPr/>
-        </p:nvSpPr>
-        <p:spPr>
-          <a:xfrm xmlns:a="http://schemas.openxmlformats.org/drawingml/2006/main">
-            <a:off x="609600" y="6400800"/>
-            <a:ext cx="5715000" cy="228600"/>
-          </a:xfrm>
-          <a:prstGeom xmlns:a="http://schemas.openxmlformats.org/drawingml/2006/main" prst="rect">
-            <a:avLst/>
-          </a:prstGeom>
-          <a:noFill xmlns:a="http://schemas.openxmlformats.org/drawingml/2006/main"/>
-          <a:ln xmlns:a="http://schemas.openxmlformats.org/drawingml/2006/main" w="0">
-            <a:noFill/>
-          </a:ln>
-        </p:spPr>
-        <p:txBody>
-          <a:bodyPr xmlns:a="http://schemas.openxmlformats.org/drawingml/2006/main">
-            <a:noAutofit/>
-          </a:bodyPr>
-          <a:lstStyle xmlns:a="http://schemas.openxmlformats.org/drawingml/2006/main"/>
-          <a:p xmlns:a="http://schemas.openxmlformats.org/drawingml/2006/main">
-            <a:pPr>
-              <a:defRPr sz="1200" b="0">
-                <a:solidFill>
-                  <a:srgbClr val="5B7177"/>
-                </a:solidFill>
-                <a:latin typeface="Arial"/>
-                <a:ea typeface="Arial"/>
-                <a:cs typeface="Arial"/>
-              </a:defRPr>
-            </a:pPr>
-            <a:r>
-              <a:rPr sz="1200" b="0">
-                <a:solidFill>
-                  <a:srgbClr val="5B7177"/>
-                </a:solidFill>
-                <a:latin typeface="Arial"/>
-                <a:ea typeface="Arial"/>
-                <a:cs typeface="Arial"/>
-              </a:rPr>
-              <a:t>10  Ilha Solteira</a:t>
-            </a:r>
-          </a:p>
-        </p:txBody>
-      </p:sp>
-      <p:graphicFrame>
-        <p:nvGraphicFramePr>
-          <p:cNvPr id="7" name="Chart"/>
-          <p:cNvGraphicFramePr/>
-          <p:nvPr/>
-        </p:nvGraphicFramePr>
-        <p:xfrm>
-          <a:off xmlns:a="http://schemas.openxmlformats.org/drawingml/2006/main" x="666750" y="1581150"/>
-          <a:ext xmlns:a="http://schemas.openxmlformats.org/drawingml/2006/main" cx="10763250" cy="4048125"/>
-        </p:xfrm>
-        <a:graphic xmlns:a="http://schemas.openxmlformats.org/drawingml/2006/main">
-          <a:graphicData uri="http://schemas.openxmlformats.org/drawingml/2006/chart">
-            <c:chart xmlns:r="http://schemas.openxmlformats.org/officeDocument/2006/relationships" xmlns:c="http://schemas.openxmlformats.org/drawingml/2006/chart" r:id="Rbc54c764fd8a4880"/>
-          </a:graphicData>
-        </a:graphic>
-      </p:graphicFrame>
-      <p:sp>
-        <p:nvSpPr>
-          <p:cNvPr id="4" name="">
-            <a:extLst xmlns:a="http://schemas.openxmlformats.org/drawingml/2006/main">
-              <a:ext uri="{FF2B5EF4-FFF2-40B4-BE49-F238E27FC236}">
-                <a16:creationId xmlns:a16="http://schemas.microsoft.com/office/drawing/2014/main" id="{3D87A019-4074-4907-BE49-AAF115B7F5A7}"/>
-              </a:ext>
-            </a:extLst>
-          </p:cNvPr>
-          <p:cNvSpPr>
-            <a:spLocks xmlns:a="http://schemas.openxmlformats.org/drawingml/2006/main" noGrp="1"/>
-          </p:cNvSpPr>
-          <p:nvPr/>
-        </p:nvSpPr>
-        <p:spPr>
-          <a:xfrm xmlns:a="http://schemas.openxmlformats.org/drawingml/2006/main">
-            <a:off x="666750" y="5810250"/>
-            <a:ext cx="10763250" cy="504825"/>
-          </a:xfrm>
-          <a:prstGeom xmlns:a="http://schemas.openxmlformats.org/drawingml/2006/main" prst="rect">
-            <a:avLst/>
-          </a:prstGeom>
-          <a:noFill xmlns:a="http://schemas.openxmlformats.org/drawingml/2006/main"/>
-          <a:ln xmlns:a="http://schemas.openxmlformats.org/drawingml/2006/main" w="0">
-            <a:noFill/>
-          </a:ln>
-        </p:spPr>
-        <p:txBody>
-          <a:bodyPr xmlns:a="http://schemas.openxmlformats.org/drawingml/2006/main">
-            <a:noAutofit/>
-          </a:bodyPr>
-          <a:lstStyle xmlns:a="http://schemas.openxmlformats.org/drawingml/2006/main"/>
-          <a:p xmlns:a="http://schemas.openxmlformats.org/drawingml/2006/main">
-            <a:pPr>
-              <a:defRPr sz="1575" b="0">
-                <a:solidFill>
-                  <a:srgbClr val="5B7177"/>
-                </a:solidFill>
-                <a:latin typeface="Arial"/>
-                <a:ea typeface="Arial"/>
-                <a:cs typeface="Arial"/>
-              </a:defRPr>
-            </a:pPr>
-            <a:r>
-              <a:rPr sz="1575" b="0">
-                <a:solidFill>
-                  <a:srgbClr val="5B7177"/>
-                </a:solidFill>
-                <a:latin typeface="Arial"/>
-                <a:ea typeface="Arial"/>
-                <a:cs typeface="Arial"/>
-              </a:rPr>
-              <a:t>2014–2016, origem dez/2013. RMSE na unidade da tabela. Menor é melhor.</a:t>
-            </a:r>
-          </a:p>
-        </p:txBody>
-      </p:sp>
-    </p:spTree>
-    <p:extLst>
-      <p:ext uri="{BB962C8B-B14F-4D97-AF65-F5344CB8AC3E}">
-        <p14:creationId xmlns:p14="http://schemas.microsoft.com/office/powerpoint/2010/main" val="769877386"/>
-      </p:ext>
-    </p:extLst>
-  </p:cSld>
-</p:sld>
-</file>
-
-<file path=ppt/slides/slide11.xml><?xml version="1.0" encoding="utf-8"?>
 <p:sld xmlns:p="http://schemas.openxmlformats.org/presentationml/2006/main">
   <p:cSld>
     <p:bg>
@@ -13509,6 +13613,7 @@
           <a:lstStyle xmlns:a="http://schemas.openxmlformats.org/drawingml/2006/main"/>
           <a:p xmlns:a="http://schemas.openxmlformats.org/drawingml/2006/main">
             <a:pPr>
+              <a:buNone/>
               <a:defRPr sz="3300" b="1">
                 <a:solidFill>
                   <a:srgbClr val="18343E"/>
@@ -13566,6 +13671,7 @@
           <a:lstStyle xmlns:a="http://schemas.openxmlformats.org/drawingml/2006/main"/>
           <a:p xmlns:a="http://schemas.openxmlformats.org/drawingml/2006/main">
             <a:pPr>
+              <a:buNone/>
               <a:defRPr sz="1200" b="0">
                 <a:solidFill>
                   <a:srgbClr val="5B7177"/>
@@ -13584,14 +13690,20 @@
                 <a:ea typeface="Arial"/>
                 <a:cs typeface="Arial"/>
               </a:rPr>
-              <a:t>11  Ilha Solteira</a:t>
+              <a:t>10  Ilha Solteira</a:t>
             </a:r>
           </a:p>
         </p:txBody>
       </p:sp>
       <p:graphicFrame>
         <p:nvGraphicFramePr>
-          <p:cNvPr id="7" name="Chart"/>
+          <p:cNvPr id="7" name="Chart">
+            <a:extLst xmlns:a="http://schemas.openxmlformats.org/drawingml/2006/main">
+              <a:ext uri="{FF2B5EF4-FFF2-40B4-BE49-F238E27FC236}">
+                <a16:creationId xmlns:a16="http://schemas.microsoft.com/office/drawing/2014/main" id="{AA7F3007-2DC8-4DF8-9576-31CFED6044BF}"/>
+              </a:ext>
+            </a:extLst>
+          </p:cNvPr>
           <p:cNvGraphicFramePr/>
           <p:nvPr/>
         </p:nvGraphicFramePr>
@@ -13601,7 +13713,7 @@
         </p:xfrm>
         <a:graphic xmlns:a="http://schemas.openxmlformats.org/drawingml/2006/main">
           <a:graphicData uri="http://schemas.openxmlformats.org/drawingml/2006/chart">
-            <c:chart xmlns:r="http://schemas.openxmlformats.org/officeDocument/2006/relationships" xmlns:c="http://schemas.openxmlformats.org/drawingml/2006/chart" r:id="R61128f114cff4e0b"/>
+            <c:chart xmlns:r="http://schemas.openxmlformats.org/officeDocument/2006/relationships" xmlns:c="http://schemas.openxmlformats.org/drawingml/2006/chart" r:id="R1a023a15231f468d"/>
           </a:graphicData>
         </a:graphic>
       </p:graphicFrame>
@@ -13639,6 +13751,7 @@
           <a:lstStyle xmlns:a="http://schemas.openxmlformats.org/drawingml/2006/main"/>
           <a:p xmlns:a="http://schemas.openxmlformats.org/drawingml/2006/main">
             <a:pPr>
+              <a:buNone/>
               <a:defRPr sz="1575" b="0">
                 <a:solidFill>
                   <a:srgbClr val="5B7177"/>
@@ -13672,7 +13785,7 @@
 </p:sld>
 </file>
 
-<file path=ppt/slides/slide12.xml><?xml version="1.0" encoding="utf-8"?>
+<file path=ppt/slides/slide11.xml><?xml version="1.0" encoding="utf-8"?>
 <p:sld xmlns:p="http://schemas.openxmlformats.org/presentationml/2006/main">
   <p:cSld>
     <p:bg>
@@ -13725,6 +13838,7 @@
           <a:lstStyle xmlns:a="http://schemas.openxmlformats.org/drawingml/2006/main"/>
           <a:p xmlns:a="http://schemas.openxmlformats.org/drawingml/2006/main">
             <a:pPr>
+              <a:buNone/>
               <a:defRPr sz="3300" b="1">
                 <a:solidFill>
                   <a:srgbClr val="18343E"/>
@@ -13782,6 +13896,7 @@
           <a:lstStyle xmlns:a="http://schemas.openxmlformats.org/drawingml/2006/main"/>
           <a:p xmlns:a="http://schemas.openxmlformats.org/drawingml/2006/main">
             <a:pPr>
+              <a:buNone/>
               <a:defRPr sz="1200" b="0">
                 <a:solidFill>
                   <a:srgbClr val="5B7177"/>
@@ -13800,14 +13915,20 @@
                 <a:ea typeface="Arial"/>
                 <a:cs typeface="Arial"/>
               </a:rPr>
-              <a:t>12  Ilha Solteira</a:t>
+              <a:t>11  Ilha Solteira</a:t>
             </a:r>
           </a:p>
         </p:txBody>
       </p:sp>
       <p:graphicFrame>
         <p:nvGraphicFramePr>
-          <p:cNvPr id="7" name="Chart"/>
+          <p:cNvPr id="7" name="Chart">
+            <a:extLst xmlns:a="http://schemas.openxmlformats.org/drawingml/2006/main">
+              <a:ext uri="{FF2B5EF4-FFF2-40B4-BE49-F238E27FC236}">
+                <a16:creationId xmlns:a16="http://schemas.microsoft.com/office/drawing/2014/main" id="{01ECF47D-3658-42DB-B7A8-D8CDCB5BC73A}"/>
+              </a:ext>
+            </a:extLst>
+          </p:cNvPr>
           <p:cNvGraphicFramePr/>
           <p:nvPr/>
         </p:nvGraphicFramePr>
@@ -13817,7 +13938,7 @@
         </p:xfrm>
         <a:graphic xmlns:a="http://schemas.openxmlformats.org/drawingml/2006/main">
           <a:graphicData uri="http://schemas.openxmlformats.org/drawingml/2006/chart">
-            <c:chart xmlns:r="http://schemas.openxmlformats.org/officeDocument/2006/relationships" xmlns:c="http://schemas.openxmlformats.org/drawingml/2006/chart" r:id="R3268fd2d62ff4bcc"/>
+            <c:chart xmlns:r="http://schemas.openxmlformats.org/officeDocument/2006/relationships" xmlns:c="http://schemas.openxmlformats.org/drawingml/2006/chart" r:id="Reb027964164f4c1f"/>
           </a:graphicData>
         </a:graphic>
       </p:graphicFrame>
@@ -13855,6 +13976,7 @@
           <a:lstStyle xmlns:a="http://schemas.openxmlformats.org/drawingml/2006/main"/>
           <a:p xmlns:a="http://schemas.openxmlformats.org/drawingml/2006/main">
             <a:pPr>
+              <a:buNone/>
               <a:defRPr sz="1575" b="0">
                 <a:solidFill>
                   <a:srgbClr val="5B7177"/>
@@ -13888,7 +14010,7 @@
 </p:sld>
 </file>
 
-<file path=ppt/slides/slide13.xml><?xml version="1.0" encoding="utf-8"?>
+<file path=ppt/slides/slide12.xml><?xml version="1.0" encoding="utf-8"?>
 <p:sld xmlns:p="http://schemas.openxmlformats.org/presentationml/2006/main">
   <p:cSld>
     <p:bg>
@@ -13941,6 +14063,7 @@
           <a:lstStyle xmlns:a="http://schemas.openxmlformats.org/drawingml/2006/main"/>
           <a:p xmlns:a="http://schemas.openxmlformats.org/drawingml/2006/main">
             <a:pPr>
+              <a:buNone/>
               <a:defRPr sz="3300" b="1">
                 <a:solidFill>
                   <a:srgbClr val="18343E"/>
@@ -13998,6 +14121,7 @@
           <a:lstStyle xmlns:a="http://schemas.openxmlformats.org/drawingml/2006/main"/>
           <a:p xmlns:a="http://schemas.openxmlformats.org/drawingml/2006/main">
             <a:pPr>
+              <a:buNone/>
               <a:defRPr sz="1200" b="0">
                 <a:solidFill>
                   <a:srgbClr val="5B7177"/>
@@ -14016,14 +14140,20 @@
                 <a:ea typeface="Arial"/>
                 <a:cs typeface="Arial"/>
               </a:rPr>
-              <a:t>13  Ilha Solteira</a:t>
+              <a:t>12  Ilha Solteira</a:t>
             </a:r>
           </a:p>
         </p:txBody>
       </p:sp>
       <p:graphicFrame>
         <p:nvGraphicFramePr>
-          <p:cNvPr id="7" name="Chart"/>
+          <p:cNvPr id="7" name="Chart">
+            <a:extLst xmlns:a="http://schemas.openxmlformats.org/drawingml/2006/main">
+              <a:ext uri="{FF2B5EF4-FFF2-40B4-BE49-F238E27FC236}">
+                <a16:creationId xmlns:a16="http://schemas.microsoft.com/office/drawing/2014/main" id="{F6C2E755-82B8-42F1-BC8F-2FEDF880EEDC}"/>
+              </a:ext>
+            </a:extLst>
+          </p:cNvPr>
           <p:cNvGraphicFramePr/>
           <p:nvPr/>
         </p:nvGraphicFramePr>
@@ -14033,7 +14163,7 @@
         </p:xfrm>
         <a:graphic xmlns:a="http://schemas.openxmlformats.org/drawingml/2006/main">
           <a:graphicData uri="http://schemas.openxmlformats.org/drawingml/2006/chart">
-            <c:chart xmlns:r="http://schemas.openxmlformats.org/officeDocument/2006/relationships" xmlns:c="http://schemas.openxmlformats.org/drawingml/2006/chart" r:id="R8b41e65e66e84590"/>
+            <c:chart xmlns:r="http://schemas.openxmlformats.org/officeDocument/2006/relationships" xmlns:c="http://schemas.openxmlformats.org/drawingml/2006/chart" r:id="R8c2d1377e2c04a14"/>
           </a:graphicData>
         </a:graphic>
       </p:graphicFrame>
@@ -14071,6 +14201,7 @@
           <a:lstStyle xmlns:a="http://schemas.openxmlformats.org/drawingml/2006/main"/>
           <a:p xmlns:a="http://schemas.openxmlformats.org/drawingml/2006/main">
             <a:pPr>
+              <a:buNone/>
               <a:defRPr sz="1575" b="0">
                 <a:solidFill>
                   <a:srgbClr val="5B7177"/>
@@ -14104,7 +14235,7 @@
 </p:sld>
 </file>
 
-<file path=ppt/slides/slide14.xml><?xml version="1.0" encoding="utf-8"?>
+<file path=ppt/slides/slide13.xml><?xml version="1.0" encoding="utf-8"?>
 <p:sld xmlns:p="http://schemas.openxmlformats.org/presentationml/2006/main">
   <p:cSld>
     <p:bg>
@@ -14157,6 +14288,7 @@
           <a:lstStyle xmlns:a="http://schemas.openxmlformats.org/drawingml/2006/main"/>
           <a:p xmlns:a="http://schemas.openxmlformats.org/drawingml/2006/main">
             <a:pPr>
+              <a:buNone/>
               <a:defRPr sz="3300" b="1">
                 <a:solidFill>
                   <a:srgbClr val="18343E"/>
@@ -14214,6 +14346,7 @@
           <a:lstStyle xmlns:a="http://schemas.openxmlformats.org/drawingml/2006/main"/>
           <a:p xmlns:a="http://schemas.openxmlformats.org/drawingml/2006/main">
             <a:pPr>
+              <a:buNone/>
               <a:defRPr sz="1200" b="0">
                 <a:solidFill>
                   <a:srgbClr val="5B7177"/>
@@ -14232,7 +14365,7 @@
                 <a:ea typeface="Arial"/>
                 <a:cs typeface="Arial"/>
               </a:rPr>
-              <a:t>14  Ilha Solteira</a:t>
+              <a:t>13  Ilha Solteira</a:t>
             </a:r>
           </a:p>
         </p:txBody>
@@ -14271,6 +14404,7 @@
           <a:lstStyle xmlns:a="http://schemas.openxmlformats.org/drawingml/2006/main"/>
           <a:p xmlns:a="http://schemas.openxmlformats.org/drawingml/2006/main">
             <a:pPr>
+              <a:buNone/>
               <a:defRPr sz="6000" b="1">
                 <a:solidFill>
                   <a:srgbClr val="007F80"/>
@@ -14328,6 +14462,7 @@
           <a:lstStyle xmlns:a="http://schemas.openxmlformats.org/drawingml/2006/main"/>
           <a:p xmlns:a="http://schemas.openxmlformats.org/drawingml/2006/main">
             <a:pPr>
+              <a:buNone/>
               <a:defRPr sz="6000" b="1">
                 <a:solidFill>
                   <a:srgbClr val="C48730"/>
@@ -14385,6 +14520,7 @@
           <a:lstStyle xmlns:a="http://schemas.openxmlformats.org/drawingml/2006/main"/>
           <a:p xmlns:a="http://schemas.openxmlformats.org/drawingml/2006/main">
             <a:pPr>
+              <a:buNone/>
               <a:defRPr sz="2325" b="0">
                 <a:solidFill>
                   <a:srgbClr val="18343E"/>
@@ -14442,6 +14578,7 @@
           <a:lstStyle xmlns:a="http://schemas.openxmlformats.org/drawingml/2006/main"/>
           <a:p xmlns:a="http://schemas.openxmlformats.org/drawingml/2006/main">
             <a:pPr>
+              <a:buNone/>
               <a:defRPr sz="2325" b="0">
                 <a:solidFill>
                   <a:srgbClr val="18343E"/>
@@ -14499,6 +14636,7 @@
           <a:lstStyle xmlns:a="http://schemas.openxmlformats.org/drawingml/2006/main"/>
           <a:p xmlns:a="http://schemas.openxmlformats.org/drawingml/2006/main">
             <a:pPr>
+              <a:buNone/>
               <a:defRPr sz="2475" b="0">
                 <a:solidFill>
                   <a:srgbClr val="18343E"/>
@@ -14522,6 +14660,7 @@
           </a:p>
           <a:p xmlns:a="http://schemas.openxmlformats.org/drawingml/2006/main">
             <a:pPr>
+              <a:buNone/>
               <a:defRPr sz="2475" b="0">
                 <a:solidFill>
                   <a:srgbClr val="18343E"/>
@@ -14579,6 +14718,7 @@
           <a:lstStyle xmlns:a="http://schemas.openxmlformats.org/drawingml/2006/main"/>
           <a:p xmlns:a="http://schemas.openxmlformats.org/drawingml/2006/main">
             <a:pPr>
+              <a:buNone/>
               <a:defRPr sz="1575" b="0">
                 <a:solidFill>
                   <a:srgbClr val="5B7177"/>
@@ -14612,7 +14752,7 @@
 </p:sld>
 </file>
 
-<file path=ppt/slides/slide15.xml><?xml version="1.0" encoding="utf-8"?>
+<file path=ppt/slides/slide14.xml><?xml version="1.0" encoding="utf-8"?>
 <p:sld xmlns:p="http://schemas.openxmlformats.org/presentationml/2006/main">
   <p:cSld>
     <p:bg>
@@ -14665,6 +14805,7 @@
           <a:lstStyle xmlns:a="http://schemas.openxmlformats.org/drawingml/2006/main"/>
           <a:p xmlns:a="http://schemas.openxmlformats.org/drawingml/2006/main">
             <a:pPr>
+              <a:buNone/>
               <a:defRPr sz="3300" b="1">
                 <a:solidFill>
                   <a:srgbClr val="18343E"/>
@@ -14722,6 +14863,7 @@
           <a:lstStyle xmlns:a="http://schemas.openxmlformats.org/drawingml/2006/main"/>
           <a:p xmlns:a="http://schemas.openxmlformats.org/drawingml/2006/main">
             <a:pPr>
+              <a:buNone/>
               <a:defRPr sz="1200" b="0">
                 <a:solidFill>
                   <a:srgbClr val="5B7177"/>
@@ -14740,7 +14882,7 @@
                 <a:ea typeface="Arial"/>
                 <a:cs typeface="Arial"/>
               </a:rPr>
-              <a:t>15  Ilha Solteira</a:t>
+              <a:t>14  Ilha Solteira</a:t>
             </a:r>
           </a:p>
         </p:txBody>
@@ -14779,6 +14921,7 @@
           <a:lstStyle xmlns:a="http://schemas.openxmlformats.org/drawingml/2006/main"/>
           <a:p xmlns:a="http://schemas.openxmlformats.org/drawingml/2006/main">
             <a:pPr>
+              <a:buNone/>
               <a:defRPr sz="3600" b="1">
                 <a:solidFill>
                   <a:srgbClr val="C48730"/>
@@ -14836,6 +14979,7 @@
           <a:lstStyle xmlns:a="http://schemas.openxmlformats.org/drawingml/2006/main"/>
           <a:p xmlns:a="http://schemas.openxmlformats.org/drawingml/2006/main">
             <a:pPr>
+              <a:buNone/>
               <a:defRPr sz="2250" b="0">
                 <a:solidFill>
                   <a:srgbClr val="18343E"/>
@@ -14893,6 +15037,7 @@
           <a:lstStyle xmlns:a="http://schemas.openxmlformats.org/drawingml/2006/main"/>
           <a:p xmlns:a="http://schemas.openxmlformats.org/drawingml/2006/main">
             <a:pPr>
+              <a:buNone/>
               <a:defRPr sz="3300" b="1">
                 <a:solidFill>
                   <a:srgbClr val="007F80"/>
@@ -14950,6 +15095,7 @@
           <a:lstStyle xmlns:a="http://schemas.openxmlformats.org/drawingml/2006/main"/>
           <a:p xmlns:a="http://schemas.openxmlformats.org/drawingml/2006/main">
             <a:pPr>
+              <a:buNone/>
               <a:defRPr sz="2250" b="0">
                 <a:solidFill>
                   <a:srgbClr val="18343E"/>
@@ -14983,7 +15129,7 @@
 </p:sld>
 </file>
 
-<file path=ppt/slides/slide16.xml><?xml version="1.0" encoding="utf-8"?>
+<file path=ppt/slides/slide15.xml><?xml version="1.0" encoding="utf-8"?>
 <p:sld xmlns:p="http://schemas.openxmlformats.org/presentationml/2006/main">
   <p:cSld>
     <p:bg>
@@ -15036,6 +15182,7 @@
           <a:lstStyle xmlns:a="http://schemas.openxmlformats.org/drawingml/2006/main"/>
           <a:p xmlns:a="http://schemas.openxmlformats.org/drawingml/2006/main">
             <a:pPr>
+              <a:buNone/>
               <a:defRPr sz="3300" b="1">
                 <a:solidFill>
                   <a:srgbClr val="18343E"/>
@@ -15093,6 +15240,7 @@
           <a:lstStyle xmlns:a="http://schemas.openxmlformats.org/drawingml/2006/main"/>
           <a:p xmlns:a="http://schemas.openxmlformats.org/drawingml/2006/main">
             <a:pPr>
+              <a:buNone/>
               <a:defRPr sz="1200" b="0">
                 <a:solidFill>
                   <a:srgbClr val="5B7177"/>
@@ -15111,14 +15259,20 @@
                 <a:ea typeface="Arial"/>
                 <a:cs typeface="Arial"/>
               </a:rPr>
-              <a:t>16  Ilha Solteira</a:t>
+              <a:t>15  Ilha Solteira</a:t>
             </a:r>
           </a:p>
         </p:txBody>
       </p:sp>
       <p:graphicFrame>
         <p:nvGraphicFramePr>
-          <p:cNvPr id="7" name="Chart"/>
+          <p:cNvPr id="7" name="Chart">
+            <a:extLst xmlns:a="http://schemas.openxmlformats.org/drawingml/2006/main">
+              <a:ext uri="{FF2B5EF4-FFF2-40B4-BE49-F238E27FC236}">
+                <a16:creationId xmlns:a16="http://schemas.microsoft.com/office/drawing/2014/main" id="{D1DFF2DA-64EB-4489-8CBB-2334DA9A9F3E}"/>
+              </a:ext>
+            </a:extLst>
+          </p:cNvPr>
           <p:cNvGraphicFramePr/>
           <p:nvPr/>
         </p:nvGraphicFramePr>
@@ -15128,7 +15282,7 @@
         </p:xfrm>
         <a:graphic xmlns:a="http://schemas.openxmlformats.org/drawingml/2006/main">
           <a:graphicData uri="http://schemas.openxmlformats.org/drawingml/2006/chart">
-            <c:chart xmlns:r="http://schemas.openxmlformats.org/officeDocument/2006/relationships" xmlns:c="http://schemas.openxmlformats.org/drawingml/2006/chart" r:id="Rf0cad7c6279c4f20"/>
+            <c:chart xmlns:r="http://schemas.openxmlformats.org/officeDocument/2006/relationships" xmlns:c="http://schemas.openxmlformats.org/drawingml/2006/chart" r:id="Redff4363c4aa432d"/>
           </a:graphicData>
         </a:graphic>
       </p:graphicFrame>
@@ -15166,6 +15320,7 @@
           <a:lstStyle xmlns:a="http://schemas.openxmlformats.org/drawingml/2006/main"/>
           <a:p xmlns:a="http://schemas.openxmlformats.org/drawingml/2006/main">
             <a:pPr>
+              <a:buNone/>
               <a:defRPr sz="1575" b="0">
                 <a:solidFill>
                   <a:srgbClr val="5B7177"/>
@@ -15199,7 +15354,7 @@
 </p:sld>
 </file>
 
-<file path=ppt/slides/slide17.xml><?xml version="1.0" encoding="utf-8"?>
+<file path=ppt/slides/slide16.xml><?xml version="1.0" encoding="utf-8"?>
 <p:sld xmlns:p="http://schemas.openxmlformats.org/presentationml/2006/main">
   <p:cSld>
     <p:bg>
@@ -15252,6 +15407,7 @@
           <a:lstStyle xmlns:a="http://schemas.openxmlformats.org/drawingml/2006/main"/>
           <a:p xmlns:a="http://schemas.openxmlformats.org/drawingml/2006/main">
             <a:pPr>
+              <a:buNone/>
               <a:defRPr sz="3300" b="1">
                 <a:solidFill>
                   <a:srgbClr val="F8FAF7"/>
@@ -15309,6 +15465,7 @@
           <a:lstStyle xmlns:a="http://schemas.openxmlformats.org/drawingml/2006/main"/>
           <a:p xmlns:a="http://schemas.openxmlformats.org/drawingml/2006/main">
             <a:pPr>
+              <a:buNone/>
               <a:defRPr sz="1200" b="0">
                 <a:solidFill>
                   <a:srgbClr val="A5C8CB"/>
@@ -15327,7 +15484,7 @@
                 <a:ea typeface="Arial"/>
                 <a:cs typeface="Arial"/>
               </a:rPr>
-              <a:t>17  Ilha Solteira</a:t>
+              <a:t>16  Ilha Solteira</a:t>
             </a:r>
           </a:p>
         </p:txBody>
@@ -15366,6 +15523,7 @@
           <a:lstStyle xmlns:a="http://schemas.openxmlformats.org/drawingml/2006/main"/>
           <a:p xmlns:a="http://schemas.openxmlformats.org/drawingml/2006/main">
             <a:pPr>
+              <a:buNone/>
               <a:defRPr sz="2925" b="1">
                 <a:solidFill>
                   <a:srgbClr val="A5C8CB"/>
@@ -15423,6 +15581,7 @@
           <a:lstStyle xmlns:a="http://schemas.openxmlformats.org/drawingml/2006/main"/>
           <a:p xmlns:a="http://schemas.openxmlformats.org/drawingml/2006/main">
             <a:pPr>
+              <a:buNone/>
               <a:defRPr sz="2925" b="1">
                 <a:solidFill>
                   <a:srgbClr val="F8FAF7"/>
@@ -15480,6 +15639,7 @@
           <a:lstStyle xmlns:a="http://schemas.openxmlformats.org/drawingml/2006/main"/>
           <a:p xmlns:a="http://schemas.openxmlformats.org/drawingml/2006/main">
             <a:pPr>
+              <a:buNone/>
               <a:defRPr sz="2775" b="1">
                 <a:solidFill>
                   <a:srgbClr val="D9AC69"/>
@@ -15537,6 +15697,7 @@
           <a:lstStyle xmlns:a="http://schemas.openxmlformats.org/drawingml/2006/main"/>
           <a:p xmlns:a="http://schemas.openxmlformats.org/drawingml/2006/main">
             <a:pPr>
+              <a:buNone/>
               <a:defRPr sz="2100" b="0">
                 <a:solidFill>
                   <a:srgbClr val="F8FAF7"/>
@@ -15570,7 +15731,7 @@
 </p:sld>
 </file>
 
-<file path=ppt/slides/slide18.xml><?xml version="1.0" encoding="utf-8"?>
+<file path=ppt/slides/slide17.xml><?xml version="1.0" encoding="utf-8"?>
 <p:sld xmlns:p="http://schemas.openxmlformats.org/presentationml/2006/main">
   <p:cSld>
     <p:bg>
@@ -15623,6 +15784,7 @@
           <a:lstStyle xmlns:a="http://schemas.openxmlformats.org/drawingml/2006/main"/>
           <a:p xmlns:a="http://schemas.openxmlformats.org/drawingml/2006/main">
             <a:pPr>
+              <a:buNone/>
               <a:defRPr sz="3300" b="1">
                 <a:solidFill>
                   <a:srgbClr val="18343E"/>
@@ -15680,6 +15842,7 @@
           <a:lstStyle xmlns:a="http://schemas.openxmlformats.org/drawingml/2006/main"/>
           <a:p xmlns:a="http://schemas.openxmlformats.org/drawingml/2006/main">
             <a:pPr>
+              <a:buNone/>
               <a:defRPr sz="1200" b="0">
                 <a:solidFill>
                   <a:srgbClr val="5B7177"/>
@@ -15698,7 +15861,7 @@
                 <a:ea typeface="Arial"/>
                 <a:cs typeface="Arial"/>
               </a:rPr>
-              <a:t>18  Ilha Solteira</a:t>
+              <a:t>17  Ilha Solteira</a:t>
             </a:r>
           </a:p>
         </p:txBody>
@@ -15737,6 +15900,7 @@
           <a:lstStyle xmlns:a="http://schemas.openxmlformats.org/drawingml/2006/main"/>
           <a:p xmlns:a="http://schemas.openxmlformats.org/drawingml/2006/main">
             <a:pPr>
+              <a:buNone/>
               <a:defRPr sz="2400" b="0">
                 <a:solidFill>
                   <a:srgbClr val="18343E"/>
@@ -15760,6 +15924,7 @@
           </a:p>
           <a:p xmlns:a="http://schemas.openxmlformats.org/drawingml/2006/main">
             <a:pPr>
+              <a:buNone/>
               <a:defRPr sz="2400" b="0">
                 <a:solidFill>
                   <a:srgbClr val="18343E"/>
@@ -15817,6 +15982,7 @@
           <a:lstStyle xmlns:a="http://schemas.openxmlformats.org/drawingml/2006/main"/>
           <a:p xmlns:a="http://schemas.openxmlformats.org/drawingml/2006/main">
             <a:pPr>
+              <a:buNone/>
               <a:defRPr sz="2025" b="0">
                 <a:solidFill>
                   <a:srgbClr val="18343E"/>
@@ -15840,6 +16006,7 @@
           </a:p>
           <a:p xmlns:a="http://schemas.openxmlformats.org/drawingml/2006/main">
             <a:pPr>
+              <a:buNone/>
               <a:defRPr sz="2025" b="0">
                 <a:solidFill>
                   <a:srgbClr val="18343E"/>
@@ -15897,6 +16064,7 @@
           <a:lstStyle xmlns:a="http://schemas.openxmlformats.org/drawingml/2006/main"/>
           <a:p xmlns:a="http://schemas.openxmlformats.org/drawingml/2006/main">
             <a:pPr>
+              <a:buNone/>
               <a:defRPr sz="2175" b="1">
                 <a:solidFill>
                   <a:srgbClr val="007F80"/>
@@ -15951,10 +16119,10 @@
       </p:grpSpPr>
       <p:sp>
         <p:nvSpPr>
-          <p:cNvPr id="5" name="">
+          <p:cNvPr id="9" name="">
             <a:extLst xmlns:a="http://schemas.openxmlformats.org/drawingml/2006/main">
               <a:ext uri="{FF2B5EF4-FFF2-40B4-BE49-F238E27FC236}">
-                <a16:creationId xmlns:a16="http://schemas.microsoft.com/office/drawing/2014/main" id="{01241DF2-A5A8-4891-A8A0-D9EC52BCEDB8}"/>
+                <a16:creationId xmlns:a16="http://schemas.microsoft.com/office/drawing/2014/main" id="{7691BCBD-730B-4C88-9D32-516EFAF54AB5}"/>
               </a:ext>
             </a:extLst>
           </p:cNvPr>
@@ -15980,7 +16148,18 @@
           <a:bodyPr xmlns:a="http://schemas.openxmlformats.org/drawingml/2006/main">
             <a:noAutofit/>
           </a:bodyPr>
-          <a:lstStyle xmlns:a="http://schemas.openxmlformats.org/drawingml/2006/main"/>
+          <a:lstStyle xmlns:a="http://schemas.openxmlformats.org/drawingml/2006/main">
+            <a:defPPr>
+              <a:defRPr sz="3300" b="1">
+                <a:solidFill>
+                  <a:srgbClr val="18343E"/>
+                </a:solidFill>
+                <a:latin typeface="Arial"/>
+                <a:ea typeface="Arial"/>
+                <a:cs typeface="Arial"/>
+              </a:defRPr>
+            </a:defPPr>
+          </a:lstStyle>
           <a:p xmlns:a="http://schemas.openxmlformats.org/drawingml/2006/main">
             <a:pPr>
               <a:defRPr sz="3300" b="1">
@@ -16001,7 +16180,7 @@
                 <a:ea typeface="Arial"/>
                 <a:cs typeface="Arial"/>
               </a:rPr>
-              <a:t>O problema de previsão</a:t>
+              <a:t>A cidade e a usina</a:t>
             </a:r>
           </a:p>
         </p:txBody>
@@ -16011,7 +16190,421 @@
           <p:cNvPr id="2" name="">
             <a:extLst xmlns:a="http://schemas.openxmlformats.org/drawingml/2006/main">
               <a:ext uri="{FF2B5EF4-FFF2-40B4-BE49-F238E27FC236}">
-                <a16:creationId xmlns:a16="http://schemas.microsoft.com/office/drawing/2014/main" id="{F5039D9D-2CF6-4C85-9651-5DE8BCC3E876}"/>
+                <a16:creationId xmlns:a16="http://schemas.microsoft.com/office/drawing/2014/main" id="{B6448F83-A713-4021-9F22-68CD09B3E232}"/>
+              </a:ext>
+            </a:extLst>
+          </p:cNvPr>
+          <p:cNvSpPr>
+            <a:spLocks xmlns:a="http://schemas.openxmlformats.org/drawingml/2006/main" noGrp="1"/>
+          </p:cNvSpPr>
+          <p:nvPr/>
+        </p:nvSpPr>
+        <p:spPr>
+          <a:xfrm xmlns:a="http://schemas.openxmlformats.org/drawingml/2006/main">
+            <a:off x="666750" y="1714500"/>
+            <a:ext cx="4000500" cy="866775"/>
+          </a:xfrm>
+          <a:prstGeom xmlns:a="http://schemas.openxmlformats.org/drawingml/2006/main" prst="rect">
+            <a:avLst/>
+          </a:prstGeom>
+          <a:noFill xmlns:a="http://schemas.openxmlformats.org/drawingml/2006/main"/>
+          <a:ln xmlns:a="http://schemas.openxmlformats.org/drawingml/2006/main" w="0">
+            <a:noFill/>
+          </a:ln>
+        </p:spPr>
+        <p:txBody>
+          <a:bodyPr xmlns:a="http://schemas.openxmlformats.org/drawingml/2006/main">
+            <a:noAutofit/>
+          </a:bodyPr>
+          <a:lstStyle xmlns:a="http://schemas.openxmlformats.org/drawingml/2006/main">
+            <a:defPPr>
+              <a:defRPr sz="4800" b="1">
+                <a:solidFill>
+                  <a:srgbClr val="007F80"/>
+                </a:solidFill>
+                <a:latin typeface="Arial"/>
+                <a:ea typeface="Arial"/>
+                <a:cs typeface="Arial"/>
+              </a:defRPr>
+            </a:defPPr>
+          </a:lstStyle>
+          <a:p xmlns:a="http://schemas.openxmlformats.org/drawingml/2006/main">
+            <a:pPr>
+              <a:defRPr sz="4800" b="1">
+                <a:solidFill>
+                  <a:srgbClr val="007F80"/>
+                </a:solidFill>
+                <a:latin typeface="Arial"/>
+                <a:ea typeface="Arial"/>
+                <a:cs typeface="Arial"/>
+              </a:defRPr>
+            </a:pPr>
+            <a:r>
+              <a:rPr sz="4800" b="1">
+                <a:solidFill>
+                  <a:srgbClr val="007F80"/>
+                </a:solidFill>
+                <a:latin typeface="Arial"/>
+                <a:ea typeface="Arial"/>
+                <a:cs typeface="Arial"/>
+              </a:rPr>
+              <a:t>1968</a:t>
+            </a:r>
+          </a:p>
+        </p:txBody>
+      </p:sp>
+      <p:sp>
+        <p:nvSpPr>
+          <p:cNvPr id="3" name="">
+            <a:extLst xmlns:a="http://schemas.openxmlformats.org/drawingml/2006/main">
+              <a:ext uri="{FF2B5EF4-FFF2-40B4-BE49-F238E27FC236}">
+                <a16:creationId xmlns:a16="http://schemas.microsoft.com/office/drawing/2014/main" id="{8EF8FD4D-84FC-4BD7-B915-56F30085C692}"/>
+              </a:ext>
+            </a:extLst>
+          </p:cNvPr>
+          <p:cNvSpPr>
+            <a:spLocks xmlns:a="http://schemas.openxmlformats.org/drawingml/2006/main" noGrp="1"/>
+          </p:cNvSpPr>
+          <p:nvPr/>
+        </p:nvSpPr>
+        <p:spPr>
+          <a:xfrm xmlns:a="http://schemas.openxmlformats.org/drawingml/2006/main">
+            <a:off x="714375" y="2743200"/>
+            <a:ext cx="4524375" cy="1000125"/>
+          </a:xfrm>
+          <a:prstGeom xmlns:a="http://schemas.openxmlformats.org/drawingml/2006/main" prst="rect">
+            <a:avLst/>
+          </a:prstGeom>
+          <a:noFill xmlns:a="http://schemas.openxmlformats.org/drawingml/2006/main"/>
+          <a:ln xmlns:a="http://schemas.openxmlformats.org/drawingml/2006/main" w="0">
+            <a:noFill/>
+          </a:ln>
+        </p:spPr>
+        <p:txBody>
+          <a:bodyPr xmlns:a="http://schemas.openxmlformats.org/drawingml/2006/main">
+            <a:noAutofit/>
+          </a:bodyPr>
+          <a:lstStyle xmlns:a="http://schemas.openxmlformats.org/drawingml/2006/main">
+            <a:defPPr>
+              <a:defRPr sz="2025" b="0">
+                <a:solidFill>
+                  <a:srgbClr val="18343E"/>
+                </a:solidFill>
+                <a:latin typeface="Arial"/>
+                <a:ea typeface="Arial"/>
+                <a:cs typeface="Arial"/>
+              </a:defRPr>
+            </a:defPPr>
+          </a:lstStyle>
+          <a:p xmlns:a="http://schemas.openxmlformats.org/drawingml/2006/main">
+            <a:pPr>
+              <a:defRPr sz="2025" b="0">
+                <a:solidFill>
+                  <a:srgbClr val="18343E"/>
+                </a:solidFill>
+                <a:latin typeface="Arial"/>
+                <a:ea typeface="Arial"/>
+                <a:cs typeface="Arial"/>
+              </a:defRPr>
+            </a:pPr>
+            <a:r>
+              <a:rPr sz="2025" b="0">
+                <a:solidFill>
+                  <a:srgbClr val="18343E"/>
+                </a:solidFill>
+                <a:latin typeface="Arial"/>
+                <a:ea typeface="Arial"/>
+                <a:cs typeface="Arial"/>
+              </a:rPr>
+              <a:t>A cidade surge para receber</a:t>
+            </a:r>
+          </a:p>
+          <a:p xmlns:a="http://schemas.openxmlformats.org/drawingml/2006/main">
+            <a:pPr>
+              <a:defRPr sz="2025" b="0">
+                <a:solidFill>
+                  <a:srgbClr val="18343E"/>
+                </a:solidFill>
+                <a:latin typeface="Arial"/>
+                <a:ea typeface="Arial"/>
+                <a:cs typeface="Arial"/>
+              </a:defRPr>
+            </a:pPr>
+            <a:r>
+              <a:rPr sz="2025" b="0">
+                <a:solidFill>
+                  <a:srgbClr val="18343E"/>
+                </a:solidFill>
+                <a:latin typeface="Arial"/>
+                <a:ea typeface="Arial"/>
+                <a:cs typeface="Arial"/>
+              </a:rPr>
+              <a:t>os trabalhadores da usina.</a:t>
+            </a:r>
+          </a:p>
+        </p:txBody>
+      </p:sp>
+      <p:sp>
+        <p:nvSpPr>
+          <p:cNvPr id="4" name="">
+            <a:extLst xmlns:a="http://schemas.openxmlformats.org/drawingml/2006/main">
+              <a:ext uri="{FF2B5EF4-FFF2-40B4-BE49-F238E27FC236}">
+                <a16:creationId xmlns:a16="http://schemas.microsoft.com/office/drawing/2014/main" id="{629BCDE2-8FF2-44EA-96C3-9D3C659A08C6}"/>
+              </a:ext>
+            </a:extLst>
+          </p:cNvPr>
+          <p:cNvSpPr>
+            <a:spLocks xmlns:a="http://schemas.openxmlformats.org/drawingml/2006/main" noGrp="1"/>
+          </p:cNvSpPr>
+          <p:nvPr/>
+        </p:nvSpPr>
+        <p:spPr>
+          <a:xfrm xmlns:a="http://schemas.openxmlformats.org/drawingml/2006/main">
+            <a:off x="666750" y="3981450"/>
+            <a:ext cx="4000500" cy="866775"/>
+          </a:xfrm>
+          <a:prstGeom xmlns:a="http://schemas.openxmlformats.org/drawingml/2006/main" prst="rect">
+            <a:avLst/>
+          </a:prstGeom>
+          <a:noFill xmlns:a="http://schemas.openxmlformats.org/drawingml/2006/main"/>
+          <a:ln xmlns:a="http://schemas.openxmlformats.org/drawingml/2006/main" w="0">
+            <a:noFill/>
+          </a:ln>
+        </p:spPr>
+        <p:txBody>
+          <a:bodyPr xmlns:a="http://schemas.openxmlformats.org/drawingml/2006/main">
+            <a:noAutofit/>
+          </a:bodyPr>
+          <a:lstStyle xmlns:a="http://schemas.openxmlformats.org/drawingml/2006/main">
+            <a:defPPr>
+              <a:defRPr sz="4800" b="1">
+                <a:solidFill>
+                  <a:srgbClr val="C48730"/>
+                </a:solidFill>
+                <a:latin typeface="Arial"/>
+                <a:ea typeface="Arial"/>
+                <a:cs typeface="Arial"/>
+              </a:defRPr>
+            </a:defPPr>
+          </a:lstStyle>
+          <a:p xmlns:a="http://schemas.openxmlformats.org/drawingml/2006/main">
+            <a:pPr>
+              <a:defRPr sz="4800" b="1">
+                <a:solidFill>
+                  <a:srgbClr val="C48730"/>
+                </a:solidFill>
+                <a:latin typeface="Arial"/>
+                <a:ea typeface="Arial"/>
+                <a:cs typeface="Arial"/>
+              </a:defRPr>
+            </a:pPr>
+            <a:r>
+              <a:rPr sz="4800" b="1">
+                <a:solidFill>
+                  <a:srgbClr val="C48730"/>
+                </a:solidFill>
+                <a:latin typeface="Arial"/>
+                <a:ea typeface="Arial"/>
+                <a:cs typeface="Arial"/>
+              </a:rPr>
+              <a:t>1973</a:t>
+            </a:r>
+          </a:p>
+        </p:txBody>
+      </p:sp>
+      <p:sp>
+        <p:nvSpPr>
+          <p:cNvPr id="5" name="">
+            <a:extLst xmlns:a="http://schemas.openxmlformats.org/drawingml/2006/main">
+              <a:ext uri="{FF2B5EF4-FFF2-40B4-BE49-F238E27FC236}">
+                <a16:creationId xmlns:a16="http://schemas.microsoft.com/office/drawing/2014/main" id="{4E457D6F-6BDA-4A4C-AEE0-C30B694417AD}"/>
+              </a:ext>
+            </a:extLst>
+          </p:cNvPr>
+          <p:cNvSpPr>
+            <a:spLocks xmlns:a="http://schemas.openxmlformats.org/drawingml/2006/main" noGrp="1"/>
+          </p:cNvSpPr>
+          <p:nvPr/>
+        </p:nvSpPr>
+        <p:spPr>
+          <a:xfrm xmlns:a="http://schemas.openxmlformats.org/drawingml/2006/main">
+            <a:off x="714375" y="4972050"/>
+            <a:ext cx="4524375" cy="1000125"/>
+          </a:xfrm>
+          <a:prstGeom xmlns:a="http://schemas.openxmlformats.org/drawingml/2006/main" prst="rect">
+            <a:avLst/>
+          </a:prstGeom>
+          <a:noFill xmlns:a="http://schemas.openxmlformats.org/drawingml/2006/main"/>
+          <a:ln xmlns:a="http://schemas.openxmlformats.org/drawingml/2006/main" w="0">
+            <a:noFill/>
+          </a:ln>
+        </p:spPr>
+        <p:txBody>
+          <a:bodyPr xmlns:a="http://schemas.openxmlformats.org/drawingml/2006/main">
+            <a:noAutofit/>
+          </a:bodyPr>
+          <a:lstStyle xmlns:a="http://schemas.openxmlformats.org/drawingml/2006/main">
+            <a:defPPr>
+              <a:defRPr sz="2025" b="0">
+                <a:solidFill>
+                  <a:srgbClr val="18343E"/>
+                </a:solidFill>
+                <a:latin typeface="Arial"/>
+                <a:ea typeface="Arial"/>
+                <a:cs typeface="Arial"/>
+              </a:defRPr>
+            </a:defPPr>
+          </a:lstStyle>
+          <a:p xmlns:a="http://schemas.openxmlformats.org/drawingml/2006/main">
+            <a:pPr>
+              <a:defRPr sz="2025" b="0">
+                <a:solidFill>
+                  <a:srgbClr val="18343E"/>
+                </a:solidFill>
+                <a:latin typeface="Arial"/>
+                <a:ea typeface="Arial"/>
+                <a:cs typeface="Arial"/>
+              </a:defRPr>
+            </a:pPr>
+            <a:r>
+              <a:rPr sz="2025" b="0">
+                <a:solidFill>
+                  <a:srgbClr val="18343E"/>
+                </a:solidFill>
+                <a:latin typeface="Arial"/>
+                <a:ea typeface="Arial"/>
+                <a:cs typeface="Arial"/>
+              </a:rPr>
+              <a:t>A primeira unidade geradora</a:t>
+            </a:r>
+          </a:p>
+          <a:p xmlns:a="http://schemas.openxmlformats.org/drawingml/2006/main">
+            <a:pPr>
+              <a:defRPr sz="2025" b="0">
+                <a:solidFill>
+                  <a:srgbClr val="18343E"/>
+                </a:solidFill>
+                <a:latin typeface="Arial"/>
+                <a:ea typeface="Arial"/>
+                <a:cs typeface="Arial"/>
+              </a:defRPr>
+            </a:pPr>
+            <a:r>
+              <a:rPr sz="2025" b="0">
+                <a:solidFill>
+                  <a:srgbClr val="18343E"/>
+                </a:solidFill>
+                <a:latin typeface="Arial"/>
+                <a:ea typeface="Arial"/>
+                <a:cs typeface="Arial"/>
+              </a:rPr>
+              <a:t>entra em operação em julho.</a:t>
+            </a:r>
+          </a:p>
+        </p:txBody>
+      </p:sp>
+      <p:pic>
+        <p:nvPicPr>
+          <p:cNvPr id="6" name="">
+            <a:extLst xmlns:a="http://schemas.openxmlformats.org/drawingml/2006/main">
+              <a:ext uri="{FF2B5EF4-FFF2-40B4-BE49-F238E27FC236}">
+                <a16:creationId xmlns:a16="http://schemas.microsoft.com/office/drawing/2014/main" id="{7AB77D2B-3D86-4F44-A9C4-E9C6924F8735}"/>
+              </a:ext>
+            </a:extLst>
+          </p:cNvPr>
+          <p:cNvPicPr>
+            <a:picLocks xmlns:a="http://schemas.openxmlformats.org/drawingml/2006/main" noChangeAspect="1"/>
+          </p:cNvPicPr>
+          <p:nvPr/>
+        </p:nvPicPr>
+        <p:blipFill>
+          <a:blip xmlns:r="http://schemas.openxmlformats.org/officeDocument/2006/relationships" xmlns:a="http://schemas.openxmlformats.org/drawingml/2006/main" r:embed="R8631618102cf427c"/>
+          <a:stretch xmlns:a="http://schemas.openxmlformats.org/drawingml/2006/main"/>
+        </p:blipFill>
+        <p:spPr>
+          <a:xfrm xmlns:a="http://schemas.openxmlformats.org/drawingml/2006/main">
+            <a:off x="5381625" y="1562100"/>
+            <a:ext cx="6124575" cy="4593431"/>
+          </a:xfrm>
+          <a:prstGeom xmlns:a="http://schemas.openxmlformats.org/drawingml/2006/main" prst="rect">
+            <a:avLst/>
+          </a:prstGeom>
+        </p:spPr>
+      </p:pic>
+      <p:sp>
+        <p:nvSpPr>
+          <p:cNvPr id="7" name="">
+            <a:extLst xmlns:a="http://schemas.openxmlformats.org/drawingml/2006/main">
+              <a:ext uri="{FF2B5EF4-FFF2-40B4-BE49-F238E27FC236}">
+                <a16:creationId xmlns:a16="http://schemas.microsoft.com/office/drawing/2014/main" id="{AC5618DA-1897-485C-B32B-5E722E8CD7DB}"/>
+              </a:ext>
+            </a:extLst>
+          </p:cNvPr>
+          <p:cNvSpPr>
+            <a:spLocks xmlns:a="http://schemas.openxmlformats.org/drawingml/2006/main" noGrp="1"/>
+          </p:cNvSpPr>
+          <p:nvPr/>
+        </p:nvSpPr>
+        <p:spPr>
+          <a:xfrm xmlns:a="http://schemas.openxmlformats.org/drawingml/2006/main">
+            <a:off x="5381625" y="6172200"/>
+            <a:ext cx="6124575" cy="228600"/>
+          </a:xfrm>
+          <a:prstGeom xmlns:a="http://schemas.openxmlformats.org/drawingml/2006/main" prst="rect">
+            <a:avLst/>
+          </a:prstGeom>
+          <a:noFill xmlns:a="http://schemas.openxmlformats.org/drawingml/2006/main"/>
+          <a:ln xmlns:a="http://schemas.openxmlformats.org/drawingml/2006/main" w="0">
+            <a:noFill/>
+          </a:ln>
+        </p:spPr>
+        <p:txBody>
+          <a:bodyPr xmlns:a="http://schemas.openxmlformats.org/drawingml/2006/main">
+            <a:noAutofit/>
+          </a:bodyPr>
+          <a:lstStyle xmlns:a="http://schemas.openxmlformats.org/drawingml/2006/main">
+            <a:defPPr>
+              <a:defRPr sz="1200" b="0">
+                <a:solidFill>
+                  <a:srgbClr val="5B7177"/>
+                </a:solidFill>
+                <a:latin typeface="Arial"/>
+                <a:ea typeface="Arial"/>
+                <a:cs typeface="Arial"/>
+              </a:defRPr>
+            </a:defPPr>
+          </a:lstStyle>
+          <a:p xmlns:a="http://schemas.openxmlformats.org/drawingml/2006/main">
+            <a:pPr>
+              <a:defRPr sz="1200" b="0">
+                <a:solidFill>
+                  <a:srgbClr val="5B7177"/>
+                </a:solidFill>
+                <a:latin typeface="Arial"/>
+                <a:ea typeface="Arial"/>
+                <a:cs typeface="Arial"/>
+              </a:defRPr>
+            </a:pPr>
+            <a:r>
+              <a:rPr sz="1200" b="0">
+                <a:solidFill>
+                  <a:srgbClr val="5B7177"/>
+                </a:solidFill>
+                <a:latin typeface="Arial"/>
+                <a:ea typeface="Arial"/>
+                <a:cs typeface="Arial"/>
+              </a:rPr>
+              <a:t>Praça Paiaguás. Foto: Mof0 / CC BY-SA 2.0</a:t>
+            </a:r>
+          </a:p>
+        </p:txBody>
+      </p:sp>
+      <p:sp>
+        <p:nvSpPr>
+          <p:cNvPr id="8" name="">
+            <a:extLst xmlns:a="http://schemas.openxmlformats.org/drawingml/2006/main">
+              <a:ext uri="{FF2B5EF4-FFF2-40B4-BE49-F238E27FC236}">
+                <a16:creationId xmlns:a16="http://schemas.microsoft.com/office/drawing/2014/main" id="{CCB92DC2-C4B1-4C44-B74C-3455A18F2091}"/>
               </a:ext>
             </a:extLst>
           </p:cNvPr>
@@ -16037,7 +16630,18 @@
           <a:bodyPr xmlns:a="http://schemas.openxmlformats.org/drawingml/2006/main">
             <a:noAutofit/>
           </a:bodyPr>
-          <a:lstStyle xmlns:a="http://schemas.openxmlformats.org/drawingml/2006/main"/>
+          <a:lstStyle xmlns:a="http://schemas.openxmlformats.org/drawingml/2006/main">
+            <a:defPPr>
+              <a:defRPr sz="1200" b="0">
+                <a:solidFill>
+                  <a:srgbClr val="5B7177"/>
+                </a:solidFill>
+                <a:latin typeface="Arial"/>
+                <a:ea typeface="Arial"/>
+                <a:cs typeface="Arial"/>
+              </a:defRPr>
+            </a:defPPr>
+          </a:lstStyle>
           <a:p xmlns:a="http://schemas.openxmlformats.org/drawingml/2006/main">
             <a:pPr>
               <a:defRPr sz="1200" b="0">
@@ -16059,189 +16663,6 @@
                 <a:cs typeface="Arial"/>
               </a:rPr>
               <a:t>02  Ilha Solteira</a:t>
-            </a:r>
-          </a:p>
-        </p:txBody>
-      </p:sp>
-      <p:sp>
-        <p:nvSpPr>
-          <p:cNvPr id="3" name="">
-            <a:extLst xmlns:a="http://schemas.openxmlformats.org/drawingml/2006/main">
-              <a:ext uri="{FF2B5EF4-FFF2-40B4-BE49-F238E27FC236}">
-                <a16:creationId xmlns:a16="http://schemas.microsoft.com/office/drawing/2014/main" id="{F2EF3C99-2ACB-4D77-B7BA-138DF48F3075}"/>
-              </a:ext>
-            </a:extLst>
-          </p:cNvPr>
-          <p:cNvSpPr>
-            <a:spLocks xmlns:a="http://schemas.openxmlformats.org/drawingml/2006/main" noGrp="1"/>
-          </p:cNvSpPr>
-          <p:nvPr/>
-        </p:nvSpPr>
-        <p:spPr>
-          <a:xfrm xmlns:a="http://schemas.openxmlformats.org/drawingml/2006/main">
-            <a:off x="666750" y="1809750"/>
-            <a:ext cx="10001250" cy="1428750"/>
-          </a:xfrm>
-          <a:prstGeom xmlns:a="http://schemas.openxmlformats.org/drawingml/2006/main" prst="rect">
-            <a:avLst/>
-          </a:prstGeom>
-          <a:noFill xmlns:a="http://schemas.openxmlformats.org/drawingml/2006/main"/>
-          <a:ln xmlns:a="http://schemas.openxmlformats.org/drawingml/2006/main" w="0">
-            <a:noFill/>
-          </a:ln>
-        </p:spPr>
-        <p:txBody>
-          <a:bodyPr xmlns:a="http://schemas.openxmlformats.org/drawingml/2006/main">
-            <a:noAutofit/>
-          </a:bodyPr>
-          <a:lstStyle xmlns:a="http://schemas.openxmlformats.org/drawingml/2006/main"/>
-          <a:p xmlns:a="http://schemas.openxmlformats.org/drawingml/2006/main">
-            <a:pPr>
-              <a:defRPr sz="3825" b="1">
-                <a:solidFill>
-                  <a:srgbClr val="007F80"/>
-                </a:solidFill>
-                <a:latin typeface="Arial"/>
-                <a:ea typeface="Arial"/>
-                <a:cs typeface="Arial"/>
-              </a:defRPr>
-            </a:pPr>
-            <a:r>
-              <a:rPr sz="3825" b="1">
-                <a:solidFill>
-                  <a:srgbClr val="007F80"/>
-                </a:solidFill>
-                <a:latin typeface="Arial"/>
-                <a:ea typeface="Arial"/>
-                <a:cs typeface="Arial"/>
-              </a:rPr>
-              <a:t>Quanto podemos prever</a:t>
-            </a:r>
-          </a:p>
-          <a:p xmlns:a="http://schemas.openxmlformats.org/drawingml/2006/main">
-            <a:pPr>
-              <a:defRPr sz="3825" b="1">
-                <a:solidFill>
-                  <a:srgbClr val="007F80"/>
-                </a:solidFill>
-                <a:latin typeface="Arial"/>
-                <a:ea typeface="Arial"/>
-                <a:cs typeface="Arial"/>
-              </a:defRPr>
-            </a:pPr>
-            <a:r>
-              <a:rPr sz="3825" b="1">
-                <a:solidFill>
-                  <a:srgbClr val="007F80"/>
-                </a:solidFill>
-                <a:latin typeface="Arial"/>
-                <a:ea typeface="Arial"/>
-                <a:cs typeface="Arial"/>
-              </a:rPr>
-              <a:t>usando o passado?</a:t>
-            </a:r>
-          </a:p>
-        </p:txBody>
-      </p:sp>
-      <p:sp>
-        <p:nvSpPr>
-          <p:cNvPr id="4" name="">
-            <a:extLst xmlns:a="http://schemas.openxmlformats.org/drawingml/2006/main">
-              <a:ext uri="{FF2B5EF4-FFF2-40B4-BE49-F238E27FC236}">
-                <a16:creationId xmlns:a16="http://schemas.microsoft.com/office/drawing/2014/main" id="{A8C9FDBF-04FB-4824-B78A-4012970D06FC}"/>
-              </a:ext>
-            </a:extLst>
-          </p:cNvPr>
-          <p:cNvSpPr>
-            <a:spLocks xmlns:a="http://schemas.openxmlformats.org/drawingml/2006/main" noGrp="1"/>
-          </p:cNvSpPr>
-          <p:nvPr/>
-        </p:nvSpPr>
-        <p:spPr>
-          <a:xfrm xmlns:a="http://schemas.openxmlformats.org/drawingml/2006/main">
-            <a:off x="695325" y="3810000"/>
-            <a:ext cx="10382250" cy="1571625"/>
-          </a:xfrm>
-          <a:prstGeom xmlns:a="http://schemas.openxmlformats.org/drawingml/2006/main" prst="rect">
-            <a:avLst/>
-          </a:prstGeom>
-          <a:noFill xmlns:a="http://schemas.openxmlformats.org/drawingml/2006/main"/>
-          <a:ln xmlns:a="http://schemas.openxmlformats.org/drawingml/2006/main" w="0">
-            <a:noFill/>
-          </a:ln>
-        </p:spPr>
-        <p:txBody>
-          <a:bodyPr xmlns:a="http://schemas.openxmlformats.org/drawingml/2006/main">
-            <a:noAutofit/>
-          </a:bodyPr>
-          <a:lstStyle xmlns:a="http://schemas.openxmlformats.org/drawingml/2006/main"/>
-          <a:p xmlns:a="http://schemas.openxmlformats.org/drawingml/2006/main">
-            <a:pPr>
-              <a:defRPr sz="2250" b="0">
-                <a:solidFill>
-                  <a:srgbClr val="18343E"/>
-                </a:solidFill>
-                <a:latin typeface="Arial"/>
-                <a:ea typeface="Arial"/>
-                <a:cs typeface="Arial"/>
-              </a:defRPr>
-            </a:pPr>
-            <a:r>
-              <a:rPr sz="2250" b="0">
-                <a:solidFill>
-                  <a:srgbClr val="18343E"/>
-                </a:solidFill>
-                <a:latin typeface="Arial"/>
-                <a:ea typeface="Arial"/>
-                <a:cs typeface="Arial"/>
-              </a:rPr>
-              <a:t>Comparação temporal entre modelos</a:t>
-            </a:r>
-          </a:p>
-          <a:p xmlns:a="http://schemas.openxmlformats.org/drawingml/2006/main">
-            <a:pPr>
-              <a:defRPr sz="2250" b="0">
-                <a:solidFill>
-                  <a:srgbClr val="18343E"/>
-                </a:solidFill>
-                <a:latin typeface="Arial"/>
-                <a:ea typeface="Arial"/>
-                <a:cs typeface="Arial"/>
-              </a:defRPr>
-            </a:pPr>
-            <a:r>
-              <a:rPr sz="2250" b="0">
-                <a:solidFill>
-                  <a:srgbClr val="18343E"/>
-                </a:solidFill>
-                <a:latin typeface="Arial"/>
-                <a:ea typeface="Arial"/>
-                <a:cs typeface="Arial"/>
-              </a:rPr>
-              <a:t>Avaliação do erro em meses reservados</a:t>
-            </a:r>
-          </a:p>
-          <a:p xmlns:a="http://schemas.openxmlformats.org/drawingml/2006/main">
-            <a:pPr>
-              <a:defRPr sz="2250" b="0">
-                <a:solidFill>
-                  <a:srgbClr val="18343E"/>
-                </a:solidFill>
-                <a:latin typeface="Arial"/>
-                <a:ea typeface="Arial"/>
-                <a:cs typeface="Arial"/>
-              </a:defRPr>
-            </a:pPr>
-            <a:r>
-              <a:rPr sz="2250" b="0">
-                <a:solidFill>
-                  <a:srgbClr val="18343E"/>
-                </a:solidFill>
-                <a:latin typeface="Arial"/>
-                <a:ea typeface="Arial"/>
-                <a:cs typeface="Arial"/>
-              </a:rPr>
-              <a:t>Incerteza para cada vazão futura</a:t>
             </a:r>
           </a:p>
         </p:txBody>
@@ -16309,6 +16730,7 @@
           <a:lstStyle xmlns:a="http://schemas.openxmlformats.org/drawingml/2006/main"/>
           <a:p xmlns:a="http://schemas.openxmlformats.org/drawingml/2006/main">
             <a:pPr>
+              <a:buNone/>
               <a:defRPr sz="3300" b="1">
                 <a:solidFill>
                   <a:srgbClr val="18343E"/>
@@ -16366,6 +16788,7 @@
           <a:lstStyle xmlns:a="http://schemas.openxmlformats.org/drawingml/2006/main"/>
           <a:p xmlns:a="http://schemas.openxmlformats.org/drawingml/2006/main">
             <a:pPr>
+              <a:buNone/>
               <a:defRPr sz="1200" b="0">
                 <a:solidFill>
                   <a:srgbClr val="5B7177"/>
@@ -16423,6 +16846,7 @@
           <a:lstStyle xmlns:a="http://schemas.openxmlformats.org/drawingml/2006/main"/>
           <a:p xmlns:a="http://schemas.openxmlformats.org/drawingml/2006/main">
             <a:pPr>
+              <a:buNone/>
               <a:defRPr sz="6750" b="1">
                 <a:solidFill>
                   <a:srgbClr val="007F80"/>
@@ -16480,6 +16904,7 @@
           <a:lstStyle xmlns:a="http://schemas.openxmlformats.org/drawingml/2006/main"/>
           <a:p xmlns:a="http://schemas.openxmlformats.org/drawingml/2006/main">
             <a:pPr>
+              <a:buNone/>
               <a:defRPr sz="2325" b="0">
                 <a:solidFill>
                   <a:srgbClr val="18343E"/>
@@ -16503,6 +16928,7 @@
           </a:p>
           <a:p xmlns:a="http://schemas.openxmlformats.org/drawingml/2006/main">
             <a:pPr>
+              <a:buNone/>
               <a:defRPr sz="2325" b="0">
                 <a:solidFill>
                   <a:srgbClr val="18343E"/>
@@ -16560,6 +16986,7 @@
           <a:lstStyle xmlns:a="http://schemas.openxmlformats.org/drawingml/2006/main"/>
           <a:p xmlns:a="http://schemas.openxmlformats.org/drawingml/2006/main">
             <a:pPr>
+              <a:buNone/>
               <a:defRPr sz="2100" b="0">
                 <a:solidFill>
                   <a:srgbClr val="18343E"/>
@@ -16583,6 +17010,7 @@
           </a:p>
           <a:p xmlns:a="http://schemas.openxmlformats.org/drawingml/2006/main">
             <a:pPr>
+              <a:buNone/>
               <a:defRPr sz="2100" b="0">
                 <a:solidFill>
                   <a:srgbClr val="18343E"/>
@@ -16606,6 +17034,7 @@
           </a:p>
           <a:p xmlns:a="http://schemas.openxmlformats.org/drawingml/2006/main">
             <a:pPr>
+              <a:buNone/>
               <a:defRPr sz="2100" b="0">
                 <a:solidFill>
                   <a:srgbClr val="18343E"/>
@@ -16663,6 +17092,7 @@
           <a:lstStyle xmlns:a="http://schemas.openxmlformats.org/drawingml/2006/main"/>
           <a:p xmlns:a="http://schemas.openxmlformats.org/drawingml/2006/main">
             <a:pPr>
+              <a:buNone/>
               <a:defRPr sz="2250" b="1">
                 <a:solidFill>
                   <a:srgbClr val="C48730"/>
@@ -16749,6 +17179,7 @@
           <a:lstStyle xmlns:a="http://schemas.openxmlformats.org/drawingml/2006/main"/>
           <a:p xmlns:a="http://schemas.openxmlformats.org/drawingml/2006/main">
             <a:pPr>
+              <a:buNone/>
               <a:defRPr sz="3300" b="1">
                 <a:solidFill>
                   <a:srgbClr val="18343E"/>
@@ -16806,6 +17237,7 @@
           <a:lstStyle xmlns:a="http://schemas.openxmlformats.org/drawingml/2006/main"/>
           <a:p xmlns:a="http://schemas.openxmlformats.org/drawingml/2006/main">
             <a:pPr>
+              <a:buNone/>
               <a:defRPr sz="1200" b="0">
                 <a:solidFill>
                   <a:srgbClr val="5B7177"/>
@@ -16831,7 +17263,13 @@
       </p:sp>
       <p:graphicFrame>
         <p:nvGraphicFramePr>
-          <p:cNvPr id="7" name="Chart"/>
+          <p:cNvPr id="7" name="Chart">
+            <a:extLst xmlns:a="http://schemas.openxmlformats.org/drawingml/2006/main">
+              <a:ext uri="{FF2B5EF4-FFF2-40B4-BE49-F238E27FC236}">
+                <a16:creationId xmlns:a16="http://schemas.microsoft.com/office/drawing/2014/main" id="{F3652DA4-4476-4B9B-A8E9-B4E46F2909C4}"/>
+              </a:ext>
+            </a:extLst>
+          </p:cNvPr>
           <p:cNvGraphicFramePr/>
           <p:nvPr/>
         </p:nvGraphicFramePr>
@@ -16841,7 +17279,7 @@
         </p:xfrm>
         <a:graphic xmlns:a="http://schemas.openxmlformats.org/drawingml/2006/main">
           <a:graphicData uri="http://schemas.openxmlformats.org/drawingml/2006/chart">
-            <c:chart xmlns:r="http://schemas.openxmlformats.org/officeDocument/2006/relationships" xmlns:c="http://schemas.openxmlformats.org/drawingml/2006/chart" r:id="R4d15504404a94b6e"/>
+            <c:chart xmlns:r="http://schemas.openxmlformats.org/officeDocument/2006/relationships" xmlns:c="http://schemas.openxmlformats.org/drawingml/2006/chart" r:id="Rdcb7a35c315d4d0b"/>
           </a:graphicData>
         </a:graphic>
       </p:graphicFrame>
@@ -16879,6 +17317,7 @@
           <a:lstStyle xmlns:a="http://schemas.openxmlformats.org/drawingml/2006/main"/>
           <a:p xmlns:a="http://schemas.openxmlformats.org/drawingml/2006/main">
             <a:pPr>
+              <a:buNone/>
               <a:defRPr sz="1575" b="0">
                 <a:solidFill>
                   <a:srgbClr val="5B7177"/>
@@ -16913,222 +17352,6 @@
 </file>
 
 <file path=ppt/slides/slide5.xml><?xml version="1.0" encoding="utf-8"?>
-<p:sld xmlns:p="http://schemas.openxmlformats.org/presentationml/2006/main">
-  <p:cSld>
-    <p:bg>
-      <p:bgPr>
-        <a:solidFill xmlns:a="http://schemas.openxmlformats.org/drawingml/2006/main">
-          <a:srgbClr val="F6F3EB"/>
-        </a:solidFill>
-      </p:bgPr>
-    </p:bg>
-    <p:spTree>
-      <p:nvGrpSpPr>
-        <p:cNvPr id="1" name=""/>
-        <p:cNvGrpSpPr/>
-        <p:nvPr/>
-      </p:nvGrpSpPr>
-      <p:grpSpPr>
-        <a:xfrm xmlns:a="http://schemas.openxmlformats.org/drawingml/2006/main"/>
-      </p:grpSpPr>
-      <p:sp>
-        <p:nvSpPr>
-          <p:cNvPr id="5" name="">
-            <a:extLst xmlns:a="http://schemas.openxmlformats.org/drawingml/2006/main">
-              <a:ext uri="{FF2B5EF4-FFF2-40B4-BE49-F238E27FC236}">
-                <a16:creationId xmlns:a16="http://schemas.microsoft.com/office/drawing/2014/main" id="{C65768A5-3492-4AA9-8C7A-7247FD2DFF66}"/>
-              </a:ext>
-            </a:extLst>
-          </p:cNvPr>
-          <p:cNvSpPr>
-            <a:spLocks xmlns:a="http://schemas.openxmlformats.org/drawingml/2006/main" noGrp="1"/>
-          </p:cNvSpPr>
-          <p:nvPr/>
-        </p:nvSpPr>
-        <p:spPr>
-          <a:xfrm xmlns:a="http://schemas.openxmlformats.org/drawingml/2006/main">
-            <a:off x="609600" y="419100"/>
-            <a:ext cx="10934700" cy="952500"/>
-          </a:xfrm>
-          <a:prstGeom xmlns:a="http://schemas.openxmlformats.org/drawingml/2006/main" prst="rect">
-            <a:avLst/>
-          </a:prstGeom>
-          <a:noFill xmlns:a="http://schemas.openxmlformats.org/drawingml/2006/main"/>
-          <a:ln xmlns:a="http://schemas.openxmlformats.org/drawingml/2006/main" w="0">
-            <a:noFill/>
-          </a:ln>
-        </p:spPr>
-        <p:txBody>
-          <a:bodyPr xmlns:a="http://schemas.openxmlformats.org/drawingml/2006/main">
-            <a:noAutofit/>
-          </a:bodyPr>
-          <a:lstStyle xmlns:a="http://schemas.openxmlformats.org/drawingml/2006/main"/>
-          <a:p xmlns:a="http://schemas.openxmlformats.org/drawingml/2006/main">
-            <a:pPr>
-              <a:defRPr sz="3300" b="1">
-                <a:solidFill>
-                  <a:srgbClr val="18343E"/>
-                </a:solidFill>
-                <a:latin typeface="Arial"/>
-                <a:ea typeface="Arial"/>
-                <a:cs typeface="Arial"/>
-              </a:defRPr>
-            </a:pPr>
-            <a:r>
-              <a:rPr sz="3300" b="1">
-                <a:solidFill>
-                  <a:srgbClr val="18343E"/>
-                </a:solidFill>
-                <a:latin typeface="Arial"/>
-                <a:ea typeface="Arial"/>
-                <a:cs typeface="Arial"/>
-              </a:rPr>
-              <a:t>O ciclo anual orienta o período sazonal</a:t>
-            </a:r>
-          </a:p>
-        </p:txBody>
-      </p:sp>
-      <p:sp>
-        <p:nvSpPr>
-          <p:cNvPr id="2" name="">
-            <a:extLst xmlns:a="http://schemas.openxmlformats.org/drawingml/2006/main">
-              <a:ext uri="{FF2B5EF4-FFF2-40B4-BE49-F238E27FC236}">
-                <a16:creationId xmlns:a16="http://schemas.microsoft.com/office/drawing/2014/main" id="{C4E20B18-2105-4259-8EB9-D44E65ACB04D}"/>
-              </a:ext>
-            </a:extLst>
-          </p:cNvPr>
-          <p:cNvSpPr>
-            <a:spLocks xmlns:a="http://schemas.openxmlformats.org/drawingml/2006/main" noGrp="1"/>
-          </p:cNvSpPr>
-          <p:nvPr/>
-        </p:nvSpPr>
-        <p:spPr>
-          <a:xfrm xmlns:a="http://schemas.openxmlformats.org/drawingml/2006/main">
-            <a:off x="609600" y="6400800"/>
-            <a:ext cx="5715000" cy="228600"/>
-          </a:xfrm>
-          <a:prstGeom xmlns:a="http://schemas.openxmlformats.org/drawingml/2006/main" prst="rect">
-            <a:avLst/>
-          </a:prstGeom>
-          <a:noFill xmlns:a="http://schemas.openxmlformats.org/drawingml/2006/main"/>
-          <a:ln xmlns:a="http://schemas.openxmlformats.org/drawingml/2006/main" w="0">
-            <a:noFill/>
-          </a:ln>
-        </p:spPr>
-        <p:txBody>
-          <a:bodyPr xmlns:a="http://schemas.openxmlformats.org/drawingml/2006/main">
-            <a:noAutofit/>
-          </a:bodyPr>
-          <a:lstStyle xmlns:a="http://schemas.openxmlformats.org/drawingml/2006/main"/>
-          <a:p xmlns:a="http://schemas.openxmlformats.org/drawingml/2006/main">
-            <a:pPr>
-              <a:defRPr sz="1200" b="0">
-                <a:solidFill>
-                  <a:srgbClr val="5B7177"/>
-                </a:solidFill>
-                <a:latin typeface="Arial"/>
-                <a:ea typeface="Arial"/>
-                <a:cs typeface="Arial"/>
-              </a:defRPr>
-            </a:pPr>
-            <a:r>
-              <a:rPr sz="1200" b="0">
-                <a:solidFill>
-                  <a:srgbClr val="5B7177"/>
-                </a:solidFill>
-                <a:latin typeface="Arial"/>
-                <a:ea typeface="Arial"/>
-                <a:cs typeface="Arial"/>
-              </a:rPr>
-              <a:t>05  Ilha Solteira</a:t>
-            </a:r>
-          </a:p>
-        </p:txBody>
-      </p:sp>
-      <p:graphicFrame>
-        <p:nvGraphicFramePr>
-          <p:cNvPr id="7" name="Chart"/>
-          <p:cNvGraphicFramePr/>
-          <p:nvPr/>
-        </p:nvGraphicFramePr>
-        <p:xfrm>
-          <a:off xmlns:a="http://schemas.openxmlformats.org/drawingml/2006/main" x="666750" y="1581150"/>
-          <a:ext xmlns:a="http://schemas.openxmlformats.org/drawingml/2006/main" cx="10763250" cy="4048125"/>
-        </p:xfrm>
-        <a:graphic xmlns:a="http://schemas.openxmlformats.org/drawingml/2006/main">
-          <a:graphicData uri="http://schemas.openxmlformats.org/drawingml/2006/chart">
-            <c:chart xmlns:r="http://schemas.openxmlformats.org/officeDocument/2006/relationships" xmlns:c="http://schemas.openxmlformats.org/drawingml/2006/chart" r:id="R689592f034054a3a"/>
-          </a:graphicData>
-        </a:graphic>
-      </p:graphicFrame>
-      <p:sp>
-        <p:nvSpPr>
-          <p:cNvPr id="4" name="">
-            <a:extLst xmlns:a="http://schemas.openxmlformats.org/drawingml/2006/main">
-              <a:ext uri="{FF2B5EF4-FFF2-40B4-BE49-F238E27FC236}">
-                <a16:creationId xmlns:a16="http://schemas.microsoft.com/office/drawing/2014/main" id="{DF099168-9A55-41BD-9D0B-20EB68E7A1DE}"/>
-              </a:ext>
-            </a:extLst>
-          </p:cNvPr>
-          <p:cNvSpPr>
-            <a:spLocks xmlns:a="http://schemas.openxmlformats.org/drawingml/2006/main" noGrp="1"/>
-          </p:cNvSpPr>
-          <p:nvPr/>
-        </p:nvSpPr>
-        <p:spPr>
-          <a:xfrm xmlns:a="http://schemas.openxmlformats.org/drawingml/2006/main">
-            <a:off x="666750" y="5810250"/>
-            <a:ext cx="10763250" cy="504825"/>
-          </a:xfrm>
-          <a:prstGeom xmlns:a="http://schemas.openxmlformats.org/drawingml/2006/main" prst="rect">
-            <a:avLst/>
-          </a:prstGeom>
-          <a:noFill xmlns:a="http://schemas.openxmlformats.org/drawingml/2006/main"/>
-          <a:ln xmlns:a="http://schemas.openxmlformats.org/drawingml/2006/main" w="0">
-            <a:noFill/>
-          </a:ln>
-        </p:spPr>
-        <p:txBody>
-          <a:bodyPr xmlns:a="http://schemas.openxmlformats.org/drawingml/2006/main">
-            <a:noAutofit/>
-          </a:bodyPr>
-          <a:lstStyle xmlns:a="http://schemas.openxmlformats.org/drawingml/2006/main"/>
-          <a:p xmlns:a="http://schemas.openxmlformats.org/drawingml/2006/main">
-            <a:pPr>
-              <a:defRPr sz="1575" b="0">
-                <a:solidFill>
-                  <a:srgbClr val="5B7177"/>
-                </a:solidFill>
-                <a:latin typeface="Arial"/>
-                <a:ea typeface="Arial"/>
-                <a:cs typeface="Arial"/>
-              </a:defRPr>
-            </a:pPr>
-            <a:r>
-              <a:rPr sz="1575" b="0">
-                <a:solidFill>
-                  <a:srgbClr val="5B7177"/>
-                </a:solidFill>
-                <a:latin typeface="Arial"/>
-                <a:ea typeface="Arial"/>
-                <a:cs typeface="Arial"/>
-              </a:rPr>
-              <a:t>Média por mês em 1931–2016. Período sazonal: 12 meses. Unidade da tabela.</a:t>
-            </a:r>
-          </a:p>
-        </p:txBody>
-      </p:sp>
-    </p:spTree>
-    <p:extLst>
-      <p:ext uri="{BB962C8B-B14F-4D97-AF65-F5344CB8AC3E}">
-        <p14:creationId xmlns:p14="http://schemas.microsoft.com/office/powerpoint/2010/main" val="1893046111"/>
-      </p:ext>
-    </p:extLst>
-  </p:cSld>
-</p:sld>
-</file>
-
-<file path=ppt/slides/slide6.xml><?xml version="1.0" encoding="utf-8"?>
 <p:sld xmlns:p="http://schemas.openxmlformats.org/presentationml/2006/main">
   <p:cSld>
     <p:bg>
@@ -17181,6 +17404,7 @@
           <a:lstStyle xmlns:a="http://schemas.openxmlformats.org/drawingml/2006/main"/>
           <a:p xmlns:a="http://schemas.openxmlformats.org/drawingml/2006/main">
             <a:pPr>
+              <a:buNone/>
               <a:defRPr sz="3300" b="1">
                 <a:solidFill>
                   <a:srgbClr val="18343E"/>
@@ -17238,6 +17462,7 @@
           <a:lstStyle xmlns:a="http://schemas.openxmlformats.org/drawingml/2006/main"/>
           <a:p xmlns:a="http://schemas.openxmlformats.org/drawingml/2006/main">
             <a:pPr>
+              <a:buNone/>
               <a:defRPr sz="1200" b="0">
                 <a:solidFill>
                   <a:srgbClr val="5B7177"/>
@@ -17256,7 +17481,7 @@
                 <a:ea typeface="Arial"/>
                 <a:cs typeface="Arial"/>
               </a:rPr>
-              <a:t>06  Ilha Solteira</a:t>
+              <a:t>05  Ilha Solteira</a:t>
             </a:r>
           </a:p>
         </p:txBody>
@@ -17295,6 +17520,7 @@
           <a:lstStyle xmlns:a="http://schemas.openxmlformats.org/drawingml/2006/main"/>
           <a:p xmlns:a="http://schemas.openxmlformats.org/drawingml/2006/main">
             <a:pPr>
+              <a:buNone/>
               <a:defRPr sz="3300" b="1">
                 <a:solidFill>
                   <a:srgbClr val="007F80"/>
@@ -17352,6 +17578,7 @@
           <a:lstStyle xmlns:a="http://schemas.openxmlformats.org/drawingml/2006/main"/>
           <a:p xmlns:a="http://schemas.openxmlformats.org/drawingml/2006/main">
             <a:pPr>
+              <a:buNone/>
               <a:defRPr sz="2175" b="0">
                 <a:solidFill>
                   <a:srgbClr val="18343E"/>
@@ -17409,6 +17636,7 @@
           <a:lstStyle xmlns:a="http://schemas.openxmlformats.org/drawingml/2006/main"/>
           <a:p xmlns:a="http://schemas.openxmlformats.org/drawingml/2006/main">
             <a:pPr>
+              <a:buNone/>
               <a:defRPr sz="3300" b="1">
                 <a:solidFill>
                   <a:srgbClr val="007F80"/>
@@ -17466,6 +17694,7 @@
           <a:lstStyle xmlns:a="http://schemas.openxmlformats.org/drawingml/2006/main"/>
           <a:p xmlns:a="http://schemas.openxmlformats.org/drawingml/2006/main">
             <a:pPr>
+              <a:buNone/>
               <a:defRPr sz="2175" b="0">
                 <a:solidFill>
                   <a:srgbClr val="18343E"/>
@@ -17489,6 +17718,7 @@
           </a:p>
           <a:p xmlns:a="http://schemas.openxmlformats.org/drawingml/2006/main">
             <a:pPr>
+              <a:buNone/>
               <a:defRPr sz="2175" b="0">
                 <a:solidFill>
                   <a:srgbClr val="18343E"/>
@@ -17546,6 +17776,7 @@
           <a:lstStyle xmlns:a="http://schemas.openxmlformats.org/drawingml/2006/main"/>
           <a:p xmlns:a="http://schemas.openxmlformats.org/drawingml/2006/main">
             <a:pPr>
+              <a:buNone/>
               <a:defRPr sz="3300" b="1">
                 <a:solidFill>
                   <a:srgbClr val="C48730"/>
@@ -17603,6 +17834,7 @@
           <a:lstStyle xmlns:a="http://schemas.openxmlformats.org/drawingml/2006/main"/>
           <a:p xmlns:a="http://schemas.openxmlformats.org/drawingml/2006/main">
             <a:pPr>
+              <a:buNone/>
               <a:defRPr sz="2175" b="0">
                 <a:solidFill>
                   <a:srgbClr val="18343E"/>
@@ -17626,6 +17858,7 @@
           </a:p>
           <a:p xmlns:a="http://schemas.openxmlformats.org/drawingml/2006/main">
             <a:pPr>
+              <a:buNone/>
               <a:defRPr sz="2175" b="0">
                 <a:solidFill>
                   <a:srgbClr val="18343E"/>
@@ -17659,7 +17892,7 @@
 </p:sld>
 </file>
 
-<file path=ppt/slides/slide7.xml><?xml version="1.0" encoding="utf-8"?>
+<file path=ppt/slides/slide6.xml><?xml version="1.0" encoding="utf-8"?>
 <p:sld xmlns:p="http://schemas.openxmlformats.org/presentationml/2006/main">
   <p:cSld>
     <p:bg>
@@ -17712,6 +17945,7 @@
           <a:lstStyle xmlns:a="http://schemas.openxmlformats.org/drawingml/2006/main"/>
           <a:p xmlns:a="http://schemas.openxmlformats.org/drawingml/2006/main">
             <a:pPr>
+              <a:buNone/>
               <a:defRPr sz="3300" b="1">
                 <a:solidFill>
                   <a:srgbClr val="18343E"/>
@@ -17769,6 +18003,7 @@
           <a:lstStyle xmlns:a="http://schemas.openxmlformats.org/drawingml/2006/main"/>
           <a:p xmlns:a="http://schemas.openxmlformats.org/drawingml/2006/main">
             <a:pPr>
+              <a:buNone/>
               <a:defRPr sz="1200" b="0">
                 <a:solidFill>
                   <a:srgbClr val="5B7177"/>
@@ -17787,7 +18022,7 @@
                 <a:ea typeface="Arial"/>
                 <a:cs typeface="Arial"/>
               </a:rPr>
-              <a:t>07  Ilha Solteira</a:t>
+              <a:t>06  Ilha Solteira</a:t>
             </a:r>
           </a:p>
         </p:txBody>
@@ -17826,6 +18061,7 @@
           <a:lstStyle xmlns:a="http://schemas.openxmlformats.org/drawingml/2006/main"/>
           <a:p xmlns:a="http://schemas.openxmlformats.org/drawingml/2006/main">
             <a:pPr>
+              <a:buNone/>
               <a:defRPr sz="3600" b="1">
                 <a:solidFill>
                   <a:srgbClr val="007F80"/>
@@ -17883,6 +18119,7 @@
           <a:lstStyle xmlns:a="http://schemas.openxmlformats.org/drawingml/2006/main"/>
           <a:p xmlns:a="http://schemas.openxmlformats.org/drawingml/2006/main">
             <a:pPr>
+              <a:buNone/>
               <a:defRPr sz="2400" b="0">
                 <a:solidFill>
                   <a:srgbClr val="18343E"/>
@@ -17940,6 +18177,7 @@
           <a:lstStyle xmlns:a="http://schemas.openxmlformats.org/drawingml/2006/main"/>
           <a:p xmlns:a="http://schemas.openxmlformats.org/drawingml/2006/main">
             <a:pPr>
+              <a:buNone/>
               <a:defRPr sz="3300" b="1">
                 <a:solidFill>
                   <a:srgbClr val="C48730"/>
@@ -17997,6 +18235,7 @@
           <a:lstStyle xmlns:a="http://schemas.openxmlformats.org/drawingml/2006/main"/>
           <a:p xmlns:a="http://schemas.openxmlformats.org/drawingml/2006/main">
             <a:pPr>
+              <a:buNone/>
               <a:defRPr sz="2400" b="0">
                 <a:solidFill>
                   <a:srgbClr val="18343E"/>
@@ -18030,7 +18269,7 @@
 </p:sld>
 </file>
 
-<file path=ppt/slides/slide8.xml><?xml version="1.0" encoding="utf-8"?>
+<file path=ppt/slides/slide7.xml><?xml version="1.0" encoding="utf-8"?>
 <p:sld xmlns:p="http://schemas.openxmlformats.org/presentationml/2006/main">
   <p:cSld>
     <p:bg>
@@ -18083,6 +18322,7 @@
           <a:lstStyle xmlns:a="http://schemas.openxmlformats.org/drawingml/2006/main"/>
           <a:p xmlns:a="http://schemas.openxmlformats.org/drawingml/2006/main">
             <a:pPr>
+              <a:buNone/>
               <a:defRPr sz="3300" b="1">
                 <a:solidFill>
                   <a:srgbClr val="18343E"/>
@@ -18140,6 +18380,7 @@
           <a:lstStyle xmlns:a="http://schemas.openxmlformats.org/drawingml/2006/main"/>
           <a:p xmlns:a="http://schemas.openxmlformats.org/drawingml/2006/main">
             <a:pPr>
+              <a:buNone/>
               <a:defRPr sz="1200" b="0">
                 <a:solidFill>
                   <a:srgbClr val="5B7177"/>
@@ -18158,7 +18399,7 @@
                 <a:ea typeface="Arial"/>
                 <a:cs typeface="Arial"/>
               </a:rPr>
-              <a:t>08  Ilha Solteira</a:t>
+              <a:t>07  Ilha Solteira</a:t>
             </a:r>
           </a:p>
         </p:txBody>
@@ -18197,6 +18438,7 @@
           <a:lstStyle xmlns:a="http://schemas.openxmlformats.org/drawingml/2006/main"/>
           <a:p xmlns:a="http://schemas.openxmlformats.org/drawingml/2006/main">
             <a:pPr>
+              <a:buNone/>
               <a:defRPr sz="3600" b="1">
                 <a:solidFill>
                   <a:srgbClr val="007F80"/>
@@ -18254,6 +18496,7 @@
           <a:lstStyle xmlns:a="http://schemas.openxmlformats.org/drawingml/2006/main"/>
           <a:p xmlns:a="http://schemas.openxmlformats.org/drawingml/2006/main">
             <a:pPr>
+              <a:buNone/>
               <a:defRPr sz="2625" b="0">
                 <a:solidFill>
                   <a:srgbClr val="18343E"/>
@@ -18277,6 +18520,7 @@
           </a:p>
           <a:p xmlns:a="http://schemas.openxmlformats.org/drawingml/2006/main">
             <a:pPr>
+              <a:buNone/>
               <a:defRPr sz="2625" b="0">
                 <a:solidFill>
                   <a:srgbClr val="18343E"/>
@@ -18334,6 +18578,7 @@
           <a:lstStyle xmlns:a="http://schemas.openxmlformats.org/drawingml/2006/main"/>
           <a:p xmlns:a="http://schemas.openxmlformats.org/drawingml/2006/main">
             <a:pPr>
+              <a:buNone/>
               <a:defRPr sz="2325" b="1">
                 <a:solidFill>
                   <a:srgbClr val="C48730"/>
@@ -18357,6 +18602,7 @@
           </a:p>
           <a:p xmlns:a="http://schemas.openxmlformats.org/drawingml/2006/main">
             <a:pPr>
+              <a:buNone/>
               <a:defRPr sz="2325" b="1">
                 <a:solidFill>
                   <a:srgbClr val="C48730"/>
@@ -18390,7 +18636,7 @@
 </p:sld>
 </file>
 
-<file path=ppt/slides/slide9.xml><?xml version="1.0" encoding="utf-8"?>
+<file path=ppt/slides/slide8.xml><?xml version="1.0" encoding="utf-8"?>
 <p:sld xmlns:p="http://schemas.openxmlformats.org/presentationml/2006/main">
   <p:cSld>
     <p:bg>
@@ -18443,6 +18689,7 @@
           <a:lstStyle xmlns:a="http://schemas.openxmlformats.org/drawingml/2006/main"/>
           <a:p xmlns:a="http://schemas.openxmlformats.org/drawingml/2006/main">
             <a:pPr>
+              <a:buNone/>
               <a:defRPr sz="3300" b="1">
                 <a:solidFill>
                   <a:srgbClr val="18343E"/>
@@ -18500,6 +18747,7 @@
           <a:lstStyle xmlns:a="http://schemas.openxmlformats.org/drawingml/2006/main"/>
           <a:p xmlns:a="http://schemas.openxmlformats.org/drawingml/2006/main">
             <a:pPr>
+              <a:buNone/>
               <a:defRPr sz="1200" b="0">
                 <a:solidFill>
                   <a:srgbClr val="5B7177"/>
@@ -18518,7 +18766,7 @@
                 <a:ea typeface="Arial"/>
                 <a:cs typeface="Arial"/>
               </a:rPr>
-              <a:t>09  Ilha Solteira</a:t>
+              <a:t>08  Ilha Solteira</a:t>
             </a:r>
           </a:p>
         </p:txBody>
@@ -18557,6 +18805,7 @@
           <a:lstStyle xmlns:a="http://schemas.openxmlformats.org/drawingml/2006/main"/>
           <a:p xmlns:a="http://schemas.openxmlformats.org/drawingml/2006/main">
             <a:pPr>
+              <a:buNone/>
               <a:defRPr sz="3300" b="1">
                 <a:solidFill>
                   <a:srgbClr val="007F80"/>
@@ -18614,6 +18863,7 @@
           <a:lstStyle xmlns:a="http://schemas.openxmlformats.org/drawingml/2006/main"/>
           <a:p xmlns:a="http://schemas.openxmlformats.org/drawingml/2006/main">
             <a:pPr>
+              <a:buNone/>
               <a:defRPr sz="2250" b="0">
                 <a:solidFill>
                   <a:srgbClr val="18343E"/>
@@ -18671,6 +18921,7 @@
           <a:lstStyle xmlns:a="http://schemas.openxmlformats.org/drawingml/2006/main"/>
           <a:p xmlns:a="http://schemas.openxmlformats.org/drawingml/2006/main">
             <a:pPr>
+              <a:buNone/>
               <a:defRPr sz="3150" b="1">
                 <a:solidFill>
                   <a:srgbClr val="C48730"/>
@@ -18728,6 +18979,7 @@
           <a:lstStyle xmlns:a="http://schemas.openxmlformats.org/drawingml/2006/main"/>
           <a:p xmlns:a="http://schemas.openxmlformats.org/drawingml/2006/main">
             <a:pPr>
+              <a:buNone/>
               <a:defRPr sz="2250" b="0">
                 <a:solidFill>
                   <a:srgbClr val="18343E"/>
@@ -18755,6 +19007,231 @@
     <p:extLst>
       <p:ext uri="{BB962C8B-B14F-4D97-AF65-F5344CB8AC3E}">
         <p14:creationId xmlns:p14="http://schemas.microsoft.com/office/powerpoint/2010/main" val="2103980114"/>
+      </p:ext>
+    </p:extLst>
+  </p:cSld>
+</p:sld>
+</file>
+
+<file path=ppt/slides/slide9.xml><?xml version="1.0" encoding="utf-8"?>
+<p:sld xmlns:p="http://schemas.openxmlformats.org/presentationml/2006/main">
+  <p:cSld>
+    <p:bg>
+      <p:bgPr>
+        <a:solidFill xmlns:a="http://schemas.openxmlformats.org/drawingml/2006/main">
+          <a:srgbClr val="F6F3EB"/>
+        </a:solidFill>
+      </p:bgPr>
+    </p:bg>
+    <p:spTree>
+      <p:nvGrpSpPr>
+        <p:cNvPr id="1" name=""/>
+        <p:cNvGrpSpPr/>
+        <p:nvPr/>
+      </p:nvGrpSpPr>
+      <p:grpSpPr>
+        <a:xfrm xmlns:a="http://schemas.openxmlformats.org/drawingml/2006/main"/>
+      </p:grpSpPr>
+      <p:sp>
+        <p:nvSpPr>
+          <p:cNvPr id="5" name="">
+            <a:extLst xmlns:a="http://schemas.openxmlformats.org/drawingml/2006/main">
+              <a:ext uri="{FF2B5EF4-FFF2-40B4-BE49-F238E27FC236}">
+                <a16:creationId xmlns:a16="http://schemas.microsoft.com/office/drawing/2014/main" id="{E288CB17-6EB2-4119-BBC2-91FB79972D74}"/>
+              </a:ext>
+            </a:extLst>
+          </p:cNvPr>
+          <p:cNvSpPr>
+            <a:spLocks xmlns:a="http://schemas.openxmlformats.org/drawingml/2006/main" noGrp="1"/>
+          </p:cNvSpPr>
+          <p:nvPr/>
+        </p:nvSpPr>
+        <p:spPr>
+          <a:xfrm xmlns:a="http://schemas.openxmlformats.org/drawingml/2006/main">
+            <a:off x="609600" y="419100"/>
+            <a:ext cx="10934700" cy="952500"/>
+          </a:xfrm>
+          <a:prstGeom xmlns:a="http://schemas.openxmlformats.org/drawingml/2006/main" prst="rect">
+            <a:avLst/>
+          </a:prstGeom>
+          <a:noFill xmlns:a="http://schemas.openxmlformats.org/drawingml/2006/main"/>
+          <a:ln xmlns:a="http://schemas.openxmlformats.org/drawingml/2006/main" w="0">
+            <a:noFill/>
+          </a:ln>
+        </p:spPr>
+        <p:txBody>
+          <a:bodyPr xmlns:a="http://schemas.openxmlformats.org/drawingml/2006/main">
+            <a:noAutofit/>
+          </a:bodyPr>
+          <a:lstStyle xmlns:a="http://schemas.openxmlformats.org/drawingml/2006/main"/>
+          <a:p xmlns:a="http://schemas.openxmlformats.org/drawingml/2006/main">
+            <a:pPr>
+              <a:buNone/>
+              <a:defRPr sz="3300" b="1">
+                <a:solidFill>
+                  <a:srgbClr val="18343E"/>
+                </a:solidFill>
+                <a:latin typeface="Arial"/>
+                <a:ea typeface="Arial"/>
+                <a:cs typeface="Arial"/>
+              </a:defRPr>
+            </a:pPr>
+            <a:r>
+              <a:rPr sz="3300" b="1">
+                <a:solidFill>
+                  <a:srgbClr val="18343E"/>
+                </a:solidFill>
+                <a:latin typeface="Arial"/>
+                <a:ea typeface="Arial"/>
+                <a:cs typeface="Arial"/>
+              </a:rPr>
+              <a:t>O ingênuo sazonal tem o menor erro no teste</a:t>
+            </a:r>
+          </a:p>
+        </p:txBody>
+      </p:sp>
+      <p:sp>
+        <p:nvSpPr>
+          <p:cNvPr id="2" name="">
+            <a:extLst xmlns:a="http://schemas.openxmlformats.org/drawingml/2006/main">
+              <a:ext uri="{FF2B5EF4-FFF2-40B4-BE49-F238E27FC236}">
+                <a16:creationId xmlns:a16="http://schemas.microsoft.com/office/drawing/2014/main" id="{FC92EB08-8AD3-4627-87E0-5A23F33CFDCA}"/>
+              </a:ext>
+            </a:extLst>
+          </p:cNvPr>
+          <p:cNvSpPr>
+            <a:spLocks xmlns:a="http://schemas.openxmlformats.org/drawingml/2006/main" noGrp="1"/>
+          </p:cNvSpPr>
+          <p:nvPr/>
+        </p:nvSpPr>
+        <p:spPr>
+          <a:xfrm xmlns:a="http://schemas.openxmlformats.org/drawingml/2006/main">
+            <a:off x="609600" y="6400800"/>
+            <a:ext cx="5715000" cy="228600"/>
+          </a:xfrm>
+          <a:prstGeom xmlns:a="http://schemas.openxmlformats.org/drawingml/2006/main" prst="rect">
+            <a:avLst/>
+          </a:prstGeom>
+          <a:noFill xmlns:a="http://schemas.openxmlformats.org/drawingml/2006/main"/>
+          <a:ln xmlns:a="http://schemas.openxmlformats.org/drawingml/2006/main" w="0">
+            <a:noFill/>
+          </a:ln>
+        </p:spPr>
+        <p:txBody>
+          <a:bodyPr xmlns:a="http://schemas.openxmlformats.org/drawingml/2006/main">
+            <a:noAutofit/>
+          </a:bodyPr>
+          <a:lstStyle xmlns:a="http://schemas.openxmlformats.org/drawingml/2006/main"/>
+          <a:p xmlns:a="http://schemas.openxmlformats.org/drawingml/2006/main">
+            <a:pPr>
+              <a:buNone/>
+              <a:defRPr sz="1200" b="0">
+                <a:solidFill>
+                  <a:srgbClr val="5B7177"/>
+                </a:solidFill>
+                <a:latin typeface="Arial"/>
+                <a:ea typeface="Arial"/>
+                <a:cs typeface="Arial"/>
+              </a:defRPr>
+            </a:pPr>
+            <a:r>
+              <a:rPr sz="1200" b="0">
+                <a:solidFill>
+                  <a:srgbClr val="5B7177"/>
+                </a:solidFill>
+                <a:latin typeface="Arial"/>
+                <a:ea typeface="Arial"/>
+                <a:cs typeface="Arial"/>
+              </a:rPr>
+              <a:t>09  Ilha Solteira</a:t>
+            </a:r>
+          </a:p>
+        </p:txBody>
+      </p:sp>
+      <p:graphicFrame>
+        <p:nvGraphicFramePr>
+          <p:cNvPr id="7" name="Chart">
+            <a:extLst xmlns:a="http://schemas.openxmlformats.org/drawingml/2006/main">
+              <a:ext uri="{FF2B5EF4-FFF2-40B4-BE49-F238E27FC236}">
+                <a16:creationId xmlns:a16="http://schemas.microsoft.com/office/drawing/2014/main" id="{AC7C278B-65B1-47D0-B867-A95640FF6D78}"/>
+              </a:ext>
+            </a:extLst>
+          </p:cNvPr>
+          <p:cNvGraphicFramePr/>
+          <p:nvPr/>
+        </p:nvGraphicFramePr>
+        <p:xfrm>
+          <a:off xmlns:a="http://schemas.openxmlformats.org/drawingml/2006/main" x="666750" y="1581150"/>
+          <a:ext xmlns:a="http://schemas.openxmlformats.org/drawingml/2006/main" cx="10763250" cy="4048125"/>
+        </p:xfrm>
+        <a:graphic xmlns:a="http://schemas.openxmlformats.org/drawingml/2006/main">
+          <a:graphicData uri="http://schemas.openxmlformats.org/drawingml/2006/chart">
+            <c:chart xmlns:r="http://schemas.openxmlformats.org/officeDocument/2006/relationships" xmlns:c="http://schemas.openxmlformats.org/drawingml/2006/chart" r:id="R7b48a04cae7b4570"/>
+          </a:graphicData>
+        </a:graphic>
+      </p:graphicFrame>
+      <p:sp>
+        <p:nvSpPr>
+          <p:cNvPr id="4" name="">
+            <a:extLst xmlns:a="http://schemas.openxmlformats.org/drawingml/2006/main">
+              <a:ext uri="{FF2B5EF4-FFF2-40B4-BE49-F238E27FC236}">
+                <a16:creationId xmlns:a16="http://schemas.microsoft.com/office/drawing/2014/main" id="{3D87A019-4074-4907-BE49-AAF115B7F5A7}"/>
+              </a:ext>
+            </a:extLst>
+          </p:cNvPr>
+          <p:cNvSpPr>
+            <a:spLocks xmlns:a="http://schemas.openxmlformats.org/drawingml/2006/main" noGrp="1"/>
+          </p:cNvSpPr>
+          <p:nvPr/>
+        </p:nvSpPr>
+        <p:spPr>
+          <a:xfrm xmlns:a="http://schemas.openxmlformats.org/drawingml/2006/main">
+            <a:off x="666750" y="5810250"/>
+            <a:ext cx="10763250" cy="504825"/>
+          </a:xfrm>
+          <a:prstGeom xmlns:a="http://schemas.openxmlformats.org/drawingml/2006/main" prst="rect">
+            <a:avLst/>
+          </a:prstGeom>
+          <a:noFill xmlns:a="http://schemas.openxmlformats.org/drawingml/2006/main"/>
+          <a:ln xmlns:a="http://schemas.openxmlformats.org/drawingml/2006/main" w="0">
+            <a:noFill/>
+          </a:ln>
+        </p:spPr>
+        <p:txBody>
+          <a:bodyPr xmlns:a="http://schemas.openxmlformats.org/drawingml/2006/main">
+            <a:noAutofit/>
+          </a:bodyPr>
+          <a:lstStyle xmlns:a="http://schemas.openxmlformats.org/drawingml/2006/main"/>
+          <a:p xmlns:a="http://schemas.openxmlformats.org/drawingml/2006/main">
+            <a:pPr>
+              <a:buNone/>
+              <a:defRPr sz="1575" b="0">
+                <a:solidFill>
+                  <a:srgbClr val="5B7177"/>
+                </a:solidFill>
+                <a:latin typeface="Arial"/>
+                <a:ea typeface="Arial"/>
+                <a:cs typeface="Arial"/>
+              </a:defRPr>
+            </a:pPr>
+            <a:r>
+              <a:rPr sz="1575" b="0">
+                <a:solidFill>
+                  <a:srgbClr val="5B7177"/>
+                </a:solidFill>
+                <a:latin typeface="Arial"/>
+                <a:ea typeface="Arial"/>
+                <a:cs typeface="Arial"/>
+              </a:rPr>
+              <a:t>2014–2016, origem dez/2013. RMSE na unidade da tabela. Menor é melhor.</a:t>
+            </a:r>
+          </a:p>
+        </p:txBody>
+      </p:sp>
+    </p:spTree>
+    <p:extLst>
+      <p:ext uri="{BB962C8B-B14F-4D97-AF65-F5344CB8AC3E}">
+        <p14:creationId xmlns:p14="http://schemas.microsoft.com/office/powerpoint/2010/main" val="769877386"/>
       </p:ext>
     </p:extLst>
   </p:cSld>

</xml_diff>

<commit_message>
Redesenha o slide da base com painel visual e estatísticas
</commit_message>
<xml_diff>
--- a/output/apresentacao_ilha_solteira.pptx
+++ b/output/apresentacao_ilha_solteira.pptx
@@ -2,29 +2,29 @@
 <file path=ppt/presentation.xml><?xml version="1.0" encoding="utf-8"?>
 <p:presentation xmlns:p="http://schemas.openxmlformats.org/presentationml/2006/main">
   <p:sldMasterIdLst>
-    <p:sldMasterId xmlns:r="http://schemas.openxmlformats.org/officeDocument/2006/relationships" id="2147483648" r:id="R43051ef24ee240c9"/>
+    <p:sldMasterId xmlns:r="http://schemas.openxmlformats.org/officeDocument/2006/relationships" id="2147483648" r:id="R6bb21fe90a854a95"/>
   </p:sldMasterIdLst>
   <p:notesMasterIdLst>
-    <p:notesMasterId xmlns:r="http://schemas.openxmlformats.org/officeDocument/2006/relationships" r:id="R72721b50d272450b"/>
+    <p:notesMasterId xmlns:r="http://schemas.openxmlformats.org/officeDocument/2006/relationships" r:id="R50431d937292452a"/>
   </p:notesMasterIdLst>
   <p:sldIdLst>
-    <p:sldId xmlns:r="http://schemas.openxmlformats.org/officeDocument/2006/relationships" id="256" r:id="Rf9fe43a5f6b54741"/>
-    <p:sldId xmlns:r="http://schemas.openxmlformats.org/officeDocument/2006/relationships" id="257" r:id="R1b19fd7f7ba84d65"/>
-    <p:sldId xmlns:r="http://schemas.openxmlformats.org/officeDocument/2006/relationships" id="258" r:id="Rc49baf8f89b14c80"/>
-    <p:sldId xmlns:r="http://schemas.openxmlformats.org/officeDocument/2006/relationships" id="259" r:id="Rcb0329d5d04c4865"/>
-    <p:sldId xmlns:r="http://schemas.openxmlformats.org/officeDocument/2006/relationships" id="260" r:id="Rf127d7c8191d446e"/>
-    <p:sldId xmlns:r="http://schemas.openxmlformats.org/officeDocument/2006/relationships" id="261" r:id="R9aa3df235b6a4b25"/>
-    <p:sldId xmlns:r="http://schemas.openxmlformats.org/officeDocument/2006/relationships" id="262" r:id="R65666869868b45d4"/>
-    <p:sldId xmlns:r="http://schemas.openxmlformats.org/officeDocument/2006/relationships" id="263" r:id="R5a9eb8935ea94fd5"/>
-    <p:sldId xmlns:r="http://schemas.openxmlformats.org/officeDocument/2006/relationships" id="264" r:id="Rc03c4d052dd245d5"/>
-    <p:sldId xmlns:r="http://schemas.openxmlformats.org/officeDocument/2006/relationships" id="265" r:id="Ra71a32a14a3140d2"/>
-    <p:sldId xmlns:r="http://schemas.openxmlformats.org/officeDocument/2006/relationships" id="266" r:id="R075715af4ad743c8"/>
-    <p:sldId xmlns:r="http://schemas.openxmlformats.org/officeDocument/2006/relationships" id="267" r:id="Rcdcb1fe0293d4a6a"/>
-    <p:sldId xmlns:r="http://schemas.openxmlformats.org/officeDocument/2006/relationships" id="268" r:id="R8c147b3119064e41"/>
-    <p:sldId xmlns:r="http://schemas.openxmlformats.org/officeDocument/2006/relationships" id="269" r:id="Rc30d3a850b3a4554"/>
-    <p:sldId xmlns:r="http://schemas.openxmlformats.org/officeDocument/2006/relationships" id="270" r:id="R04d84f0889574b8d"/>
-    <p:sldId xmlns:r="http://schemas.openxmlformats.org/officeDocument/2006/relationships" id="271" r:id="Redaadac3d5534246"/>
-    <p:sldId xmlns:r="http://schemas.openxmlformats.org/officeDocument/2006/relationships" id="272" r:id="Rcabd4a7291664b5b"/>
+    <p:sldId xmlns:r="http://schemas.openxmlformats.org/officeDocument/2006/relationships" id="256" r:id="R67f72210d24741e1"/>
+    <p:sldId xmlns:r="http://schemas.openxmlformats.org/officeDocument/2006/relationships" id="257" r:id="R3b7d19f6529f4e38"/>
+    <p:sldId xmlns:r="http://schemas.openxmlformats.org/officeDocument/2006/relationships" id="258" r:id="R8260761e44b74dd1"/>
+    <p:sldId xmlns:r="http://schemas.openxmlformats.org/officeDocument/2006/relationships" id="259" r:id="R8b0c3dc94c774805"/>
+    <p:sldId xmlns:r="http://schemas.openxmlformats.org/officeDocument/2006/relationships" id="260" r:id="R8ad31efb3b894c38"/>
+    <p:sldId xmlns:r="http://schemas.openxmlformats.org/officeDocument/2006/relationships" id="261" r:id="R87345a2863954f49"/>
+    <p:sldId xmlns:r="http://schemas.openxmlformats.org/officeDocument/2006/relationships" id="262" r:id="Rfd23e276455c4e67"/>
+    <p:sldId xmlns:r="http://schemas.openxmlformats.org/officeDocument/2006/relationships" id="263" r:id="R45245bc7d47f49a2"/>
+    <p:sldId xmlns:r="http://schemas.openxmlformats.org/officeDocument/2006/relationships" id="264" r:id="R6cc7206c17a64da9"/>
+    <p:sldId xmlns:r="http://schemas.openxmlformats.org/officeDocument/2006/relationships" id="265" r:id="R6bd9aa5cbedc491c"/>
+    <p:sldId xmlns:r="http://schemas.openxmlformats.org/officeDocument/2006/relationships" id="266" r:id="Rd0ac46c22c2e4cef"/>
+    <p:sldId xmlns:r="http://schemas.openxmlformats.org/officeDocument/2006/relationships" id="267" r:id="Ra5dac21bb78442a0"/>
+    <p:sldId xmlns:r="http://schemas.openxmlformats.org/officeDocument/2006/relationships" id="268" r:id="Rde3e2aaa2d0d4888"/>
+    <p:sldId xmlns:r="http://schemas.openxmlformats.org/officeDocument/2006/relationships" id="269" r:id="Rcd649e13c1684962"/>
+    <p:sldId xmlns:r="http://schemas.openxmlformats.org/officeDocument/2006/relationships" id="270" r:id="Raa2441c9b4f649c0"/>
+    <p:sldId xmlns:r="http://schemas.openxmlformats.org/officeDocument/2006/relationships" id="271" r:id="R539eb364e7714e0d"/>
+    <p:sldId xmlns:r="http://schemas.openxmlformats.org/officeDocument/2006/relationships" id="272" r:id="R02a8d49204ce429b"/>
   </p:sldIdLst>
   <p:sldSz cx="12192000" cy="6858000"/>
   <p:notesSz cx="6858000" cy="9144000"/>
@@ -1158,7 +1158,7 @@
           <a:lstStyle xmlns:a="http://schemas.openxmlformats.org/drawingml/2006/main"/>
           <a:p xmlns:a="http://schemas.openxmlformats.org/drawingml/2006/main">
             <a:r>
-              <a:t>Tempo: 50 segundos. Explique a passagem da tabela anual com 12 colunas para uma série longa, com uma data por linha. A base tem 1032 valores positivos e completos. A unidade não está explicitada no PDF. Evite afirmar m³/s como unidade confirmada. O documento também não identifica se são vazões naturais, afluentes ou defluentes. Fonte: data/processed/ilha_solteira_mensal.csv, extraído de ILHA_SOLTEIRA.pdf.</a:t>
+              <a:t>Tempo: 85 segundos. Apresente os três números do topo: 1.032 observações, 86 anos de janeiro de 1931 a dezembro de 2016 e frequência de 12 valores por ano. Cada valor representa uma vazão média mensal. A fonte recebida é ILHA_SOLTEIRA.pdf. No documento, os anos e os meses estão organizados em uma tabela anual distribuída pelas páginas. A extração organiza uma linha por mês. O CSV tem as colunas data, vazao, pagina_pdf e linha_tabela, permitindo rastrear cada observação até sua origem. O índice é mensal, sem lacunas ou duplicatas, e todos os valores são positivos. Não foi necessário preencher meses ausentes. Explique o painel de estatísticas da série completa: média 5.271,65, mediana 4.194 e desvio padrão amostral 3.095,16. Os valores foram arredondados no slide para facilitar a leitura. O mínimo é 1.212 em outubro de 2014 e o máximo é 20.314 em fevereiro de 1983. As estatísticas descrevem a base e não são usadas para escolher parâmetros com os dados de teste. A fonte não explicita a unidade nem se a vazão é natural, afluente ou defluente. Não confirme m³/s sem outra documentação. A base termina em 2016 e não fornece observações de 2017. Fontes: data/raw/ILHA_SOLTEIRA.pdf, data/processed/ilha_solteira_mensal.csv, data/processed/metadados.json e output/resumo.json. Conferência independente dos valores e da regularidade: scripts/verificar.py.</a:t>
             </a:r>
           </a:p>
         </p:txBody>
@@ -1646,7 +1646,7 @@
   </p:cSld>
   <p:clrMap bg1="lt1" tx1="dk1" bg2="lt2" tx2="dk2" accent1="accent1" accent2="accent2" accent3="accent3" accent4="accent4" accent5="accent5" accent6="accent6" hlink="hlink" folHlink="folHlink"/>
   <p:sldLayoutIdLst>
-    <p:sldLayoutId xmlns:r="http://schemas.openxmlformats.org/officeDocument/2006/relationships" id="2147483649" r:id="Rd9791ed121514622"/>
+    <p:sldLayoutId xmlns:r="http://schemas.openxmlformats.org/officeDocument/2006/relationships" id="2147483649" r:id="R581ed93bd059433a"/>
   </p:sldLayoutIdLst>
   <p:txStyles>
     <p:titleStyle>
@@ -2174,7 +2174,7 @@
 </file>
 
 <file path=ppt/slides/charts/chart1.xml><?xml version="1.0" encoding="utf-8"?>
-<c:chartSpace xmlns:c="http://schemas.openxmlformats.org/drawingml/2006/chart" xmlns:r="http://schemas.openxmlformats.org/officeDocument/2006/relationships">
+<c:chartSpace xmlns:c="http://schemas.openxmlformats.org/drawingml/2006/chart">
   <c:lang val="en-US"/>
   <c:chart>
     <c:plotArea>
@@ -2386,7 +2386,7 @@
       <a:srgbClr val="F6F3EB"/>
     </a:solidFill>
   </c:spPr>
-  <c:externalData r:id="rIdChartSnapshot1">
+  <c:externalData xmlns:r="http://schemas.openxmlformats.org/officeDocument/2006/relationships" r:id="rIdChartSnapshot1">
     <c:autoUpdate val="0"/>
   </c:externalData>
 </c:chartSpace>
@@ -8669,8 +8669,6 @@
         <c:numFmt formatCode="General"/>
         <c:majorTickMark val="none"/>
         <c:minorTickMark val="none"/>
-        <c:tickLblSkip val="120"/>
-        <c:tickMarkSkip val="120"/>
         <c:spPr>
           <a:ln xmlns:a="http://schemas.openxmlformats.org/drawingml/2006/main" w="9525">
             <a:solidFill>
@@ -8866,8 +8864,6 @@
         <c:numFmt formatCode="General"/>
         <c:majorTickMark val="none"/>
         <c:minorTickMark val="none"/>
-        <c:tickLblSkip val="1"/>
-        <c:tickMarkSkip val="1"/>
         <c:spPr>
           <a:ln xmlns:a="http://schemas.openxmlformats.org/drawingml/2006/main" w="9525">
             <a:solidFill>
@@ -9770,8 +9766,6 @@
         <c:numFmt formatCode="General"/>
         <c:majorTickMark val="none"/>
         <c:minorTickMark val="none"/>
-        <c:tickLblSkip val="3"/>
-        <c:tickMarkSkip val="3"/>
         <c:spPr>
           <a:ln xmlns:a="http://schemas.openxmlformats.org/drawingml/2006/main" w="9525">
             <a:solidFill>
@@ -10948,8 +10942,6 @@
         <c:numFmt formatCode="General"/>
         <c:majorTickMark val="none"/>
         <c:minorTickMark val="none"/>
-        <c:tickLblSkip val="3"/>
-        <c:tickMarkSkip val="3"/>
         <c:spPr>
           <a:ln xmlns:a="http://schemas.openxmlformats.org/drawingml/2006/main" w="9525">
             <a:solidFill>
@@ -12126,8 +12118,6 @@
         <c:numFmt formatCode="General"/>
         <c:majorTickMark val="none"/>
         <c:minorTickMark val="none"/>
-        <c:tickLblSkip val="3"/>
-        <c:tickMarkSkip val="3"/>
         <c:spPr>
           <a:ln xmlns:a="http://schemas.openxmlformats.org/drawingml/2006/main" w="9525">
             <a:solidFill>
@@ -12728,8 +12718,6 @@
         <c:numFmt formatCode="General"/>
         <c:majorTickMark val="none"/>
         <c:minorTickMark val="none"/>
-        <c:tickLblSkip val="1"/>
-        <c:tickMarkSkip val="1"/>
         <c:spPr>
           <a:ln xmlns:a="http://schemas.openxmlformats.org/drawingml/2006/main" w="9525">
             <a:solidFill>
@@ -12907,6 +12895,7 @@
           </a:lstStyle>
           <a:p xmlns:a="http://schemas.openxmlformats.org/drawingml/2006/main">
             <a:pPr>
+              <a:buNone/>
               <a:defRPr sz="3300" b="1">
                 <a:solidFill>
                   <a:srgbClr val="18343E"/>
@@ -12975,6 +12964,7 @@
           </a:lstStyle>
           <a:p xmlns:a="http://schemas.openxmlformats.org/drawingml/2006/main">
             <a:pPr>
+              <a:buNone/>
               <a:defRPr sz="1950" b="0">
                 <a:solidFill>
                   <a:srgbClr val="5B7177"/>
@@ -13003,7 +12993,7 @@
           <p:cNvPr id="3" name="">
             <a:extLst xmlns:a="http://schemas.openxmlformats.org/drawingml/2006/main">
               <a:ext uri="{FF2B5EF4-FFF2-40B4-BE49-F238E27FC236}">
-                <a16:creationId xmlns:a16="http://schemas.microsoft.com/office/drawing/2014/main" id="{BD68EBDF-BD06-4DB0-8A08-2AD48C4E09C1}"/>
+                <a16:creationId xmlns:a16="http://schemas.microsoft.com/office/drawing/2014/main" id="{2DEBDF49-4423-46DF-8EC8-DDFE18547C2B}"/>
               </a:ext>
             </a:extLst>
           </p:cNvPr>
@@ -13013,7 +13003,7 @@
           <p:nvPr/>
         </p:nvPicPr>
         <p:blipFill>
-          <a:blip xmlns:r="http://schemas.openxmlformats.org/officeDocument/2006/relationships" xmlns:a="http://schemas.openxmlformats.org/drawingml/2006/main" r:embed="Rc799fbf650384d2a"/>
+          <a:blip xmlns:r="http://schemas.openxmlformats.org/officeDocument/2006/relationships" xmlns:a="http://schemas.openxmlformats.org/drawingml/2006/main" r:embed="Rf2133e920caf4c85"/>
           <a:srcRect xmlns:a="http://schemas.openxmlformats.org/drawingml/2006/main" l="0" t="2381" r="0" b="2381"/>
           <a:stretch xmlns:a="http://schemas.openxmlformats.org/drawingml/2006/main">
             <a:fillRect l="0" t="0" r="0" b="0"/>
@@ -13074,6 +13064,7 @@
           </a:lstStyle>
           <a:p xmlns:a="http://schemas.openxmlformats.org/drawingml/2006/main">
             <a:pPr>
+              <a:buNone/>
               <a:defRPr sz="1875" b="0">
                 <a:solidFill>
                   <a:srgbClr val="18343E"/>
@@ -13097,6 +13088,7 @@
           </a:p>
           <a:p xmlns:a="http://schemas.openxmlformats.org/drawingml/2006/main">
             <a:pPr>
+              <a:buNone/>
               <a:defRPr sz="1875" b="0">
                 <a:solidFill>
                   <a:srgbClr val="18343E"/>
@@ -13165,6 +13157,7 @@
           </a:lstStyle>
           <a:p xmlns:a="http://schemas.openxmlformats.org/drawingml/2006/main">
             <a:pPr>
+              <a:buNone/>
               <a:defRPr sz="1200" b="0">
                 <a:solidFill>
                   <a:srgbClr val="5B7177"/>
@@ -13233,6 +13226,7 @@
           </a:lstStyle>
           <a:p xmlns:a="http://schemas.openxmlformats.org/drawingml/2006/main">
             <a:pPr>
+              <a:buNone/>
               <a:defRPr sz="2250" b="1">
                 <a:solidFill>
                   <a:srgbClr val="007F80"/>
@@ -13261,7 +13255,7 @@
           <p:cNvPr id="7" name="Chart">
             <a:extLst xmlns:a="http://schemas.openxmlformats.org/drawingml/2006/main">
               <a:ext uri="{FF2B5EF4-FFF2-40B4-BE49-F238E27FC236}">
-                <a16:creationId xmlns:a16="http://schemas.microsoft.com/office/drawing/2014/main" id="{5823122B-488C-45C9-AEB0-CE0617B895D8}"/>
+                <a16:creationId xmlns:a16="http://schemas.microsoft.com/office/drawing/2014/main" id="{89891C63-8B28-4532-8E67-EDD61205924D}"/>
               </a:ext>
             </a:extLst>
           </p:cNvPr>
@@ -13274,7 +13268,7 @@
         </p:xfrm>
         <a:graphic xmlns:a="http://schemas.openxmlformats.org/drawingml/2006/main">
           <a:graphicData uri="http://schemas.openxmlformats.org/drawingml/2006/chart">
-            <c:chart xmlns:r="http://schemas.openxmlformats.org/officeDocument/2006/relationships" xmlns:c="http://schemas.openxmlformats.org/drawingml/2006/chart" r:id="Rf5fcb34877f84100"/>
+            <c:chart xmlns:r="http://schemas.openxmlformats.org/officeDocument/2006/relationships" xmlns:c="http://schemas.openxmlformats.org/drawingml/2006/chart" r:id="R710182510b394440"/>
           </a:graphicData>
         </a:graphic>
       </p:graphicFrame>
@@ -13323,6 +13317,7 @@
           </a:lstStyle>
           <a:p xmlns:a="http://schemas.openxmlformats.org/drawingml/2006/main">
             <a:pPr>
+              <a:buNone/>
               <a:defRPr sz="1650" b="1">
                 <a:solidFill>
                   <a:srgbClr val="007F80"/>
@@ -13391,6 +13386,7 @@
           </a:lstStyle>
           <a:p xmlns:a="http://schemas.openxmlformats.org/drawingml/2006/main">
             <a:pPr>
+              <a:buNone/>
               <a:defRPr sz="1350" b="0">
                 <a:solidFill>
                   <a:srgbClr val="5B7177"/>
@@ -13459,6 +13455,7 @@
           </a:lstStyle>
           <a:p xmlns:a="http://schemas.openxmlformats.org/drawingml/2006/main">
             <a:pPr>
+              <a:buNone/>
               <a:defRPr sz="1200" b="0">
                 <a:solidFill>
                   <a:srgbClr val="5B7177"/>
@@ -13527,6 +13524,7 @@
           </a:lstStyle>
           <a:p xmlns:a="http://schemas.openxmlformats.org/drawingml/2006/main">
             <a:pPr>
+              <a:buNone/>
               <a:defRPr sz="1200" b="0">
                 <a:solidFill>
                   <a:srgbClr val="5B7177"/>
@@ -13700,7 +13698,7 @@
           <p:cNvPr id="7" name="Chart">
             <a:extLst xmlns:a="http://schemas.openxmlformats.org/drawingml/2006/main">
               <a:ext uri="{FF2B5EF4-FFF2-40B4-BE49-F238E27FC236}">
-                <a16:creationId xmlns:a16="http://schemas.microsoft.com/office/drawing/2014/main" id="{AA7F3007-2DC8-4DF8-9576-31CFED6044BF}"/>
+                <a16:creationId xmlns:a16="http://schemas.microsoft.com/office/drawing/2014/main" id="{A7AD511B-3A4C-4EDB-82EE-DBEDE843D717}"/>
               </a:ext>
             </a:extLst>
           </p:cNvPr>
@@ -13713,7 +13711,7 @@
         </p:xfrm>
         <a:graphic xmlns:a="http://schemas.openxmlformats.org/drawingml/2006/main">
           <a:graphicData uri="http://schemas.openxmlformats.org/drawingml/2006/chart">
-            <c:chart xmlns:r="http://schemas.openxmlformats.org/officeDocument/2006/relationships" xmlns:c="http://schemas.openxmlformats.org/drawingml/2006/chart" r:id="R1a023a15231f468d"/>
+            <c:chart xmlns:r="http://schemas.openxmlformats.org/officeDocument/2006/relationships" xmlns:c="http://schemas.openxmlformats.org/drawingml/2006/chart" r:id="Rffce25e5669f411b"/>
           </a:graphicData>
         </a:graphic>
       </p:graphicFrame>
@@ -13925,7 +13923,7 @@
           <p:cNvPr id="7" name="Chart">
             <a:extLst xmlns:a="http://schemas.openxmlformats.org/drawingml/2006/main">
               <a:ext uri="{FF2B5EF4-FFF2-40B4-BE49-F238E27FC236}">
-                <a16:creationId xmlns:a16="http://schemas.microsoft.com/office/drawing/2014/main" id="{01ECF47D-3658-42DB-B7A8-D8CDCB5BC73A}"/>
+                <a16:creationId xmlns:a16="http://schemas.microsoft.com/office/drawing/2014/main" id="{85B5EC14-E38D-44D9-9E66-9BDFAEE37960}"/>
               </a:ext>
             </a:extLst>
           </p:cNvPr>
@@ -13938,7 +13936,7 @@
         </p:xfrm>
         <a:graphic xmlns:a="http://schemas.openxmlformats.org/drawingml/2006/main">
           <a:graphicData uri="http://schemas.openxmlformats.org/drawingml/2006/chart">
-            <c:chart xmlns:r="http://schemas.openxmlformats.org/officeDocument/2006/relationships" xmlns:c="http://schemas.openxmlformats.org/drawingml/2006/chart" r:id="Reb027964164f4c1f"/>
+            <c:chart xmlns:r="http://schemas.openxmlformats.org/officeDocument/2006/relationships" xmlns:c="http://schemas.openxmlformats.org/drawingml/2006/chart" r:id="Rc938acaaa13540a9"/>
           </a:graphicData>
         </a:graphic>
       </p:graphicFrame>
@@ -14150,7 +14148,7 @@
           <p:cNvPr id="7" name="Chart">
             <a:extLst xmlns:a="http://schemas.openxmlformats.org/drawingml/2006/main">
               <a:ext uri="{FF2B5EF4-FFF2-40B4-BE49-F238E27FC236}">
-                <a16:creationId xmlns:a16="http://schemas.microsoft.com/office/drawing/2014/main" id="{F6C2E755-82B8-42F1-BC8F-2FEDF880EEDC}"/>
+                <a16:creationId xmlns:a16="http://schemas.microsoft.com/office/drawing/2014/main" id="{7E06ECC6-257D-4F37-AA8C-D16205CAF91F}"/>
               </a:ext>
             </a:extLst>
           </p:cNvPr>
@@ -14163,7 +14161,7 @@
         </p:xfrm>
         <a:graphic xmlns:a="http://schemas.openxmlformats.org/drawingml/2006/main">
           <a:graphicData uri="http://schemas.openxmlformats.org/drawingml/2006/chart">
-            <c:chart xmlns:r="http://schemas.openxmlformats.org/officeDocument/2006/relationships" xmlns:c="http://schemas.openxmlformats.org/drawingml/2006/chart" r:id="R8c2d1377e2c04a14"/>
+            <c:chart xmlns:r="http://schemas.openxmlformats.org/officeDocument/2006/relationships" xmlns:c="http://schemas.openxmlformats.org/drawingml/2006/chart" r:id="Rf4a5cad1ce6a4d59"/>
           </a:graphicData>
         </a:graphic>
       </p:graphicFrame>
@@ -15269,7 +15267,7 @@
           <p:cNvPr id="7" name="Chart">
             <a:extLst xmlns:a="http://schemas.openxmlformats.org/drawingml/2006/main">
               <a:ext uri="{FF2B5EF4-FFF2-40B4-BE49-F238E27FC236}">
-                <a16:creationId xmlns:a16="http://schemas.microsoft.com/office/drawing/2014/main" id="{D1DFF2DA-64EB-4489-8CBB-2334DA9A9F3E}"/>
+                <a16:creationId xmlns:a16="http://schemas.microsoft.com/office/drawing/2014/main" id="{FD27CF6F-2F21-4D9E-9B9D-FBEF63009D99}"/>
               </a:ext>
             </a:extLst>
           </p:cNvPr>
@@ -15282,7 +15280,7 @@
         </p:xfrm>
         <a:graphic xmlns:a="http://schemas.openxmlformats.org/drawingml/2006/main">
           <a:graphicData uri="http://schemas.openxmlformats.org/drawingml/2006/chart">
-            <c:chart xmlns:r="http://schemas.openxmlformats.org/officeDocument/2006/relationships" xmlns:c="http://schemas.openxmlformats.org/drawingml/2006/chart" r:id="Redff4363c4aa432d"/>
+            <c:chart xmlns:r="http://schemas.openxmlformats.org/officeDocument/2006/relationships" xmlns:c="http://schemas.openxmlformats.org/drawingml/2006/chart" r:id="Rde917ece11584e14"/>
           </a:graphicData>
         </a:graphic>
       </p:graphicFrame>
@@ -16162,6 +16160,7 @@
           </a:lstStyle>
           <a:p xmlns:a="http://schemas.openxmlformats.org/drawingml/2006/main">
             <a:pPr>
+              <a:buNone/>
               <a:defRPr sz="3300" b="1">
                 <a:solidFill>
                   <a:srgbClr val="18343E"/>
@@ -16230,6 +16229,7 @@
           </a:lstStyle>
           <a:p xmlns:a="http://schemas.openxmlformats.org/drawingml/2006/main">
             <a:pPr>
+              <a:buNone/>
               <a:defRPr sz="4800" b="1">
                 <a:solidFill>
                   <a:srgbClr val="007F80"/>
@@ -16298,6 +16298,7 @@
           </a:lstStyle>
           <a:p xmlns:a="http://schemas.openxmlformats.org/drawingml/2006/main">
             <a:pPr>
+              <a:buNone/>
               <a:defRPr sz="2025" b="0">
                 <a:solidFill>
                   <a:srgbClr val="18343E"/>
@@ -16321,6 +16322,7 @@
           </a:p>
           <a:p xmlns:a="http://schemas.openxmlformats.org/drawingml/2006/main">
             <a:pPr>
+              <a:buNone/>
               <a:defRPr sz="2025" b="0">
                 <a:solidFill>
                   <a:srgbClr val="18343E"/>
@@ -16389,6 +16391,7 @@
           </a:lstStyle>
           <a:p xmlns:a="http://schemas.openxmlformats.org/drawingml/2006/main">
             <a:pPr>
+              <a:buNone/>
               <a:defRPr sz="4800" b="1">
                 <a:solidFill>
                   <a:srgbClr val="C48730"/>
@@ -16457,6 +16460,7 @@
           </a:lstStyle>
           <a:p xmlns:a="http://schemas.openxmlformats.org/drawingml/2006/main">
             <a:pPr>
+              <a:buNone/>
               <a:defRPr sz="2025" b="0">
                 <a:solidFill>
                   <a:srgbClr val="18343E"/>
@@ -16480,6 +16484,7 @@
           </a:p>
           <a:p xmlns:a="http://schemas.openxmlformats.org/drawingml/2006/main">
             <a:pPr>
+              <a:buNone/>
               <a:defRPr sz="2025" b="0">
                 <a:solidFill>
                   <a:srgbClr val="18343E"/>
@@ -16508,7 +16513,7 @@
           <p:cNvPr id="6" name="">
             <a:extLst xmlns:a="http://schemas.openxmlformats.org/drawingml/2006/main">
               <a:ext uri="{FF2B5EF4-FFF2-40B4-BE49-F238E27FC236}">
-                <a16:creationId xmlns:a16="http://schemas.microsoft.com/office/drawing/2014/main" id="{7AB77D2B-3D86-4F44-A9C4-E9C6924F8735}"/>
+                <a16:creationId xmlns:a16="http://schemas.microsoft.com/office/drawing/2014/main" id="{D8B63F6D-05A3-418D-B520-4A967013A03B}"/>
               </a:ext>
             </a:extLst>
           </p:cNvPr>
@@ -16518,7 +16523,7 @@
           <p:nvPr/>
         </p:nvPicPr>
         <p:blipFill>
-          <a:blip xmlns:r="http://schemas.openxmlformats.org/officeDocument/2006/relationships" xmlns:a="http://schemas.openxmlformats.org/drawingml/2006/main" r:embed="R8631618102cf427c"/>
+          <a:blip xmlns:r="http://schemas.openxmlformats.org/officeDocument/2006/relationships" xmlns:a="http://schemas.openxmlformats.org/drawingml/2006/main" r:embed="R639a4a67e9414fbf"/>
           <a:stretch xmlns:a="http://schemas.openxmlformats.org/drawingml/2006/main"/>
         </p:blipFill>
         <p:spPr>
@@ -16576,6 +16581,7 @@
           </a:lstStyle>
           <a:p xmlns:a="http://schemas.openxmlformats.org/drawingml/2006/main">
             <a:pPr>
+              <a:buNone/>
               <a:defRPr sz="1200" b="0">
                 <a:solidFill>
                   <a:srgbClr val="5B7177"/>
@@ -16644,6 +16650,7 @@
           </a:lstStyle>
           <a:p xmlns:a="http://schemas.openxmlformats.org/drawingml/2006/main">
             <a:pPr>
+              <a:buNone/>
               <a:defRPr sz="1200" b="0">
                 <a:solidFill>
                   <a:srgbClr val="5B7177"/>
@@ -16683,7 +16690,7 @@
     <p:bg>
       <p:bgPr>
         <a:solidFill xmlns:a="http://schemas.openxmlformats.org/drawingml/2006/main">
-          <a:srgbClr val="F6F3EB"/>
+          <a:srgbClr val="102E3A"/>
         </a:solidFill>
       </p:bgPr>
     </p:bg>
@@ -16698,10 +16705,10 @@
       </p:grpSpPr>
       <p:sp>
         <p:nvSpPr>
-          <p:cNvPr id="7" name="">
+          <p:cNvPr id="30" name="">
             <a:extLst xmlns:a="http://schemas.openxmlformats.org/drawingml/2006/main">
               <a:ext uri="{FF2B5EF4-FFF2-40B4-BE49-F238E27FC236}">
-                <a16:creationId xmlns:a16="http://schemas.microsoft.com/office/drawing/2014/main" id="{16BA9192-86F3-42B7-9B51-69FBA2026F52}"/>
+                <a16:creationId xmlns:a16="http://schemas.microsoft.com/office/drawing/2014/main" id="{9B839E9E-5A88-4EE9-A814-CDB1FD83EF58}"/>
               </a:ext>
             </a:extLst>
           </p:cNvPr>
@@ -16713,7 +16720,7 @@
         <p:spPr>
           <a:xfrm xmlns:a="http://schemas.openxmlformats.org/drawingml/2006/main">
             <a:off x="609600" y="419100"/>
-            <a:ext cx="10934700" cy="952500"/>
+            <a:ext cx="10972800" cy="609600"/>
           </a:xfrm>
           <a:prstGeom xmlns:a="http://schemas.openxmlformats.org/drawingml/2006/main" prst="rect">
             <a:avLst/>
@@ -16727,13 +16734,23 @@
           <a:bodyPr xmlns:a="http://schemas.openxmlformats.org/drawingml/2006/main">
             <a:noAutofit/>
           </a:bodyPr>
-          <a:lstStyle xmlns:a="http://schemas.openxmlformats.org/drawingml/2006/main"/>
+          <a:lstStyle xmlns:a="http://schemas.openxmlformats.org/drawingml/2006/main">
+            <a:defPPr>
+              <a:defRPr sz="3300" b="1">
+                <a:solidFill>
+                  <a:srgbClr val="F6F3EB"/>
+                </a:solidFill>
+                <a:latin typeface="Arial"/>
+                <a:ea typeface="Arial"/>
+                <a:cs typeface="Arial"/>
+              </a:defRPr>
+            </a:defPPr>
+          </a:lstStyle>
           <a:p xmlns:a="http://schemas.openxmlformats.org/drawingml/2006/main">
             <a:pPr>
-              <a:buNone/>
               <a:defRPr sz="3300" b="1">
                 <a:solidFill>
-                  <a:srgbClr val="18343E"/>
+                  <a:srgbClr val="F6F3EB"/>
                 </a:solidFill>
                 <a:latin typeface="Arial"/>
                 <a:ea typeface="Arial"/>
@@ -16743,13 +16760,13 @@
             <a:r>
               <a:rPr sz="3300" b="1">
                 <a:solidFill>
-                  <a:srgbClr val="18343E"/>
+                  <a:srgbClr val="F6F3EB"/>
                 </a:solidFill>
                 <a:latin typeface="Arial"/>
                 <a:ea typeface="Arial"/>
                 <a:cs typeface="Arial"/>
               </a:rPr>
-              <a:t>86 anos de observações mensais</a:t>
+              <a:t>A base de dados em um olhar</a:t>
             </a:r>
           </a:p>
         </p:txBody>
@@ -16759,7 +16776,7 @@
           <p:cNvPr id="2" name="">
             <a:extLst xmlns:a="http://schemas.openxmlformats.org/drawingml/2006/main">
               <a:ext uri="{FF2B5EF4-FFF2-40B4-BE49-F238E27FC236}">
-                <a16:creationId xmlns:a16="http://schemas.microsoft.com/office/drawing/2014/main" id="{306109AE-EF9A-4025-875E-3004A93AB359}"/>
+                <a16:creationId xmlns:a16="http://schemas.microsoft.com/office/drawing/2014/main" id="{9675BD05-D234-4ECB-9FE3-B30EB2759B3C}"/>
               </a:ext>
             </a:extLst>
           </p:cNvPr>
@@ -16770,8 +16787,8 @@
         </p:nvSpPr>
         <p:spPr>
           <a:xfrm xmlns:a="http://schemas.openxmlformats.org/drawingml/2006/main">
-            <a:off x="609600" y="6400800"/>
-            <a:ext cx="5715000" cy="228600"/>
+            <a:off x="647700" y="1028700"/>
+            <a:ext cx="10820400" cy="285750"/>
           </a:xfrm>
           <a:prstGeom xmlns:a="http://schemas.openxmlformats.org/drawingml/2006/main" prst="rect">
             <a:avLst/>
@@ -16785,13 +16802,23 @@
           <a:bodyPr xmlns:a="http://schemas.openxmlformats.org/drawingml/2006/main">
             <a:noAutofit/>
           </a:bodyPr>
-          <a:lstStyle xmlns:a="http://schemas.openxmlformats.org/drawingml/2006/main"/>
+          <a:lstStyle xmlns:a="http://schemas.openxmlformats.org/drawingml/2006/main">
+            <a:defPPr>
+              <a:defRPr sz="1575" b="0">
+                <a:solidFill>
+                  <a:srgbClr val="A5C8CB"/>
+                </a:solidFill>
+                <a:latin typeface="Arial"/>
+                <a:ea typeface="Arial"/>
+                <a:cs typeface="Arial"/>
+              </a:defRPr>
+            </a:defPPr>
+          </a:lstStyle>
           <a:p xmlns:a="http://schemas.openxmlformats.org/drawingml/2006/main">
             <a:pPr>
-              <a:buNone/>
-              <a:defRPr sz="1200" b="0">
-                <a:solidFill>
-                  <a:srgbClr val="5B7177"/>
+              <a:defRPr sz="1575" b="0">
+                <a:solidFill>
+                  <a:srgbClr val="A5C8CB"/>
                 </a:solidFill>
                 <a:latin typeface="Arial"/>
                 <a:ea typeface="Arial"/>
@@ -16799,25 +16826,25 @@
               </a:defRPr>
             </a:pPr>
             <a:r>
-              <a:rPr sz="1200" b="0">
-                <a:solidFill>
-                  <a:srgbClr val="5B7177"/>
+              <a:rPr sz="1575" b="0">
+                <a:solidFill>
+                  <a:srgbClr val="A5C8CB"/>
                 </a:solidFill>
                 <a:latin typeface="Arial"/>
                 <a:ea typeface="Arial"/>
                 <a:cs typeface="Arial"/>
               </a:rPr>
-              <a:t>03  Ilha Solteira</a:t>
+              <a:t>Vazões médias mensais fornecidas ao grupo</a:t>
             </a:r>
           </a:p>
         </p:txBody>
       </p:sp>
       <p:sp>
         <p:nvSpPr>
-          <p:cNvPr id="3" name="">
+          <p:cNvPr id="3" name="Quantidade de observações">
             <a:extLst xmlns:a="http://schemas.openxmlformats.org/drawingml/2006/main">
               <a:ext uri="{FF2B5EF4-FFF2-40B4-BE49-F238E27FC236}">
-                <a16:creationId xmlns:a16="http://schemas.microsoft.com/office/drawing/2014/main" id="{4E95E13E-501A-4AE6-991D-D7E6AAFA8A76}"/>
+                <a16:creationId xmlns:a16="http://schemas.microsoft.com/office/drawing/2014/main" id="{2E48CF9E-C135-40E3-ABB0-ABE657834E83}"/>
               </a:ext>
             </a:extLst>
           </p:cNvPr>
@@ -16828,8 +16855,104 @@
         </p:nvSpPr>
         <p:spPr>
           <a:xfrm xmlns:a="http://schemas.openxmlformats.org/drawingml/2006/main">
-            <a:off x="666750" y="1666875"/>
-            <a:ext cx="5048250" cy="1143000"/>
+            <a:off x="609600" y="1438275"/>
+            <a:ext cx="3505200" cy="1438275"/>
+          </a:xfrm>
+          <a:prstGeom xmlns:a="http://schemas.openxmlformats.org/drawingml/2006/main" prst="roundRect">
+            <a:avLst>
+              <a:gd name="adj" fmla="val 11921"/>
+            </a:avLst>
+          </a:prstGeom>
+          <a:solidFill xmlns:a="http://schemas.openxmlformats.org/drawingml/2006/main">
+            <a:srgbClr val="007F80"/>
+          </a:solidFill>
+          <a:ln xmlns:a="http://schemas.openxmlformats.org/drawingml/2006/main" w="0">
+            <a:noFill/>
+          </a:ln>
+        </p:spPr>
+      </p:sp>
+      <p:sp>
+        <p:nvSpPr>
+          <p:cNvPr id="4" name="Período de observação">
+            <a:extLst xmlns:a="http://schemas.openxmlformats.org/drawingml/2006/main">
+              <a:ext uri="{FF2B5EF4-FFF2-40B4-BE49-F238E27FC236}">
+                <a16:creationId xmlns:a16="http://schemas.microsoft.com/office/drawing/2014/main" id="{E36396F2-F53F-4847-BAF7-D457E9B7DEAD}"/>
+              </a:ext>
+            </a:extLst>
+          </p:cNvPr>
+          <p:cNvSpPr>
+            <a:spLocks xmlns:a="http://schemas.openxmlformats.org/drawingml/2006/main" noGrp="1"/>
+          </p:cNvSpPr>
+          <p:nvPr/>
+        </p:nvSpPr>
+        <p:spPr>
+          <a:xfrm xmlns:a="http://schemas.openxmlformats.org/drawingml/2006/main">
+            <a:off x="4343400" y="1438275"/>
+            <a:ext cx="3505200" cy="1438275"/>
+          </a:xfrm>
+          <a:prstGeom xmlns:a="http://schemas.openxmlformats.org/drawingml/2006/main" prst="roundRect">
+            <a:avLst>
+              <a:gd name="adj" fmla="val 11921"/>
+            </a:avLst>
+          </a:prstGeom>
+          <a:solidFill xmlns:a="http://schemas.openxmlformats.org/drawingml/2006/main">
+            <a:srgbClr val="1B414D"/>
+          </a:solidFill>
+          <a:ln xmlns:a="http://schemas.openxmlformats.org/drawingml/2006/main" w="0">
+            <a:noFill/>
+          </a:ln>
+        </p:spPr>
+      </p:sp>
+      <p:sp>
+        <p:nvSpPr>
+          <p:cNvPr id="5" name="Frequência temporal">
+            <a:extLst xmlns:a="http://schemas.openxmlformats.org/drawingml/2006/main">
+              <a:ext uri="{FF2B5EF4-FFF2-40B4-BE49-F238E27FC236}">
+                <a16:creationId xmlns:a16="http://schemas.microsoft.com/office/drawing/2014/main" id="{413DC023-8871-4A9F-944B-B53F5F6676E3}"/>
+              </a:ext>
+            </a:extLst>
+          </p:cNvPr>
+          <p:cNvSpPr>
+            <a:spLocks xmlns:a="http://schemas.openxmlformats.org/drawingml/2006/main" noGrp="1"/>
+          </p:cNvSpPr>
+          <p:nvPr/>
+        </p:nvSpPr>
+        <p:spPr>
+          <a:xfrm xmlns:a="http://schemas.openxmlformats.org/drawingml/2006/main">
+            <a:off x="8077200" y="1438275"/>
+            <a:ext cx="3505200" cy="1438275"/>
+          </a:xfrm>
+          <a:prstGeom xmlns:a="http://schemas.openxmlformats.org/drawingml/2006/main" prst="roundRect">
+            <a:avLst>
+              <a:gd name="adj" fmla="val 11921"/>
+            </a:avLst>
+          </a:prstGeom>
+          <a:solidFill xmlns:a="http://schemas.openxmlformats.org/drawingml/2006/main">
+            <a:srgbClr val="D5E9E4"/>
+          </a:solidFill>
+          <a:ln xmlns:a="http://schemas.openxmlformats.org/drawingml/2006/main" w="0">
+            <a:noFill/>
+          </a:ln>
+        </p:spPr>
+      </p:sp>
+      <p:sp>
+        <p:nvSpPr>
+          <p:cNvPr id="6" name="">
+            <a:extLst xmlns:a="http://schemas.openxmlformats.org/drawingml/2006/main">
+              <a:ext uri="{FF2B5EF4-FFF2-40B4-BE49-F238E27FC236}">
+                <a16:creationId xmlns:a16="http://schemas.microsoft.com/office/drawing/2014/main" id="{DB9C5D84-9D67-4E0A-91D2-85A75BE5875A}"/>
+              </a:ext>
+            </a:extLst>
+          </p:cNvPr>
+          <p:cNvSpPr>
+            <a:spLocks xmlns:a="http://schemas.openxmlformats.org/drawingml/2006/main" noGrp="1"/>
+          </p:cNvSpPr>
+          <p:nvPr/>
+        </p:nvSpPr>
+        <p:spPr>
+          <a:xfrm xmlns:a="http://schemas.openxmlformats.org/drawingml/2006/main">
+            <a:off x="819150" y="1562100"/>
+            <a:ext cx="3095625" cy="695325"/>
           </a:xfrm>
           <a:prstGeom xmlns:a="http://schemas.openxmlformats.org/drawingml/2006/main" prst="rect">
             <a:avLst/>
@@ -16843,13 +16966,23 @@
           <a:bodyPr xmlns:a="http://schemas.openxmlformats.org/drawingml/2006/main">
             <a:noAutofit/>
           </a:bodyPr>
-          <a:lstStyle xmlns:a="http://schemas.openxmlformats.org/drawingml/2006/main"/>
+          <a:lstStyle xmlns:a="http://schemas.openxmlformats.org/drawingml/2006/main">
+            <a:defPPr>
+              <a:defRPr sz="4350" b="1">
+                <a:solidFill>
+                  <a:srgbClr val="F6F3EB"/>
+                </a:solidFill>
+                <a:latin typeface="Arial"/>
+                <a:ea typeface="Arial"/>
+                <a:cs typeface="Arial"/>
+              </a:defRPr>
+            </a:defPPr>
+          </a:lstStyle>
           <a:p xmlns:a="http://schemas.openxmlformats.org/drawingml/2006/main">
             <a:pPr>
-              <a:buNone/>
-              <a:defRPr sz="6750" b="1">
-                <a:solidFill>
-                  <a:srgbClr val="007F80"/>
+              <a:defRPr sz="4350" b="1">
+                <a:solidFill>
+                  <a:srgbClr val="F6F3EB"/>
                 </a:solidFill>
                 <a:latin typeface="Arial"/>
                 <a:ea typeface="Arial"/>
@@ -16857,9 +16990,9 @@
               </a:defRPr>
             </a:pPr>
             <a:r>
-              <a:rPr sz="6750" b="1">
-                <a:solidFill>
-                  <a:srgbClr val="007F80"/>
+              <a:rPr sz="4350" b="1">
+                <a:solidFill>
+                  <a:srgbClr val="F6F3EB"/>
                 </a:solidFill>
                 <a:latin typeface="Arial"/>
                 <a:ea typeface="Arial"/>
@@ -16872,10 +17005,10 @@
       </p:sp>
       <p:sp>
         <p:nvSpPr>
-          <p:cNvPr id="4" name="">
+          <p:cNvPr id="7" name="">
             <a:extLst xmlns:a="http://schemas.openxmlformats.org/drawingml/2006/main">
               <a:ext uri="{FF2B5EF4-FFF2-40B4-BE49-F238E27FC236}">
-                <a16:creationId xmlns:a16="http://schemas.microsoft.com/office/drawing/2014/main" id="{13297A04-2389-4FDD-98D3-4C1668349C0F}"/>
+                <a16:creationId xmlns:a16="http://schemas.microsoft.com/office/drawing/2014/main" id="{25982FD2-1825-4884-A7BA-ECF20A877273}"/>
               </a:ext>
             </a:extLst>
           </p:cNvPr>
@@ -16886,8 +17019,8 @@
         </p:nvSpPr>
         <p:spPr>
           <a:xfrm xmlns:a="http://schemas.openxmlformats.org/drawingml/2006/main">
-            <a:off x="723900" y="3048000"/>
-            <a:ext cx="6191250" cy="952500"/>
+            <a:off x="857250" y="2352675"/>
+            <a:ext cx="3095625" cy="342900"/>
           </a:xfrm>
           <a:prstGeom xmlns:a="http://schemas.openxmlformats.org/drawingml/2006/main" prst="rect">
             <a:avLst/>
@@ -16901,13 +17034,23 @@
           <a:bodyPr xmlns:a="http://schemas.openxmlformats.org/drawingml/2006/main">
             <a:noAutofit/>
           </a:bodyPr>
-          <a:lstStyle xmlns:a="http://schemas.openxmlformats.org/drawingml/2006/main"/>
+          <a:lstStyle xmlns:a="http://schemas.openxmlformats.org/drawingml/2006/main">
+            <a:defPPr>
+              <a:defRPr sz="1800" b="0">
+                <a:solidFill>
+                  <a:srgbClr val="F6F3EB"/>
+                </a:solidFill>
+                <a:latin typeface="Arial"/>
+                <a:ea typeface="Arial"/>
+                <a:cs typeface="Arial"/>
+              </a:defRPr>
+            </a:defPPr>
+          </a:lstStyle>
           <a:p xmlns:a="http://schemas.openxmlformats.org/drawingml/2006/main">
             <a:pPr>
-              <a:buNone/>
-              <a:defRPr sz="2325" b="0">
-                <a:solidFill>
-                  <a:srgbClr val="18343E"/>
+              <a:defRPr sz="1800" b="0">
+                <a:solidFill>
+                  <a:srgbClr val="F6F3EB"/>
                 </a:solidFill>
                 <a:latin typeface="Arial"/>
                 <a:ea typeface="Arial"/>
@@ -16915,49 +17058,25 @@
               </a:defRPr>
             </a:pPr>
             <a:r>
-              <a:rPr sz="2325" b="0">
-                <a:solidFill>
-                  <a:srgbClr val="18343E"/>
+              <a:rPr sz="1800" b="0">
+                <a:solidFill>
+                  <a:srgbClr val="F6F3EB"/>
                 </a:solidFill>
                 <a:latin typeface="Arial"/>
                 <a:ea typeface="Arial"/>
                 <a:cs typeface="Arial"/>
               </a:rPr>
-              <a:t>meses de janeiro de 1931</a:t>
-            </a:r>
-          </a:p>
-          <a:p xmlns:a="http://schemas.openxmlformats.org/drawingml/2006/main">
-            <a:pPr>
-              <a:buNone/>
-              <a:defRPr sz="2325" b="0">
-                <a:solidFill>
-                  <a:srgbClr val="18343E"/>
-                </a:solidFill>
-                <a:latin typeface="Arial"/>
-                <a:ea typeface="Arial"/>
-                <a:cs typeface="Arial"/>
-              </a:defRPr>
-            </a:pPr>
-            <a:r>
-              <a:rPr sz="2325" b="0">
-                <a:solidFill>
-                  <a:srgbClr val="18343E"/>
-                </a:solidFill>
-                <a:latin typeface="Arial"/>
-                <a:ea typeface="Arial"/>
-                <a:cs typeface="Arial"/>
-              </a:rPr>
-              <a:t>a dezembro de 2016</a:t>
+              <a:t>observações mensais</a:t>
             </a:r>
           </a:p>
         </p:txBody>
       </p:sp>
       <p:sp>
         <p:nvSpPr>
-          <p:cNvPr id="5" name="">
+          <p:cNvPr id="8" name="">
             <a:extLst xmlns:a="http://schemas.openxmlformats.org/drawingml/2006/main">
               <a:ext uri="{FF2B5EF4-FFF2-40B4-BE49-F238E27FC236}">
-                <a16:creationId xmlns:a16="http://schemas.microsoft.com/office/drawing/2014/main" id="{200DB55F-848E-46CA-9370-EA2888D49237}"/>
+                <a16:creationId xmlns:a16="http://schemas.microsoft.com/office/drawing/2014/main" id="{76C1F6CA-AD3A-4ED0-8553-D0169CA5BCE2}"/>
               </a:ext>
             </a:extLst>
           </p:cNvPr>
@@ -16968,8 +17087,8 @@
         </p:nvSpPr>
         <p:spPr>
           <a:xfrm xmlns:a="http://schemas.openxmlformats.org/drawingml/2006/main">
-            <a:off x="7239000" y="1905000"/>
-            <a:ext cx="4381500" cy="1809750"/>
+            <a:off x="4572000" y="1638300"/>
+            <a:ext cx="3048000" cy="619125"/>
           </a:xfrm>
           <a:prstGeom xmlns:a="http://schemas.openxmlformats.org/drawingml/2006/main" prst="rect">
             <a:avLst/>
@@ -16983,13 +17102,23 @@
           <a:bodyPr xmlns:a="http://schemas.openxmlformats.org/drawingml/2006/main">
             <a:noAutofit/>
           </a:bodyPr>
-          <a:lstStyle xmlns:a="http://schemas.openxmlformats.org/drawingml/2006/main"/>
+          <a:lstStyle xmlns:a="http://schemas.openxmlformats.org/drawingml/2006/main">
+            <a:defPPr>
+              <a:defRPr sz="3600" b="1">
+                <a:solidFill>
+                  <a:srgbClr val="D9AC69"/>
+                </a:solidFill>
+                <a:latin typeface="Arial"/>
+                <a:ea typeface="Arial"/>
+                <a:cs typeface="Arial"/>
+              </a:defRPr>
+            </a:defPPr>
+          </a:lstStyle>
           <a:p xmlns:a="http://schemas.openxmlformats.org/drawingml/2006/main">
             <a:pPr>
-              <a:buNone/>
-              <a:defRPr sz="2100" b="0">
-                <a:solidFill>
-                  <a:srgbClr val="18343E"/>
+              <a:defRPr sz="3600" b="1">
+                <a:solidFill>
+                  <a:srgbClr val="D9AC69"/>
                 </a:solidFill>
                 <a:latin typeface="Arial"/>
                 <a:ea typeface="Arial"/>
@@ -16997,73 +17126,25 @@
               </a:defRPr>
             </a:pPr>
             <a:r>
-              <a:rPr sz="2100" b="0">
-                <a:solidFill>
-                  <a:srgbClr val="18343E"/>
+              <a:rPr sz="3600" b="1">
+                <a:solidFill>
+                  <a:srgbClr val="D9AC69"/>
                 </a:solidFill>
                 <a:latin typeface="Arial"/>
                 <a:ea typeface="Arial"/>
                 <a:cs typeface="Arial"/>
               </a:rPr>
-              <a:t>12 observações por ano</a:t>
-            </a:r>
-          </a:p>
-          <a:p xmlns:a="http://schemas.openxmlformats.org/drawingml/2006/main">
-            <a:pPr>
-              <a:buNone/>
-              <a:defRPr sz="2100" b="0">
-                <a:solidFill>
-                  <a:srgbClr val="18343E"/>
-                </a:solidFill>
-                <a:latin typeface="Arial"/>
-                <a:ea typeface="Arial"/>
-                <a:cs typeface="Arial"/>
-              </a:defRPr>
-            </a:pPr>
-            <a:r>
-              <a:rPr sz="2100" b="0">
-                <a:solidFill>
-                  <a:srgbClr val="18343E"/>
-                </a:solidFill>
-                <a:latin typeface="Arial"/>
-                <a:ea typeface="Arial"/>
-                <a:cs typeface="Arial"/>
-              </a:rPr>
-              <a:t>Sem meses ausentes</a:t>
-            </a:r>
-          </a:p>
-          <a:p xmlns:a="http://schemas.openxmlformats.org/drawingml/2006/main">
-            <a:pPr>
-              <a:buNone/>
-              <a:defRPr sz="2100" b="0">
-                <a:solidFill>
-                  <a:srgbClr val="18343E"/>
-                </a:solidFill>
-                <a:latin typeface="Arial"/>
-                <a:ea typeface="Arial"/>
-                <a:cs typeface="Arial"/>
-              </a:defRPr>
-            </a:pPr>
-            <a:r>
-              <a:rPr sz="2100" b="0">
-                <a:solidFill>
-                  <a:srgbClr val="18343E"/>
-                </a:solidFill>
-                <a:latin typeface="Arial"/>
-                <a:ea typeface="Arial"/>
-                <a:cs typeface="Arial"/>
-              </a:rPr>
-              <a:t>Valores positivos</a:t>
+              <a:t>86 anos</a:t>
             </a:r>
           </a:p>
         </p:txBody>
       </p:sp>
       <p:sp>
         <p:nvSpPr>
-          <p:cNvPr id="6" name="">
+          <p:cNvPr id="9" name="">
             <a:extLst xmlns:a="http://schemas.openxmlformats.org/drawingml/2006/main">
               <a:ext uri="{FF2B5EF4-FFF2-40B4-BE49-F238E27FC236}">
-                <a16:creationId xmlns:a16="http://schemas.microsoft.com/office/drawing/2014/main" id="{AFA04799-D3B1-4074-863A-77942FE2151B}"/>
+                <a16:creationId xmlns:a16="http://schemas.microsoft.com/office/drawing/2014/main" id="{F5E98563-9731-4483-AFE8-65EDC601FB83}"/>
               </a:ext>
             </a:extLst>
           </p:cNvPr>
@@ -17074,8 +17155,8 @@
         </p:nvSpPr>
         <p:spPr>
           <a:xfrm xmlns:a="http://schemas.openxmlformats.org/drawingml/2006/main">
-            <a:off x="714375" y="4810125"/>
-            <a:ext cx="10572750" cy="857250"/>
+            <a:off x="4572000" y="2352675"/>
+            <a:ext cx="3048000" cy="342900"/>
           </a:xfrm>
           <a:prstGeom xmlns:a="http://schemas.openxmlformats.org/drawingml/2006/main" prst="rect">
             <a:avLst/>
@@ -17089,13 +17170,23 @@
           <a:bodyPr xmlns:a="http://schemas.openxmlformats.org/drawingml/2006/main">
             <a:noAutofit/>
           </a:bodyPr>
-          <a:lstStyle xmlns:a="http://schemas.openxmlformats.org/drawingml/2006/main"/>
+          <a:lstStyle xmlns:a="http://schemas.openxmlformats.org/drawingml/2006/main">
+            <a:defPPr>
+              <a:defRPr sz="1800" b="0">
+                <a:solidFill>
+                  <a:srgbClr val="F6F3EB"/>
+                </a:solidFill>
+                <a:latin typeface="Arial"/>
+                <a:ea typeface="Arial"/>
+                <a:cs typeface="Arial"/>
+              </a:defRPr>
+            </a:defPPr>
+          </a:lstStyle>
           <a:p xmlns:a="http://schemas.openxmlformats.org/drawingml/2006/main">
             <a:pPr>
-              <a:buNone/>
-              <a:defRPr sz="2250" b="1">
-                <a:solidFill>
-                  <a:srgbClr val="C48730"/>
+              <a:defRPr sz="1800" b="0">
+                <a:solidFill>
+                  <a:srgbClr val="F6F3EB"/>
                 </a:solidFill>
                 <a:latin typeface="Arial"/>
                 <a:ea typeface="Arial"/>
@@ -17103,15 +17194,1295 @@
               </a:defRPr>
             </a:pPr>
             <a:r>
-              <a:rPr sz="2250" b="1">
-                <a:solidFill>
-                  <a:srgbClr val="C48730"/>
+              <a:rPr sz="1800" b="0">
+                <a:solidFill>
+                  <a:srgbClr val="F6F3EB"/>
                 </a:solidFill>
                 <a:latin typeface="Arial"/>
                 <a:ea typeface="Arial"/>
                 <a:cs typeface="Arial"/>
               </a:rPr>
-              <a:t>Unidade e tipo de vazão não informados no PDF</a:t>
+              <a:t>jan/1931 a dez/2016</a:t>
+            </a:r>
+          </a:p>
+        </p:txBody>
+      </p:sp>
+      <p:sp>
+        <p:nvSpPr>
+          <p:cNvPr id="10" name="">
+            <a:extLst xmlns:a="http://schemas.openxmlformats.org/drawingml/2006/main">
+              <a:ext uri="{FF2B5EF4-FFF2-40B4-BE49-F238E27FC236}">
+                <a16:creationId xmlns:a16="http://schemas.microsoft.com/office/drawing/2014/main" id="{D926EFFA-908C-4A54-BE46-2AD9A05D4204}"/>
+              </a:ext>
+            </a:extLst>
+          </p:cNvPr>
+          <p:cNvSpPr>
+            <a:spLocks xmlns:a="http://schemas.openxmlformats.org/drawingml/2006/main" noGrp="1"/>
+          </p:cNvSpPr>
+          <p:nvPr/>
+        </p:nvSpPr>
+        <p:spPr>
+          <a:xfrm xmlns:a="http://schemas.openxmlformats.org/drawingml/2006/main">
+            <a:off x="8296275" y="1638300"/>
+            <a:ext cx="3095625" cy="619125"/>
+          </a:xfrm>
+          <a:prstGeom xmlns:a="http://schemas.openxmlformats.org/drawingml/2006/main" prst="rect">
+            <a:avLst/>
+          </a:prstGeom>
+          <a:noFill xmlns:a="http://schemas.openxmlformats.org/drawingml/2006/main"/>
+          <a:ln xmlns:a="http://schemas.openxmlformats.org/drawingml/2006/main" w="0">
+            <a:noFill/>
+          </a:ln>
+        </p:spPr>
+        <p:txBody>
+          <a:bodyPr xmlns:a="http://schemas.openxmlformats.org/drawingml/2006/main">
+            <a:noAutofit/>
+          </a:bodyPr>
+          <a:lstStyle xmlns:a="http://schemas.openxmlformats.org/drawingml/2006/main">
+            <a:defPPr>
+              <a:defRPr sz="3600" b="1">
+                <a:solidFill>
+                  <a:srgbClr val="102E3A"/>
+                </a:solidFill>
+                <a:latin typeface="Arial"/>
+                <a:ea typeface="Arial"/>
+                <a:cs typeface="Arial"/>
+              </a:defRPr>
+            </a:defPPr>
+          </a:lstStyle>
+          <a:p xmlns:a="http://schemas.openxmlformats.org/drawingml/2006/main">
+            <a:pPr>
+              <a:defRPr sz="3600" b="1">
+                <a:solidFill>
+                  <a:srgbClr val="102E3A"/>
+                </a:solidFill>
+                <a:latin typeface="Arial"/>
+                <a:ea typeface="Arial"/>
+                <a:cs typeface="Arial"/>
+              </a:defRPr>
+            </a:pPr>
+            <a:r>
+              <a:rPr sz="3600" b="1">
+                <a:solidFill>
+                  <a:srgbClr val="102E3A"/>
+                </a:solidFill>
+                <a:latin typeface="Arial"/>
+                <a:ea typeface="Arial"/>
+                <a:cs typeface="Arial"/>
+              </a:rPr>
+              <a:t>12 por ano</a:t>
+            </a:r>
+          </a:p>
+        </p:txBody>
+      </p:sp>
+      <p:sp>
+        <p:nvSpPr>
+          <p:cNvPr id="11" name="">
+            <a:extLst xmlns:a="http://schemas.openxmlformats.org/drawingml/2006/main">
+              <a:ext uri="{FF2B5EF4-FFF2-40B4-BE49-F238E27FC236}">
+                <a16:creationId xmlns:a16="http://schemas.microsoft.com/office/drawing/2014/main" id="{46CBED94-604B-447A-9259-6F9A7B9C7769}"/>
+              </a:ext>
+            </a:extLst>
+          </p:cNvPr>
+          <p:cNvSpPr>
+            <a:spLocks xmlns:a="http://schemas.openxmlformats.org/drawingml/2006/main" noGrp="1"/>
+          </p:cNvSpPr>
+          <p:nvPr/>
+        </p:nvSpPr>
+        <p:spPr>
+          <a:xfrm xmlns:a="http://schemas.openxmlformats.org/drawingml/2006/main">
+            <a:off x="8315325" y="2352675"/>
+            <a:ext cx="3095625" cy="342900"/>
+          </a:xfrm>
+          <a:prstGeom xmlns:a="http://schemas.openxmlformats.org/drawingml/2006/main" prst="rect">
+            <a:avLst/>
+          </a:prstGeom>
+          <a:noFill xmlns:a="http://schemas.openxmlformats.org/drawingml/2006/main"/>
+          <a:ln xmlns:a="http://schemas.openxmlformats.org/drawingml/2006/main" w="0">
+            <a:noFill/>
+          </a:ln>
+        </p:spPr>
+        <p:txBody>
+          <a:bodyPr xmlns:a="http://schemas.openxmlformats.org/drawingml/2006/main">
+            <a:noAutofit/>
+          </a:bodyPr>
+          <a:lstStyle xmlns:a="http://schemas.openxmlformats.org/drawingml/2006/main">
+            <a:defPPr>
+              <a:defRPr sz="1650" b="0">
+                <a:solidFill>
+                  <a:srgbClr val="102E3A"/>
+                </a:solidFill>
+                <a:latin typeface="Arial"/>
+                <a:ea typeface="Arial"/>
+                <a:cs typeface="Arial"/>
+              </a:defRPr>
+            </a:defPPr>
+          </a:lstStyle>
+          <a:p xmlns:a="http://schemas.openxmlformats.org/drawingml/2006/main">
+            <a:pPr>
+              <a:defRPr sz="1650" b="0">
+                <a:solidFill>
+                  <a:srgbClr val="102E3A"/>
+                </a:solidFill>
+                <a:latin typeface="Arial"/>
+                <a:ea typeface="Arial"/>
+                <a:cs typeface="Arial"/>
+              </a:defRPr>
+            </a:pPr>
+            <a:r>
+              <a:rPr sz="1650" b="0">
+                <a:solidFill>
+                  <a:srgbClr val="102E3A"/>
+                </a:solidFill>
+                <a:latin typeface="Arial"/>
+                <a:ea typeface="Arial"/>
+                <a:cs typeface="Arial"/>
+              </a:rPr>
+              <a:t>frequência mensal regular</a:t>
+            </a:r>
+          </a:p>
+        </p:txBody>
+      </p:sp>
+      <p:sp>
+        <p:nvSpPr>
+          <p:cNvPr id="12" name="Estrutura e qualidade da base">
+            <a:extLst xmlns:a="http://schemas.openxmlformats.org/drawingml/2006/main">
+              <a:ext uri="{FF2B5EF4-FFF2-40B4-BE49-F238E27FC236}">
+                <a16:creationId xmlns:a16="http://schemas.microsoft.com/office/drawing/2014/main" id="{DECDFD2C-7E4C-4893-ABC2-64729B3428E0}"/>
+              </a:ext>
+            </a:extLst>
+          </p:cNvPr>
+          <p:cNvSpPr>
+            <a:spLocks xmlns:a="http://schemas.openxmlformats.org/drawingml/2006/main" noGrp="1"/>
+          </p:cNvSpPr>
+          <p:nvPr/>
+        </p:nvSpPr>
+        <p:spPr>
+          <a:xfrm xmlns:a="http://schemas.openxmlformats.org/drawingml/2006/main">
+            <a:off x="609600" y="3105150"/>
+            <a:ext cx="7086600" cy="2362200"/>
+          </a:xfrm>
+          <a:prstGeom xmlns:a="http://schemas.openxmlformats.org/drawingml/2006/main" prst="roundRect">
+            <a:avLst>
+              <a:gd name="adj" fmla="val 7258"/>
+            </a:avLst>
+          </a:prstGeom>
+          <a:solidFill xmlns:a="http://schemas.openxmlformats.org/drawingml/2006/main">
+            <a:srgbClr val="1B414D"/>
+          </a:solidFill>
+          <a:ln xmlns:a="http://schemas.openxmlformats.org/drawingml/2006/main" w="0">
+            <a:noFill/>
+          </a:ln>
+        </p:spPr>
+      </p:sp>
+      <p:sp>
+        <p:nvSpPr>
+          <p:cNvPr id="13" name="">
+            <a:extLst xmlns:a="http://schemas.openxmlformats.org/drawingml/2006/main">
+              <a:ext uri="{FF2B5EF4-FFF2-40B4-BE49-F238E27FC236}">
+                <a16:creationId xmlns:a16="http://schemas.microsoft.com/office/drawing/2014/main" id="{675BC082-49DD-48C5-96E1-4DF0180452EC}"/>
+              </a:ext>
+            </a:extLst>
+          </p:cNvPr>
+          <p:cNvSpPr>
+            <a:spLocks xmlns:a="http://schemas.openxmlformats.org/drawingml/2006/main" noGrp="1"/>
+          </p:cNvSpPr>
+          <p:nvPr/>
+        </p:nvSpPr>
+        <p:spPr>
+          <a:xfrm xmlns:a="http://schemas.openxmlformats.org/drawingml/2006/main">
+            <a:off x="819150" y="3228975"/>
+            <a:ext cx="6667500" cy="409575"/>
+          </a:xfrm>
+          <a:prstGeom xmlns:a="http://schemas.openxmlformats.org/drawingml/2006/main" prst="rect">
+            <a:avLst/>
+          </a:prstGeom>
+          <a:noFill xmlns:a="http://schemas.openxmlformats.org/drawingml/2006/main"/>
+          <a:ln xmlns:a="http://schemas.openxmlformats.org/drawingml/2006/main" w="0">
+            <a:noFill/>
+          </a:ln>
+        </p:spPr>
+        <p:txBody>
+          <a:bodyPr xmlns:a="http://schemas.openxmlformats.org/drawingml/2006/main">
+            <a:noAutofit/>
+          </a:bodyPr>
+          <a:lstStyle xmlns:a="http://schemas.openxmlformats.org/drawingml/2006/main">
+            <a:defPPr>
+              <a:defRPr sz="2100" b="1">
+                <a:solidFill>
+                  <a:srgbClr val="F6F3EB"/>
+                </a:solidFill>
+                <a:latin typeface="Arial"/>
+                <a:ea typeface="Arial"/>
+                <a:cs typeface="Arial"/>
+              </a:defRPr>
+            </a:defPPr>
+          </a:lstStyle>
+          <a:p xmlns:a="http://schemas.openxmlformats.org/drawingml/2006/main">
+            <a:pPr>
+              <a:defRPr sz="2100" b="1">
+                <a:solidFill>
+                  <a:srgbClr val="F6F3EB"/>
+                </a:solidFill>
+                <a:latin typeface="Arial"/>
+                <a:ea typeface="Arial"/>
+                <a:cs typeface="Arial"/>
+              </a:defRPr>
+            </a:pPr>
+            <a:r>
+              <a:rPr sz="2100" b="1">
+                <a:solidFill>
+                  <a:srgbClr val="F6F3EB"/>
+                </a:solidFill>
+                <a:latin typeface="Arial"/>
+                <a:ea typeface="Arial"/>
+                <a:cs typeface="Arial"/>
+              </a:rPr>
+              <a:t>Da tabela do PDF à série temporal</a:t>
+            </a:r>
+          </a:p>
+        </p:txBody>
+      </p:sp>
+      <p:sp>
+        <p:nvSpPr>
+          <p:cNvPr id="14" name="Formato original">
+            <a:extLst xmlns:a="http://schemas.openxmlformats.org/drawingml/2006/main">
+              <a:ext uri="{FF2B5EF4-FFF2-40B4-BE49-F238E27FC236}">
+                <a16:creationId xmlns:a16="http://schemas.microsoft.com/office/drawing/2014/main" id="{7DBA1E32-5BE4-4B18-8395-6EBBC6D8BAAD}"/>
+              </a:ext>
+            </a:extLst>
+          </p:cNvPr>
+          <p:cNvSpPr>
+            <a:spLocks xmlns:a="http://schemas.openxmlformats.org/drawingml/2006/main" noGrp="1"/>
+          </p:cNvSpPr>
+          <p:nvPr/>
+        </p:nvSpPr>
+        <p:spPr>
+          <a:xfrm xmlns:a="http://schemas.openxmlformats.org/drawingml/2006/main">
+            <a:off x="838200" y="3790950"/>
+            <a:ext cx="2533650" cy="781050"/>
+          </a:xfrm>
+          <a:prstGeom xmlns:a="http://schemas.openxmlformats.org/drawingml/2006/main" prst="roundRect">
+            <a:avLst>
+              <a:gd name="adj" fmla="val 21951"/>
+            </a:avLst>
+          </a:prstGeom>
+          <a:solidFill xmlns:a="http://schemas.openxmlformats.org/drawingml/2006/main">
+            <a:srgbClr val="285563"/>
+          </a:solidFill>
+          <a:ln xmlns:a="http://schemas.openxmlformats.org/drawingml/2006/main" w="0">
+            <a:noFill/>
+          </a:ln>
+        </p:spPr>
+      </p:sp>
+      <p:sp>
+        <p:nvSpPr>
+          <p:cNvPr id="15" name="Formato organizado">
+            <a:extLst xmlns:a="http://schemas.openxmlformats.org/drawingml/2006/main">
+              <a:ext uri="{FF2B5EF4-FFF2-40B4-BE49-F238E27FC236}">
+                <a16:creationId xmlns:a16="http://schemas.microsoft.com/office/drawing/2014/main" id="{B77B2EF7-CCD4-4BF4-A3F5-4CDF572580F6}"/>
+              </a:ext>
+            </a:extLst>
+          </p:cNvPr>
+          <p:cNvSpPr>
+            <a:spLocks xmlns:a="http://schemas.openxmlformats.org/drawingml/2006/main" noGrp="1"/>
+          </p:cNvSpPr>
+          <p:nvPr/>
+        </p:nvSpPr>
+        <p:spPr>
+          <a:xfrm xmlns:a="http://schemas.openxmlformats.org/drawingml/2006/main">
+            <a:off x="3905250" y="3790950"/>
+            <a:ext cx="3562350" cy="781050"/>
+          </a:xfrm>
+          <a:prstGeom xmlns:a="http://schemas.openxmlformats.org/drawingml/2006/main" prst="roundRect">
+            <a:avLst>
+              <a:gd name="adj" fmla="val 21951"/>
+            </a:avLst>
+          </a:prstGeom>
+          <a:solidFill xmlns:a="http://schemas.openxmlformats.org/drawingml/2006/main">
+            <a:srgbClr val="D5E9E4"/>
+          </a:solidFill>
+          <a:ln xmlns:a="http://schemas.openxmlformats.org/drawingml/2006/main" w="0">
+            <a:noFill/>
+          </a:ln>
+        </p:spPr>
+      </p:sp>
+      <p:sp>
+        <p:nvSpPr>
+          <p:cNvPr id="16" name="Transformação da tabela anual em série mensal">
+            <a:extLst xmlns:a="http://schemas.openxmlformats.org/drawingml/2006/main">
+              <a:ext uri="{FF2B5EF4-FFF2-40B4-BE49-F238E27FC236}">
+                <a16:creationId xmlns:a16="http://schemas.microsoft.com/office/drawing/2014/main" id="{13892C9C-A1C7-4974-9FB8-94DFEFC7D402}"/>
+              </a:ext>
+            </a:extLst>
+          </p:cNvPr>
+          <p:cNvSpPr>
+            <a:spLocks xmlns:a="http://schemas.openxmlformats.org/drawingml/2006/main" noGrp="1"/>
+          </p:cNvSpPr>
+          <p:nvPr/>
+        </p:nvSpPr>
+        <p:spPr>
+          <a:xfrm xmlns:a="http://schemas.openxmlformats.org/drawingml/2006/main">
+            <a:off x="3514725" y="4048125"/>
+            <a:ext cx="247650" cy="257175"/>
+          </a:xfrm>
+          <a:prstGeom xmlns:a="http://schemas.openxmlformats.org/drawingml/2006/main" prst="rightArrow">
+            <a:avLst/>
+          </a:prstGeom>
+          <a:solidFill xmlns:a="http://schemas.openxmlformats.org/drawingml/2006/main">
+            <a:srgbClr val="D9AC69"/>
+          </a:solidFill>
+          <a:ln xmlns:a="http://schemas.openxmlformats.org/drawingml/2006/main" w="0">
+            <a:noFill/>
+          </a:ln>
+        </p:spPr>
+      </p:sp>
+      <p:sp>
+        <p:nvSpPr>
+          <p:cNvPr id="17" name="">
+            <a:extLst xmlns:a="http://schemas.openxmlformats.org/drawingml/2006/main">
+              <a:ext uri="{FF2B5EF4-FFF2-40B4-BE49-F238E27FC236}">
+                <a16:creationId xmlns:a16="http://schemas.microsoft.com/office/drawing/2014/main" id="{B86E92C7-D07F-4CCF-BB21-83F24BBBE44A}"/>
+              </a:ext>
+            </a:extLst>
+          </p:cNvPr>
+          <p:cNvSpPr>
+            <a:spLocks xmlns:a="http://schemas.openxmlformats.org/drawingml/2006/main" noGrp="1"/>
+          </p:cNvSpPr>
+          <p:nvPr/>
+        </p:nvSpPr>
+        <p:spPr>
+          <a:xfrm xmlns:a="http://schemas.openxmlformats.org/drawingml/2006/main">
+            <a:off x="942975" y="3876675"/>
+            <a:ext cx="2333625" cy="323850"/>
+          </a:xfrm>
+          <a:prstGeom xmlns:a="http://schemas.openxmlformats.org/drawingml/2006/main" prst="rect">
+            <a:avLst/>
+          </a:prstGeom>
+          <a:noFill xmlns:a="http://schemas.openxmlformats.org/drawingml/2006/main"/>
+          <a:ln xmlns:a="http://schemas.openxmlformats.org/drawingml/2006/main" w="0">
+            <a:noFill/>
+          </a:ln>
+        </p:spPr>
+        <p:txBody>
+          <a:bodyPr xmlns:a="http://schemas.openxmlformats.org/drawingml/2006/main">
+            <a:noAutofit/>
+          </a:bodyPr>
+          <a:lstStyle xmlns:a="http://schemas.openxmlformats.org/drawingml/2006/main">
+            <a:defPPr>
+              <a:defRPr sz="1725" b="1">
+                <a:solidFill>
+                  <a:srgbClr val="F6F3EB"/>
+                </a:solidFill>
+                <a:latin typeface="Arial"/>
+                <a:ea typeface="Arial"/>
+                <a:cs typeface="Arial"/>
+              </a:defRPr>
+            </a:defPPr>
+          </a:lstStyle>
+          <a:p xmlns:a="http://schemas.openxmlformats.org/drawingml/2006/main">
+            <a:pPr>
+              <a:defRPr sz="1725" b="1">
+                <a:solidFill>
+                  <a:srgbClr val="F6F3EB"/>
+                </a:solidFill>
+                <a:latin typeface="Arial"/>
+                <a:ea typeface="Arial"/>
+                <a:cs typeface="Arial"/>
+              </a:defRPr>
+            </a:pPr>
+            <a:r>
+              <a:rPr sz="1725" b="1">
+                <a:solidFill>
+                  <a:srgbClr val="F6F3EB"/>
+                </a:solidFill>
+                <a:latin typeface="Arial"/>
+                <a:ea typeface="Arial"/>
+                <a:cs typeface="Arial"/>
+              </a:rPr>
+              <a:t>86 linhas anuais</a:t>
+            </a:r>
+          </a:p>
+        </p:txBody>
+      </p:sp>
+      <p:sp>
+        <p:nvSpPr>
+          <p:cNvPr id="18" name="">
+            <a:extLst xmlns:a="http://schemas.openxmlformats.org/drawingml/2006/main">
+              <a:ext uri="{FF2B5EF4-FFF2-40B4-BE49-F238E27FC236}">
+                <a16:creationId xmlns:a16="http://schemas.microsoft.com/office/drawing/2014/main" id="{E9F19667-9089-464B-851F-9B53C0A794A3}"/>
+              </a:ext>
+            </a:extLst>
+          </p:cNvPr>
+          <p:cNvSpPr>
+            <a:spLocks xmlns:a="http://schemas.openxmlformats.org/drawingml/2006/main" noGrp="1"/>
+          </p:cNvSpPr>
+          <p:nvPr/>
+        </p:nvSpPr>
+        <p:spPr>
+          <a:xfrm xmlns:a="http://schemas.openxmlformats.org/drawingml/2006/main">
+            <a:off x="942975" y="4248150"/>
+            <a:ext cx="2333625" cy="276225"/>
+          </a:xfrm>
+          <a:prstGeom xmlns:a="http://schemas.openxmlformats.org/drawingml/2006/main" prst="rect">
+            <a:avLst/>
+          </a:prstGeom>
+          <a:noFill xmlns:a="http://schemas.openxmlformats.org/drawingml/2006/main"/>
+          <a:ln xmlns:a="http://schemas.openxmlformats.org/drawingml/2006/main" w="0">
+            <a:noFill/>
+          </a:ln>
+        </p:spPr>
+        <p:txBody>
+          <a:bodyPr xmlns:a="http://schemas.openxmlformats.org/drawingml/2006/main">
+            <a:noAutofit/>
+          </a:bodyPr>
+          <a:lstStyle xmlns:a="http://schemas.openxmlformats.org/drawingml/2006/main">
+            <a:defPPr>
+              <a:defRPr sz="1575" b="0">
+                <a:solidFill>
+                  <a:srgbClr val="F6F3EB"/>
+                </a:solidFill>
+                <a:latin typeface="Arial"/>
+                <a:ea typeface="Arial"/>
+                <a:cs typeface="Arial"/>
+              </a:defRPr>
+            </a:defPPr>
+          </a:lstStyle>
+          <a:p xmlns:a="http://schemas.openxmlformats.org/drawingml/2006/main">
+            <a:pPr>
+              <a:defRPr sz="1575" b="0">
+                <a:solidFill>
+                  <a:srgbClr val="F6F3EB"/>
+                </a:solidFill>
+                <a:latin typeface="Arial"/>
+                <a:ea typeface="Arial"/>
+                <a:cs typeface="Arial"/>
+              </a:defRPr>
+            </a:pPr>
+            <a:r>
+              <a:rPr sz="1575" b="0">
+                <a:solidFill>
+                  <a:srgbClr val="F6F3EB"/>
+                </a:solidFill>
+                <a:latin typeface="Arial"/>
+                <a:ea typeface="Arial"/>
+                <a:cs typeface="Arial"/>
+              </a:rPr>
+              <a:t>12 colunas de meses</a:t>
+            </a:r>
+          </a:p>
+        </p:txBody>
+      </p:sp>
+      <p:sp>
+        <p:nvSpPr>
+          <p:cNvPr id="19" name="">
+            <a:extLst xmlns:a="http://schemas.openxmlformats.org/drawingml/2006/main">
+              <a:ext uri="{FF2B5EF4-FFF2-40B4-BE49-F238E27FC236}">
+                <a16:creationId xmlns:a16="http://schemas.microsoft.com/office/drawing/2014/main" id="{5D3E39DD-6636-4448-B65E-DE04F23FF4E5}"/>
+              </a:ext>
+            </a:extLst>
+          </p:cNvPr>
+          <p:cNvSpPr>
+            <a:spLocks xmlns:a="http://schemas.openxmlformats.org/drawingml/2006/main" noGrp="1"/>
+          </p:cNvSpPr>
+          <p:nvPr/>
+        </p:nvSpPr>
+        <p:spPr>
+          <a:xfrm xmlns:a="http://schemas.openxmlformats.org/drawingml/2006/main">
+            <a:off x="4029075" y="3876675"/>
+            <a:ext cx="3305175" cy="323850"/>
+          </a:xfrm>
+          <a:prstGeom xmlns:a="http://schemas.openxmlformats.org/drawingml/2006/main" prst="rect">
+            <a:avLst/>
+          </a:prstGeom>
+          <a:noFill xmlns:a="http://schemas.openxmlformats.org/drawingml/2006/main"/>
+          <a:ln xmlns:a="http://schemas.openxmlformats.org/drawingml/2006/main" w="0">
+            <a:noFill/>
+          </a:ln>
+        </p:spPr>
+        <p:txBody>
+          <a:bodyPr xmlns:a="http://schemas.openxmlformats.org/drawingml/2006/main">
+            <a:noAutofit/>
+          </a:bodyPr>
+          <a:lstStyle xmlns:a="http://schemas.openxmlformats.org/drawingml/2006/main">
+            <a:defPPr>
+              <a:defRPr sz="1725" b="1">
+                <a:solidFill>
+                  <a:srgbClr val="102E3A"/>
+                </a:solidFill>
+                <a:latin typeface="Arial"/>
+                <a:ea typeface="Arial"/>
+                <a:cs typeface="Arial"/>
+              </a:defRPr>
+            </a:defPPr>
+          </a:lstStyle>
+          <a:p xmlns:a="http://schemas.openxmlformats.org/drawingml/2006/main">
+            <a:pPr>
+              <a:defRPr sz="1725" b="1">
+                <a:solidFill>
+                  <a:srgbClr val="102E3A"/>
+                </a:solidFill>
+                <a:latin typeface="Arial"/>
+                <a:ea typeface="Arial"/>
+                <a:cs typeface="Arial"/>
+              </a:defRPr>
+            </a:pPr>
+            <a:r>
+              <a:rPr sz="1725" b="1">
+                <a:solidFill>
+                  <a:srgbClr val="102E3A"/>
+                </a:solidFill>
+                <a:latin typeface="Arial"/>
+                <a:ea typeface="Arial"/>
+                <a:cs typeface="Arial"/>
+              </a:rPr>
+              <a:t>1.032 linhas mensais</a:t>
+            </a:r>
+          </a:p>
+        </p:txBody>
+      </p:sp>
+      <p:sp>
+        <p:nvSpPr>
+          <p:cNvPr id="20" name="">
+            <a:extLst xmlns:a="http://schemas.openxmlformats.org/drawingml/2006/main">
+              <a:ext uri="{FF2B5EF4-FFF2-40B4-BE49-F238E27FC236}">
+                <a16:creationId xmlns:a16="http://schemas.microsoft.com/office/drawing/2014/main" id="{9B44C262-BB57-4A82-B0C6-34878D5638CC}"/>
+              </a:ext>
+            </a:extLst>
+          </p:cNvPr>
+          <p:cNvSpPr>
+            <a:spLocks xmlns:a="http://schemas.openxmlformats.org/drawingml/2006/main" noGrp="1"/>
+          </p:cNvSpPr>
+          <p:nvPr/>
+        </p:nvSpPr>
+        <p:spPr>
+          <a:xfrm xmlns:a="http://schemas.openxmlformats.org/drawingml/2006/main">
+            <a:off x="4029075" y="4248150"/>
+            <a:ext cx="3305175" cy="276225"/>
+          </a:xfrm>
+          <a:prstGeom xmlns:a="http://schemas.openxmlformats.org/drawingml/2006/main" prst="rect">
+            <a:avLst/>
+          </a:prstGeom>
+          <a:noFill xmlns:a="http://schemas.openxmlformats.org/drawingml/2006/main"/>
+          <a:ln xmlns:a="http://schemas.openxmlformats.org/drawingml/2006/main" w="0">
+            <a:noFill/>
+          </a:ln>
+        </p:spPr>
+        <p:txBody>
+          <a:bodyPr xmlns:a="http://schemas.openxmlformats.org/drawingml/2006/main">
+            <a:noAutofit/>
+          </a:bodyPr>
+          <a:lstStyle xmlns:a="http://schemas.openxmlformats.org/drawingml/2006/main">
+            <a:defPPr>
+              <a:defRPr sz="1425" b="0">
+                <a:solidFill>
+                  <a:srgbClr val="102E3A"/>
+                </a:solidFill>
+                <a:latin typeface="Arial"/>
+                <a:ea typeface="Arial"/>
+                <a:cs typeface="Arial"/>
+              </a:defRPr>
+            </a:defPPr>
+          </a:lstStyle>
+          <a:p xmlns:a="http://schemas.openxmlformats.org/drawingml/2006/main">
+            <a:pPr>
+              <a:defRPr sz="1425" b="0">
+                <a:solidFill>
+                  <a:srgbClr val="102E3A"/>
+                </a:solidFill>
+                <a:latin typeface="Arial"/>
+                <a:ea typeface="Arial"/>
+                <a:cs typeface="Arial"/>
+              </a:defRPr>
+            </a:pPr>
+            <a:r>
+              <a:rPr sz="1425" b="0">
+                <a:solidFill>
+                  <a:srgbClr val="102E3A"/>
+                </a:solidFill>
+                <a:latin typeface="Arial"/>
+                <a:ea typeface="Arial"/>
+                <a:cs typeface="Arial"/>
+              </a:rPr>
+              <a:t>data, vazão + referência no PDF</a:t>
+            </a:r>
+          </a:p>
+        </p:txBody>
+      </p:sp>
+      <p:sp>
+        <p:nvSpPr>
+          <p:cNvPr id="21" name="">
+            <a:extLst xmlns:a="http://schemas.openxmlformats.org/drawingml/2006/main">
+              <a:ext uri="{FF2B5EF4-FFF2-40B4-BE49-F238E27FC236}">
+                <a16:creationId xmlns:a16="http://schemas.microsoft.com/office/drawing/2014/main" id="{4E56D796-2C77-4DE6-9924-E31947F75BA4}"/>
+              </a:ext>
+            </a:extLst>
+          </p:cNvPr>
+          <p:cNvSpPr>
+            <a:spLocks xmlns:a="http://schemas.openxmlformats.org/drawingml/2006/main" noGrp="1"/>
+          </p:cNvSpPr>
+          <p:nvPr/>
+        </p:nvSpPr>
+        <p:spPr>
+          <a:xfrm xmlns:a="http://schemas.openxmlformats.org/drawingml/2006/main">
+            <a:off x="838200" y="4781550"/>
+            <a:ext cx="6629400" cy="619125"/>
+          </a:xfrm>
+          <a:prstGeom xmlns:a="http://schemas.openxmlformats.org/drawingml/2006/main" prst="rect">
+            <a:avLst/>
+          </a:prstGeom>
+          <a:noFill xmlns:a="http://schemas.openxmlformats.org/drawingml/2006/main"/>
+          <a:ln xmlns:a="http://schemas.openxmlformats.org/drawingml/2006/main" w="0">
+            <a:noFill/>
+          </a:ln>
+        </p:spPr>
+        <p:txBody>
+          <a:bodyPr xmlns:a="http://schemas.openxmlformats.org/drawingml/2006/main">
+            <a:noAutofit/>
+          </a:bodyPr>
+          <a:lstStyle xmlns:a="http://schemas.openxmlformats.org/drawingml/2006/main">
+            <a:defPPr>
+              <a:defRPr sz="1725" b="0">
+                <a:solidFill>
+                  <a:srgbClr val="F6F3EB"/>
+                </a:solidFill>
+                <a:latin typeface="Arial"/>
+                <a:ea typeface="Arial"/>
+                <a:cs typeface="Arial"/>
+              </a:defRPr>
+            </a:defPPr>
+          </a:lstStyle>
+          <a:p xmlns:a="http://schemas.openxmlformats.org/drawingml/2006/main">
+            <a:pPr>
+              <a:defRPr sz="1725" b="0">
+                <a:solidFill>
+                  <a:srgbClr val="F6F3EB"/>
+                </a:solidFill>
+                <a:latin typeface="Arial"/>
+                <a:ea typeface="Arial"/>
+                <a:cs typeface="Arial"/>
+              </a:defRPr>
+            </a:pPr>
+            <a:r>
+              <a:rPr sz="1725" b="0">
+                <a:solidFill>
+                  <a:srgbClr val="F6F3EB"/>
+                </a:solidFill>
+                <a:latin typeface="Arial"/>
+                <a:ea typeface="Arial"/>
+                <a:cs typeface="Arial"/>
+              </a:rPr>
+              <a:t>Sem meses ausentes ou duplicados.</a:t>
+            </a:r>
+          </a:p>
+          <a:p xmlns:a="http://schemas.openxmlformats.org/drawingml/2006/main">
+            <a:pPr>
+              <a:defRPr sz="1725" b="0">
+                <a:solidFill>
+                  <a:srgbClr val="F6F3EB"/>
+                </a:solidFill>
+                <a:latin typeface="Arial"/>
+                <a:ea typeface="Arial"/>
+                <a:cs typeface="Arial"/>
+              </a:defRPr>
+            </a:pPr>
+            <a:r>
+              <a:rPr sz="1725" b="0">
+                <a:solidFill>
+                  <a:srgbClr val="F6F3EB"/>
+                </a:solidFill>
+                <a:latin typeface="Arial"/>
+                <a:ea typeface="Arial"/>
+                <a:cs typeface="Arial"/>
+              </a:rPr>
+              <a:t>Todos os valores são positivos.</a:t>
+            </a:r>
+          </a:p>
+        </p:txBody>
+      </p:sp>
+      <p:sp>
+        <p:nvSpPr>
+          <p:cNvPr id="22" name="Estatísticas descritivas da série completa">
+            <a:extLst xmlns:a="http://schemas.openxmlformats.org/drawingml/2006/main">
+              <a:ext uri="{FF2B5EF4-FFF2-40B4-BE49-F238E27FC236}">
+                <a16:creationId xmlns:a16="http://schemas.microsoft.com/office/drawing/2014/main" id="{3E3133C7-5AC5-46D3-9D18-D3BA4ABBB73A}"/>
+              </a:ext>
+            </a:extLst>
+          </p:cNvPr>
+          <p:cNvSpPr>
+            <a:spLocks xmlns:a="http://schemas.openxmlformats.org/drawingml/2006/main" noGrp="1"/>
+          </p:cNvSpPr>
+          <p:nvPr/>
+        </p:nvSpPr>
+        <p:spPr>
+          <a:xfrm xmlns:a="http://schemas.openxmlformats.org/drawingml/2006/main">
+            <a:off x="7924800" y="3105150"/>
+            <a:ext cx="3657600" cy="2362200"/>
+          </a:xfrm>
+          <a:prstGeom xmlns:a="http://schemas.openxmlformats.org/drawingml/2006/main" prst="roundRect">
+            <a:avLst>
+              <a:gd name="adj" fmla="val 7258"/>
+            </a:avLst>
+          </a:prstGeom>
+          <a:solidFill xmlns:a="http://schemas.openxmlformats.org/drawingml/2006/main">
+            <a:srgbClr val="F6F3EB"/>
+          </a:solidFill>
+          <a:ln xmlns:a="http://schemas.openxmlformats.org/drawingml/2006/main" w="0">
+            <a:noFill/>
+          </a:ln>
+        </p:spPr>
+      </p:sp>
+      <p:sp>
+        <p:nvSpPr>
+          <p:cNvPr id="23" name="">
+            <a:extLst xmlns:a="http://schemas.openxmlformats.org/drawingml/2006/main">
+              <a:ext uri="{FF2B5EF4-FFF2-40B4-BE49-F238E27FC236}">
+                <a16:creationId xmlns:a16="http://schemas.microsoft.com/office/drawing/2014/main" id="{DA9EDC38-1CC1-4E73-8674-FA479EC7A5C8}"/>
+              </a:ext>
+            </a:extLst>
+          </p:cNvPr>
+          <p:cNvSpPr>
+            <a:spLocks xmlns:a="http://schemas.openxmlformats.org/drawingml/2006/main" noGrp="1"/>
+          </p:cNvSpPr>
+          <p:nvPr/>
+        </p:nvSpPr>
+        <p:spPr>
+          <a:xfrm xmlns:a="http://schemas.openxmlformats.org/drawingml/2006/main">
+            <a:off x="8115300" y="3228975"/>
+            <a:ext cx="3276600" cy="409575"/>
+          </a:xfrm>
+          <a:prstGeom xmlns:a="http://schemas.openxmlformats.org/drawingml/2006/main" prst="rect">
+            <a:avLst/>
+          </a:prstGeom>
+          <a:noFill xmlns:a="http://schemas.openxmlformats.org/drawingml/2006/main"/>
+          <a:ln xmlns:a="http://schemas.openxmlformats.org/drawingml/2006/main" w="0">
+            <a:noFill/>
+          </a:ln>
+        </p:spPr>
+        <p:txBody>
+          <a:bodyPr xmlns:a="http://schemas.openxmlformats.org/drawingml/2006/main">
+            <a:noAutofit/>
+          </a:bodyPr>
+          <a:lstStyle xmlns:a="http://schemas.openxmlformats.org/drawingml/2006/main">
+            <a:defPPr>
+              <a:defRPr sz="2100" b="1">
+                <a:solidFill>
+                  <a:srgbClr val="102E3A"/>
+                </a:solidFill>
+                <a:latin typeface="Arial"/>
+                <a:ea typeface="Arial"/>
+                <a:cs typeface="Arial"/>
+              </a:defRPr>
+            </a:defPPr>
+          </a:lstStyle>
+          <a:p xmlns:a="http://schemas.openxmlformats.org/drawingml/2006/main">
+            <a:pPr>
+              <a:defRPr sz="2100" b="1">
+                <a:solidFill>
+                  <a:srgbClr val="102E3A"/>
+                </a:solidFill>
+                <a:latin typeface="Arial"/>
+                <a:ea typeface="Arial"/>
+                <a:cs typeface="Arial"/>
+              </a:defRPr>
+            </a:pPr>
+            <a:r>
+              <a:rPr sz="2100" b="1">
+                <a:solidFill>
+                  <a:srgbClr val="102E3A"/>
+                </a:solidFill>
+                <a:latin typeface="Arial"/>
+                <a:ea typeface="Arial"/>
+                <a:cs typeface="Arial"/>
+              </a:rPr>
+              <a:t>Valores da série</a:t>
+            </a:r>
+          </a:p>
+        </p:txBody>
+      </p:sp>
+      <p:sp>
+        <p:nvSpPr>
+          <p:cNvPr id="24" name="">
+            <a:extLst xmlns:a="http://schemas.openxmlformats.org/drawingml/2006/main">
+              <a:ext uri="{FF2B5EF4-FFF2-40B4-BE49-F238E27FC236}">
+                <a16:creationId xmlns:a16="http://schemas.microsoft.com/office/drawing/2014/main" id="{4AFE23F4-728E-4253-8A91-F30DB9D10CA8}"/>
+              </a:ext>
+            </a:extLst>
+          </p:cNvPr>
+          <p:cNvSpPr>
+            <a:spLocks xmlns:a="http://schemas.openxmlformats.org/drawingml/2006/main" noGrp="1"/>
+          </p:cNvSpPr>
+          <p:nvPr/>
+        </p:nvSpPr>
+        <p:spPr>
+          <a:xfrm xmlns:a="http://schemas.openxmlformats.org/drawingml/2006/main">
+            <a:off x="8124825" y="3724275"/>
+            <a:ext cx="3276600" cy="1581150"/>
+          </a:xfrm>
+          <a:prstGeom xmlns:a="http://schemas.openxmlformats.org/drawingml/2006/main" prst="rect">
+            <a:avLst/>
+          </a:prstGeom>
+          <a:noFill xmlns:a="http://schemas.openxmlformats.org/drawingml/2006/main"/>
+          <a:ln xmlns:a="http://schemas.openxmlformats.org/drawingml/2006/main" w="0">
+            <a:noFill/>
+          </a:ln>
+        </p:spPr>
+        <p:txBody>
+          <a:bodyPr xmlns:a="http://schemas.openxmlformats.org/drawingml/2006/main">
+            <a:noAutofit/>
+          </a:bodyPr>
+          <a:lstStyle xmlns:a="http://schemas.openxmlformats.org/drawingml/2006/main">
+            <a:defPPr>
+              <a:defRPr sz="1650" b="0">
+                <a:solidFill>
+                  <a:srgbClr val="102E3A"/>
+                </a:solidFill>
+                <a:latin typeface="Arial"/>
+                <a:ea typeface="Arial"/>
+                <a:cs typeface="Arial"/>
+              </a:defRPr>
+            </a:defPPr>
+          </a:lstStyle>
+          <a:p xmlns:a="http://schemas.openxmlformats.org/drawingml/2006/main">
+            <a:pPr>
+              <a:defRPr sz="1650" b="0">
+                <a:solidFill>
+                  <a:srgbClr val="102E3A"/>
+                </a:solidFill>
+                <a:latin typeface="Arial"/>
+                <a:ea typeface="Arial"/>
+                <a:cs typeface="Arial"/>
+              </a:defRPr>
+            </a:pPr>
+            <a:r>
+              <a:rPr sz="1650" b="0">
+                <a:solidFill>
+                  <a:srgbClr val="102E3A"/>
+                </a:solidFill>
+                <a:latin typeface="Arial"/>
+                <a:ea typeface="Arial"/>
+                <a:cs typeface="Arial"/>
+              </a:rPr>
+              <a:t>Média: 5.272</a:t>
+            </a:r>
+          </a:p>
+          <a:p xmlns:a="http://schemas.openxmlformats.org/drawingml/2006/main">
+            <a:pPr>
+              <a:defRPr sz="1650" b="0">
+                <a:solidFill>
+                  <a:srgbClr val="102E3A"/>
+                </a:solidFill>
+                <a:latin typeface="Arial"/>
+                <a:ea typeface="Arial"/>
+                <a:cs typeface="Arial"/>
+              </a:defRPr>
+            </a:pPr>
+            <a:r>
+              <a:rPr sz="1650" b="0">
+                <a:solidFill>
+                  <a:srgbClr val="102E3A"/>
+                </a:solidFill>
+                <a:latin typeface="Arial"/>
+                <a:ea typeface="Arial"/>
+                <a:cs typeface="Arial"/>
+              </a:rPr>
+              <a:t>Mediana: 4.194</a:t>
+            </a:r>
+          </a:p>
+          <a:p xmlns:a="http://schemas.openxmlformats.org/drawingml/2006/main">
+            <a:pPr>
+              <a:defRPr sz="1650" b="0">
+                <a:solidFill>
+                  <a:srgbClr val="102E3A"/>
+                </a:solidFill>
+                <a:latin typeface="Arial"/>
+                <a:ea typeface="Arial"/>
+                <a:cs typeface="Arial"/>
+              </a:defRPr>
+            </a:pPr>
+            <a:r>
+              <a:rPr sz="1650" b="0">
+                <a:solidFill>
+                  <a:srgbClr val="102E3A"/>
+                </a:solidFill>
+                <a:latin typeface="Arial"/>
+                <a:ea typeface="Arial"/>
+                <a:cs typeface="Arial"/>
+              </a:rPr>
+              <a:t>Desvio padrão: 3.095</a:t>
+            </a:r>
+          </a:p>
+          <a:p xmlns:a="http://schemas.openxmlformats.org/drawingml/2006/main">
+            <a:pPr>
+              <a:defRPr sz="1650" b="0">
+                <a:solidFill>
+                  <a:srgbClr val="102E3A"/>
+                </a:solidFill>
+                <a:latin typeface="Arial"/>
+                <a:ea typeface="Arial"/>
+                <a:cs typeface="Arial"/>
+              </a:defRPr>
+            </a:pPr>
+            <a:r>
+              <a:rPr sz="1650" b="0">
+                <a:solidFill>
+                  <a:srgbClr val="102E3A"/>
+                </a:solidFill>
+                <a:latin typeface="Arial"/>
+                <a:ea typeface="Arial"/>
+                <a:cs typeface="Arial"/>
+              </a:rPr>
+              <a:t>Mínimo: 1.212 (out/2014)</a:t>
+            </a:r>
+          </a:p>
+          <a:p xmlns:a="http://schemas.openxmlformats.org/drawingml/2006/main">
+            <a:pPr>
+              <a:defRPr sz="1650" b="0">
+                <a:solidFill>
+                  <a:srgbClr val="102E3A"/>
+                </a:solidFill>
+                <a:latin typeface="Arial"/>
+                <a:ea typeface="Arial"/>
+                <a:cs typeface="Arial"/>
+              </a:defRPr>
+            </a:pPr>
+            <a:r>
+              <a:rPr sz="1650" b="0">
+                <a:solidFill>
+                  <a:srgbClr val="102E3A"/>
+                </a:solidFill>
+                <a:latin typeface="Arial"/>
+                <a:ea typeface="Arial"/>
+                <a:cs typeface="Arial"/>
+              </a:rPr>
+              <a:t>Máximo: 20.314 (fev/1983)</a:t>
+            </a:r>
+          </a:p>
+        </p:txBody>
+      </p:sp>
+      <p:sp>
+        <p:nvSpPr>
+          <p:cNvPr id="25" name="Limitações da fonte">
+            <a:extLst xmlns:a="http://schemas.openxmlformats.org/drawingml/2006/main">
+              <a:ext uri="{FF2B5EF4-FFF2-40B4-BE49-F238E27FC236}">
+                <a16:creationId xmlns:a16="http://schemas.microsoft.com/office/drawing/2014/main" id="{92A23608-B408-4B79-9E79-CB2ECA301757}"/>
+              </a:ext>
+            </a:extLst>
+          </p:cNvPr>
+          <p:cNvSpPr>
+            <a:spLocks xmlns:a="http://schemas.openxmlformats.org/drawingml/2006/main" noGrp="1"/>
+          </p:cNvSpPr>
+          <p:nvPr/>
+        </p:nvSpPr>
+        <p:spPr>
+          <a:xfrm xmlns:a="http://schemas.openxmlformats.org/drawingml/2006/main">
+            <a:off x="609600" y="5657850"/>
+            <a:ext cx="10972800" cy="666750"/>
+          </a:xfrm>
+          <a:prstGeom xmlns:a="http://schemas.openxmlformats.org/drawingml/2006/main" prst="roundRect">
+            <a:avLst>
+              <a:gd name="adj" fmla="val 25714"/>
+            </a:avLst>
+          </a:prstGeom>
+          <a:solidFill xmlns:a="http://schemas.openxmlformats.org/drawingml/2006/main">
+            <a:srgbClr val="D9AC69"/>
+          </a:solidFill>
+          <a:ln xmlns:a="http://schemas.openxmlformats.org/drawingml/2006/main" w="0">
+            <a:noFill/>
+          </a:ln>
+        </p:spPr>
+      </p:sp>
+      <p:sp>
+        <p:nvSpPr>
+          <p:cNvPr id="26" name="">
+            <a:extLst xmlns:a="http://schemas.openxmlformats.org/drawingml/2006/main">
+              <a:ext uri="{FF2B5EF4-FFF2-40B4-BE49-F238E27FC236}">
+                <a16:creationId xmlns:a16="http://schemas.microsoft.com/office/drawing/2014/main" id="{1C4FC6C1-ED75-4C13-87B2-8E8A8E942378}"/>
+              </a:ext>
+            </a:extLst>
+          </p:cNvPr>
+          <p:cNvSpPr>
+            <a:spLocks xmlns:a="http://schemas.openxmlformats.org/drawingml/2006/main" noGrp="1"/>
+          </p:cNvSpPr>
+          <p:nvPr/>
+        </p:nvSpPr>
+        <p:spPr>
+          <a:xfrm xmlns:a="http://schemas.openxmlformats.org/drawingml/2006/main">
+            <a:off x="800100" y="5810250"/>
+            <a:ext cx="2190750" cy="381000"/>
+          </a:xfrm>
+          <a:prstGeom xmlns:a="http://schemas.openxmlformats.org/drawingml/2006/main" prst="rect">
+            <a:avLst/>
+          </a:prstGeom>
+          <a:noFill xmlns:a="http://schemas.openxmlformats.org/drawingml/2006/main"/>
+          <a:ln xmlns:a="http://schemas.openxmlformats.org/drawingml/2006/main" w="0">
+            <a:noFill/>
+          </a:ln>
+        </p:spPr>
+        <p:txBody>
+          <a:bodyPr xmlns:a="http://schemas.openxmlformats.org/drawingml/2006/main">
+            <a:noAutofit/>
+          </a:bodyPr>
+          <a:lstStyle xmlns:a="http://schemas.openxmlformats.org/drawingml/2006/main">
+            <a:defPPr>
+              <a:defRPr sz="1800" b="1">
+                <a:solidFill>
+                  <a:srgbClr val="102E3A"/>
+                </a:solidFill>
+                <a:latin typeface="Arial"/>
+                <a:ea typeface="Arial"/>
+                <a:cs typeface="Arial"/>
+              </a:defRPr>
+            </a:defPPr>
+          </a:lstStyle>
+          <a:p xmlns:a="http://schemas.openxmlformats.org/drawingml/2006/main">
+            <a:pPr>
+              <a:defRPr sz="1800" b="1">
+                <a:solidFill>
+                  <a:srgbClr val="102E3A"/>
+                </a:solidFill>
+                <a:latin typeface="Arial"/>
+                <a:ea typeface="Arial"/>
+                <a:cs typeface="Arial"/>
+              </a:defRPr>
+            </a:pPr>
+            <a:r>
+              <a:rPr sz="1800" b="1">
+                <a:solidFill>
+                  <a:srgbClr val="102E3A"/>
+                </a:solidFill>
+                <a:latin typeface="Arial"/>
+                <a:ea typeface="Arial"/>
+                <a:cs typeface="Arial"/>
+              </a:rPr>
+              <a:t>Limites da fonte</a:t>
+            </a:r>
+          </a:p>
+        </p:txBody>
+      </p:sp>
+      <p:sp>
+        <p:nvSpPr>
+          <p:cNvPr id="27" name="">
+            <a:extLst xmlns:a="http://schemas.openxmlformats.org/drawingml/2006/main">
+              <a:ext uri="{FF2B5EF4-FFF2-40B4-BE49-F238E27FC236}">
+                <a16:creationId xmlns:a16="http://schemas.microsoft.com/office/drawing/2014/main" id="{BC9F8C96-32BC-4429-B28F-03CB91C77CA9}"/>
+              </a:ext>
+            </a:extLst>
+          </p:cNvPr>
+          <p:cNvSpPr>
+            <a:spLocks xmlns:a="http://schemas.openxmlformats.org/drawingml/2006/main" noGrp="1"/>
+          </p:cNvSpPr>
+          <p:nvPr/>
+        </p:nvSpPr>
+        <p:spPr>
+          <a:xfrm xmlns:a="http://schemas.openxmlformats.org/drawingml/2006/main">
+            <a:off x="3076575" y="5734050"/>
+            <a:ext cx="8267700" cy="552450"/>
+          </a:xfrm>
+          <a:prstGeom xmlns:a="http://schemas.openxmlformats.org/drawingml/2006/main" prst="rect">
+            <a:avLst/>
+          </a:prstGeom>
+          <a:noFill xmlns:a="http://schemas.openxmlformats.org/drawingml/2006/main"/>
+          <a:ln xmlns:a="http://schemas.openxmlformats.org/drawingml/2006/main" w="0">
+            <a:noFill/>
+          </a:ln>
+        </p:spPr>
+        <p:txBody>
+          <a:bodyPr xmlns:a="http://schemas.openxmlformats.org/drawingml/2006/main">
+            <a:noAutofit/>
+          </a:bodyPr>
+          <a:lstStyle xmlns:a="http://schemas.openxmlformats.org/drawingml/2006/main">
+            <a:defPPr>
+              <a:defRPr sz="1650" b="0">
+                <a:solidFill>
+                  <a:srgbClr val="102E3A"/>
+                </a:solidFill>
+                <a:latin typeface="Arial"/>
+                <a:ea typeface="Arial"/>
+                <a:cs typeface="Arial"/>
+              </a:defRPr>
+            </a:defPPr>
+          </a:lstStyle>
+          <a:p xmlns:a="http://schemas.openxmlformats.org/drawingml/2006/main">
+            <a:pPr>
+              <a:defRPr sz="1650" b="0">
+                <a:solidFill>
+                  <a:srgbClr val="102E3A"/>
+                </a:solidFill>
+                <a:latin typeface="Arial"/>
+                <a:ea typeface="Arial"/>
+                <a:cs typeface="Arial"/>
+              </a:defRPr>
+            </a:pPr>
+            <a:r>
+              <a:rPr sz="1650" b="0">
+                <a:solidFill>
+                  <a:srgbClr val="102E3A"/>
+                </a:solidFill>
+                <a:latin typeface="Arial"/>
+                <a:ea typeface="Arial"/>
+                <a:cs typeface="Arial"/>
+              </a:rPr>
+              <a:t>Unidade e tipo de vazão não informados.</a:t>
+            </a:r>
+          </a:p>
+          <a:p xmlns:a="http://schemas.openxmlformats.org/drawingml/2006/main">
+            <a:pPr>
+              <a:defRPr sz="1650" b="0">
+                <a:solidFill>
+                  <a:srgbClr val="102E3A"/>
+                </a:solidFill>
+                <a:latin typeface="Arial"/>
+                <a:ea typeface="Arial"/>
+                <a:cs typeface="Arial"/>
+              </a:defRPr>
+            </a:pPr>
+            <a:r>
+              <a:rPr sz="1650" b="0">
+                <a:solidFill>
+                  <a:srgbClr val="102E3A"/>
+                </a:solidFill>
+                <a:latin typeface="Arial"/>
+                <a:ea typeface="Arial"/>
+                <a:cs typeface="Arial"/>
+              </a:rPr>
+              <a:t>A base termina em 2016, sem observações de 2017.</a:t>
+            </a:r>
+          </a:p>
+        </p:txBody>
+      </p:sp>
+      <p:sp>
+        <p:nvSpPr>
+          <p:cNvPr id="28" name="">
+            <a:extLst xmlns:a="http://schemas.openxmlformats.org/drawingml/2006/main">
+              <a:ext uri="{FF2B5EF4-FFF2-40B4-BE49-F238E27FC236}">
+                <a16:creationId xmlns:a16="http://schemas.microsoft.com/office/drawing/2014/main" id="{AA38BC9C-6EE1-4A69-B88D-158CC106B1C9}"/>
+              </a:ext>
+            </a:extLst>
+          </p:cNvPr>
+          <p:cNvSpPr>
+            <a:spLocks xmlns:a="http://schemas.openxmlformats.org/drawingml/2006/main" noGrp="1"/>
+          </p:cNvSpPr>
+          <p:nvPr/>
+        </p:nvSpPr>
+        <p:spPr>
+          <a:xfrm xmlns:a="http://schemas.openxmlformats.org/drawingml/2006/main">
+            <a:off x="609600" y="6400800"/>
+            <a:ext cx="2857500" cy="228600"/>
+          </a:xfrm>
+          <a:prstGeom xmlns:a="http://schemas.openxmlformats.org/drawingml/2006/main" prst="rect">
+            <a:avLst/>
+          </a:prstGeom>
+          <a:noFill xmlns:a="http://schemas.openxmlformats.org/drawingml/2006/main"/>
+          <a:ln xmlns:a="http://schemas.openxmlformats.org/drawingml/2006/main" w="0">
+            <a:noFill/>
+          </a:ln>
+        </p:spPr>
+        <p:txBody>
+          <a:bodyPr xmlns:a="http://schemas.openxmlformats.org/drawingml/2006/main">
+            <a:noAutofit/>
+          </a:bodyPr>
+          <a:lstStyle xmlns:a="http://schemas.openxmlformats.org/drawingml/2006/main">
+            <a:defPPr>
+              <a:defRPr sz="1200" b="0">
+                <a:solidFill>
+                  <a:srgbClr val="A5C8CB"/>
+                </a:solidFill>
+                <a:latin typeface="Arial"/>
+                <a:ea typeface="Arial"/>
+                <a:cs typeface="Arial"/>
+              </a:defRPr>
+            </a:defPPr>
+          </a:lstStyle>
+          <a:p xmlns:a="http://schemas.openxmlformats.org/drawingml/2006/main">
+            <a:pPr>
+              <a:defRPr sz="1200" b="0">
+                <a:solidFill>
+                  <a:srgbClr val="A5C8CB"/>
+                </a:solidFill>
+                <a:latin typeface="Arial"/>
+                <a:ea typeface="Arial"/>
+                <a:cs typeface="Arial"/>
+              </a:defRPr>
+            </a:pPr>
+            <a:r>
+              <a:rPr sz="1200" b="0">
+                <a:solidFill>
+                  <a:srgbClr val="A5C8CB"/>
+                </a:solidFill>
+                <a:latin typeface="Arial"/>
+                <a:ea typeface="Arial"/>
+                <a:cs typeface="Arial"/>
+              </a:rPr>
+              <a:t>03  Ilha Solteira</a:t>
+            </a:r>
+          </a:p>
+        </p:txBody>
+      </p:sp>
+      <p:sp>
+        <p:nvSpPr>
+          <p:cNvPr id="29" name="">
+            <a:extLst xmlns:a="http://schemas.openxmlformats.org/drawingml/2006/main">
+              <a:ext uri="{FF2B5EF4-FFF2-40B4-BE49-F238E27FC236}">
+                <a16:creationId xmlns:a16="http://schemas.microsoft.com/office/drawing/2014/main" id="{86D45A61-56DB-415D-860A-B18DEB4F22F3}"/>
+              </a:ext>
+            </a:extLst>
+          </p:cNvPr>
+          <p:cNvSpPr>
+            <a:spLocks xmlns:a="http://schemas.openxmlformats.org/drawingml/2006/main" noGrp="1"/>
+          </p:cNvSpPr>
+          <p:nvPr/>
+        </p:nvSpPr>
+        <p:spPr>
+          <a:xfrm xmlns:a="http://schemas.openxmlformats.org/drawingml/2006/main">
+            <a:off x="3733800" y="6400800"/>
+            <a:ext cx="7848600" cy="228600"/>
+          </a:xfrm>
+          <a:prstGeom xmlns:a="http://schemas.openxmlformats.org/drawingml/2006/main" prst="rect">
+            <a:avLst/>
+          </a:prstGeom>
+          <a:noFill xmlns:a="http://schemas.openxmlformats.org/drawingml/2006/main"/>
+          <a:ln xmlns:a="http://schemas.openxmlformats.org/drawingml/2006/main" w="0">
+            <a:noFill/>
+          </a:ln>
+        </p:spPr>
+        <p:txBody>
+          <a:bodyPr xmlns:a="http://schemas.openxmlformats.org/drawingml/2006/main">
+            <a:noAutofit/>
+          </a:bodyPr>
+          <a:lstStyle xmlns:a="http://schemas.openxmlformats.org/drawingml/2006/main">
+            <a:defPPr>
+              <a:defRPr sz="1125" b="0">
+                <a:solidFill>
+                  <a:srgbClr val="A5C8CB"/>
+                </a:solidFill>
+                <a:latin typeface="Arial"/>
+                <a:ea typeface="Arial"/>
+                <a:cs typeface="Arial"/>
+              </a:defRPr>
+            </a:defPPr>
+          </a:lstStyle>
+          <a:p xmlns:a="http://schemas.openxmlformats.org/drawingml/2006/main">
+            <a:pPr>
+              <a:defRPr sz="1125" b="0">
+                <a:solidFill>
+                  <a:srgbClr val="A5C8CB"/>
+                </a:solidFill>
+                <a:latin typeface="Arial"/>
+                <a:ea typeface="Arial"/>
+                <a:cs typeface="Arial"/>
+              </a:defRPr>
+            </a:pPr>
+            <a:r>
+              <a:rPr sz="1125" b="0">
+                <a:solidFill>
+                  <a:srgbClr val="A5C8CB"/>
+                </a:solidFill>
+                <a:latin typeface="Arial"/>
+                <a:ea typeface="Arial"/>
+                <a:cs typeface="Arial"/>
+              </a:rPr>
+              <a:t>Fonte: ILHA_SOLTEIRA.pdf. Estatísticas na unidade da tabela, arredondadas.</a:t>
             </a:r>
           </a:p>
         </p:txBody>
@@ -17266,7 +18637,7 @@
           <p:cNvPr id="7" name="Chart">
             <a:extLst xmlns:a="http://schemas.openxmlformats.org/drawingml/2006/main">
               <a:ext uri="{FF2B5EF4-FFF2-40B4-BE49-F238E27FC236}">
-                <a16:creationId xmlns:a16="http://schemas.microsoft.com/office/drawing/2014/main" id="{F3652DA4-4476-4B9B-A8E9-B4E46F2909C4}"/>
+                <a16:creationId xmlns:a16="http://schemas.microsoft.com/office/drawing/2014/main" id="{A6250BBD-E7BD-4E31-8D0E-B2C03C114333}"/>
               </a:ext>
             </a:extLst>
           </p:cNvPr>
@@ -17279,7 +18650,7 @@
         </p:xfrm>
         <a:graphic xmlns:a="http://schemas.openxmlformats.org/drawingml/2006/main">
           <a:graphicData uri="http://schemas.openxmlformats.org/drawingml/2006/chart">
-            <c:chart xmlns:r="http://schemas.openxmlformats.org/officeDocument/2006/relationships" xmlns:c="http://schemas.openxmlformats.org/drawingml/2006/chart" r:id="Rdcb7a35c315d4d0b"/>
+            <c:chart xmlns:r="http://schemas.openxmlformats.org/officeDocument/2006/relationships" xmlns:c="http://schemas.openxmlformats.org/drawingml/2006/chart" r:id="R06eb84eca5404d08"/>
           </a:graphicData>
         </a:graphic>
       </p:graphicFrame>
@@ -19153,7 +20524,7 @@
           <p:cNvPr id="7" name="Chart">
             <a:extLst xmlns:a="http://schemas.openxmlformats.org/drawingml/2006/main">
               <a:ext uri="{FF2B5EF4-FFF2-40B4-BE49-F238E27FC236}">
-                <a16:creationId xmlns:a16="http://schemas.microsoft.com/office/drawing/2014/main" id="{AC7C278B-65B1-47D0-B867-A95640FF6D78}"/>
+                <a16:creationId xmlns:a16="http://schemas.microsoft.com/office/drawing/2014/main" id="{8061BD9C-E405-4A71-A9B5-E0593CE91392}"/>
               </a:ext>
             </a:extLst>
           </p:cNvPr>
@@ -19166,7 +20537,7 @@
         </p:xfrm>
         <a:graphic xmlns:a="http://schemas.openxmlformats.org/drawingml/2006/main">
           <a:graphicData uri="http://schemas.openxmlformats.org/drawingml/2006/chart">
-            <c:chart xmlns:r="http://schemas.openxmlformats.org/officeDocument/2006/relationships" xmlns:c="http://schemas.openxmlformats.org/drawingml/2006/chart" r:id="R7b48a04cae7b4570"/>
+            <c:chart xmlns:r="http://schemas.openxmlformats.org/officeDocument/2006/relationships" xmlns:c="http://schemas.openxmlformats.org/drawingml/2006/chart" r:id="Rc378d40a37714e0c"/>
           </a:graphicData>
         </a:graphic>
       </p:graphicFrame>

</xml_diff>

<commit_message>
Remove a faixa de limites da fonte do slide da base
</commit_message>
<xml_diff>
--- a/output/apresentacao_ilha_solteira.pptx
+++ b/output/apresentacao_ilha_solteira.pptx
@@ -2,28 +2,28 @@
 <file path=ppt/presentation.xml><?xml version="1.0" encoding="utf-8"?>
 <p:presentation xmlns:p="http://schemas.openxmlformats.org/presentationml/2006/main">
   <p:sldMasterIdLst>
-    <p:sldMasterId xmlns:r="http://schemas.openxmlformats.org/officeDocument/2006/relationships" id="2147483648" r:id="Re0e4056bd9d04742"/>
+    <p:sldMasterId xmlns:r="http://schemas.openxmlformats.org/officeDocument/2006/relationships" id="2147483648" r:id="Rd4637e1e9b9f4019"/>
   </p:sldMasterIdLst>
   <p:notesMasterIdLst>
-    <p:notesMasterId xmlns:r="http://schemas.openxmlformats.org/officeDocument/2006/relationships" r:id="Rdfc516f564124b83"/>
+    <p:notesMasterId xmlns:r="http://schemas.openxmlformats.org/officeDocument/2006/relationships" r:id="Rb3193e283b9342ea"/>
   </p:notesMasterIdLst>
   <p:sldIdLst>
-    <p:sldId xmlns:r="http://schemas.openxmlformats.org/officeDocument/2006/relationships" id="256" r:id="R0b60e1c953f64f97"/>
-    <p:sldId xmlns:r="http://schemas.openxmlformats.org/officeDocument/2006/relationships" id="257" r:id="R59d49b89684745a9"/>
-    <p:sldId xmlns:r="http://schemas.openxmlformats.org/officeDocument/2006/relationships" id="258" r:id="Ra9de1b1089ca4d21"/>
-    <p:sldId xmlns:r="http://schemas.openxmlformats.org/officeDocument/2006/relationships" id="259" r:id="R22c53ee2342a45d8"/>
-    <p:sldId xmlns:r="http://schemas.openxmlformats.org/officeDocument/2006/relationships" id="260" r:id="R9e7101b980774424"/>
-    <p:sldId xmlns:r="http://schemas.openxmlformats.org/officeDocument/2006/relationships" id="261" r:id="Rfdddf3ad4dfe486c"/>
-    <p:sldId xmlns:r="http://schemas.openxmlformats.org/officeDocument/2006/relationships" id="262" r:id="R538c5572cd8647fe"/>
-    <p:sldId xmlns:r="http://schemas.openxmlformats.org/officeDocument/2006/relationships" id="263" r:id="R8ead4f6fc6c34715"/>
-    <p:sldId xmlns:r="http://schemas.openxmlformats.org/officeDocument/2006/relationships" id="264" r:id="R5275b0b33ac54591"/>
-    <p:sldId xmlns:r="http://schemas.openxmlformats.org/officeDocument/2006/relationships" id="265" r:id="Rc4cfd1cebdaf4549"/>
-    <p:sldId xmlns:r="http://schemas.openxmlformats.org/officeDocument/2006/relationships" id="266" r:id="Rac3fd519b2ed4680"/>
-    <p:sldId xmlns:r="http://schemas.openxmlformats.org/officeDocument/2006/relationships" id="267" r:id="Ra0bd8e66060d4c7d"/>
-    <p:sldId xmlns:r="http://schemas.openxmlformats.org/officeDocument/2006/relationships" id="268" r:id="R9f6a0221e2e34504"/>
-    <p:sldId xmlns:r="http://schemas.openxmlformats.org/officeDocument/2006/relationships" id="269" r:id="R03dbfd0795b2429b"/>
-    <p:sldId xmlns:r="http://schemas.openxmlformats.org/officeDocument/2006/relationships" id="270" r:id="R5ed5b0dbe0184bf5"/>
-    <p:sldId xmlns:r="http://schemas.openxmlformats.org/officeDocument/2006/relationships" id="271" r:id="R701f08f14c1546bf"/>
+    <p:sldId xmlns:r="http://schemas.openxmlformats.org/officeDocument/2006/relationships" id="256" r:id="R8313acdbd77e4fe1"/>
+    <p:sldId xmlns:r="http://schemas.openxmlformats.org/officeDocument/2006/relationships" id="257" r:id="Ra7d4f96e33f44181"/>
+    <p:sldId xmlns:r="http://schemas.openxmlformats.org/officeDocument/2006/relationships" id="258" r:id="R8119635919f9488e"/>
+    <p:sldId xmlns:r="http://schemas.openxmlformats.org/officeDocument/2006/relationships" id="259" r:id="R0d9158a3e087440b"/>
+    <p:sldId xmlns:r="http://schemas.openxmlformats.org/officeDocument/2006/relationships" id="260" r:id="R0831355b7ffd4a12"/>
+    <p:sldId xmlns:r="http://schemas.openxmlformats.org/officeDocument/2006/relationships" id="261" r:id="R48e76e09ac204b7b"/>
+    <p:sldId xmlns:r="http://schemas.openxmlformats.org/officeDocument/2006/relationships" id="262" r:id="Rb246e94a0f364798"/>
+    <p:sldId xmlns:r="http://schemas.openxmlformats.org/officeDocument/2006/relationships" id="263" r:id="Rdf8263ab5713403a"/>
+    <p:sldId xmlns:r="http://schemas.openxmlformats.org/officeDocument/2006/relationships" id="264" r:id="R5f43fc433c0f491c"/>
+    <p:sldId xmlns:r="http://schemas.openxmlformats.org/officeDocument/2006/relationships" id="265" r:id="R53852687c3fe42b4"/>
+    <p:sldId xmlns:r="http://schemas.openxmlformats.org/officeDocument/2006/relationships" id="266" r:id="R30ba1f83664c4559"/>
+    <p:sldId xmlns:r="http://schemas.openxmlformats.org/officeDocument/2006/relationships" id="267" r:id="Re05daabba0c241e3"/>
+    <p:sldId xmlns:r="http://schemas.openxmlformats.org/officeDocument/2006/relationships" id="268" r:id="Re33ed1f7f9484d47"/>
+    <p:sldId xmlns:r="http://schemas.openxmlformats.org/officeDocument/2006/relationships" id="269" r:id="R95237bce3e2d4ccc"/>
+    <p:sldId xmlns:r="http://schemas.openxmlformats.org/officeDocument/2006/relationships" id="270" r:id="R082cff9615e047e2"/>
+    <p:sldId xmlns:r="http://schemas.openxmlformats.org/officeDocument/2006/relationships" id="271" r:id="R60aca9d3f1ff46c4"/>
   </p:sldIdLst>
   <p:sldSz cx="12192000" cy="6858000"/>
   <p:notesSz cx="6858000" cy="9144000"/>
@@ -1575,7 +1575,7 @@
   </p:cSld>
   <p:clrMap bg1="lt1" tx1="dk1" bg2="lt2" tx2="dk2" accent1="accent1" accent2="accent2" accent3="accent3" accent4="accent4" accent5="accent5" accent6="accent6" hlink="hlink" folHlink="folHlink"/>
   <p:sldLayoutIdLst>
-    <p:sldLayoutId xmlns:r="http://schemas.openxmlformats.org/officeDocument/2006/relationships" id="2147483649" r:id="R2e7d05c7c5c64c6a"/>
+    <p:sldLayoutId xmlns:r="http://schemas.openxmlformats.org/officeDocument/2006/relationships" id="2147483649" r:id="R52fe8620d3d34080"/>
   </p:sldLayoutIdLst>
   <p:txStyles>
     <p:titleStyle>
@@ -12991,7 +12991,7 @@
           <p:cNvPr id="7" name="Chart">
             <a:extLst xmlns:a="http://schemas.openxmlformats.org/drawingml/2006/main">
               <a:ext uri="{FF2B5EF4-FFF2-40B4-BE49-F238E27FC236}">
-                <a16:creationId xmlns:a16="http://schemas.microsoft.com/office/drawing/2014/main" id="{7B4B94DE-6071-4008-B0F6-187BAB464083}"/>
+                <a16:creationId xmlns:a16="http://schemas.microsoft.com/office/drawing/2014/main" id="{34A09744-FE80-45B6-A80D-EBC5979C2AB6}"/>
               </a:ext>
             </a:extLst>
           </p:cNvPr>
@@ -13004,7 +13004,7 @@
         </p:xfrm>
         <a:graphic xmlns:a="http://schemas.openxmlformats.org/drawingml/2006/main">
           <a:graphicData uri="http://schemas.openxmlformats.org/drawingml/2006/chart">
-            <c:chart xmlns:r="http://schemas.openxmlformats.org/officeDocument/2006/relationships" xmlns:c="http://schemas.openxmlformats.org/drawingml/2006/chart" r:id="R25c5fb4c7ed8482f"/>
+            <c:chart xmlns:r="http://schemas.openxmlformats.org/officeDocument/2006/relationships" xmlns:c="http://schemas.openxmlformats.org/drawingml/2006/chart" r:id="R5897d08afdda47db"/>
           </a:graphicData>
         </a:graphic>
       </p:graphicFrame>
@@ -13289,7 +13289,7 @@
           <p:cNvPr id="13" name="">
             <a:extLst xmlns:a="http://schemas.openxmlformats.org/drawingml/2006/main">
               <a:ext uri="{FF2B5EF4-FFF2-40B4-BE49-F238E27FC236}">
-                <a16:creationId xmlns:a16="http://schemas.microsoft.com/office/drawing/2014/main" id="{3DFABB21-1E3F-49E0-989F-89A60D339510}"/>
+                <a16:creationId xmlns:a16="http://schemas.microsoft.com/office/drawing/2014/main" id="{83EBC292-8F9C-4BC9-B155-99E22BCE5808}"/>
               </a:ext>
             </a:extLst>
           </p:cNvPr>
@@ -13357,7 +13357,7 @@
           <p:cNvPr id="14" name="">
             <a:extLst xmlns:a="http://schemas.openxmlformats.org/drawingml/2006/main">
               <a:ext uri="{FF2B5EF4-FFF2-40B4-BE49-F238E27FC236}">
-                <a16:creationId xmlns:a16="http://schemas.microsoft.com/office/drawing/2014/main" id="{1666017E-1820-4397-9E35-9A4DD8D0D436}"/>
+                <a16:creationId xmlns:a16="http://schemas.microsoft.com/office/drawing/2014/main" id="{EBCAC07A-AA02-4AFB-9B20-42A7EEA4DD62}"/>
               </a:ext>
             </a:extLst>
           </p:cNvPr>
@@ -13367,7 +13367,7 @@
           <p:nvPr/>
         </p:nvPicPr>
         <p:blipFill>
-          <a:blip xmlns:r="http://schemas.openxmlformats.org/officeDocument/2006/relationships" xmlns:a="http://schemas.openxmlformats.org/drawingml/2006/main" r:embed="R6ce8d9ea4e5846e8"/>
+          <a:blip xmlns:r="http://schemas.openxmlformats.org/officeDocument/2006/relationships" xmlns:a="http://schemas.openxmlformats.org/drawingml/2006/main" r:embed="R1806c215d27b4f53"/>
           <a:stretch xmlns:a="http://schemas.openxmlformats.org/drawingml/2006/main"/>
         </p:blipFill>
         <p:spPr>
@@ -13385,7 +13385,7 @@
           <p:cNvPr id="15" name="">
             <a:extLst xmlns:a="http://schemas.openxmlformats.org/drawingml/2006/main">
               <a:ext uri="{FF2B5EF4-FFF2-40B4-BE49-F238E27FC236}">
-                <a16:creationId xmlns:a16="http://schemas.microsoft.com/office/drawing/2014/main" id="{889CB6D4-0893-420C-A86C-173724F66D34}"/>
+                <a16:creationId xmlns:a16="http://schemas.microsoft.com/office/drawing/2014/main" id="{5991515E-6BC1-4AE7-9FA5-FE55217306F2}"/>
               </a:ext>
             </a:extLst>
           </p:cNvPr>
@@ -13395,7 +13395,7 @@
           <p:nvPr/>
         </p:nvPicPr>
         <p:blipFill>
-          <a:blip xmlns:r="http://schemas.openxmlformats.org/officeDocument/2006/relationships" xmlns:a="http://schemas.openxmlformats.org/drawingml/2006/main" r:embed="R11701eff940a4332"/>
+          <a:blip xmlns:r="http://schemas.openxmlformats.org/officeDocument/2006/relationships" xmlns:a="http://schemas.openxmlformats.org/drawingml/2006/main" r:embed="Rafa17eb3e58440b9"/>
           <a:stretch xmlns:a="http://schemas.openxmlformats.org/drawingml/2006/main"/>
         </p:blipFill>
         <p:spPr>
@@ -13558,7 +13558,7 @@
           <p:cNvPr id="7" name="Chart">
             <a:extLst xmlns:a="http://schemas.openxmlformats.org/drawingml/2006/main">
               <a:ext uri="{FF2B5EF4-FFF2-40B4-BE49-F238E27FC236}">
-                <a16:creationId xmlns:a16="http://schemas.microsoft.com/office/drawing/2014/main" id="{2BB13AAC-8CFA-4FB0-9330-D7F4E5D84181}"/>
+                <a16:creationId xmlns:a16="http://schemas.microsoft.com/office/drawing/2014/main" id="{CE9077C5-ECEF-44E6-AD09-7F022E4FC236}"/>
               </a:ext>
             </a:extLst>
           </p:cNvPr>
@@ -13571,7 +13571,7 @@
         </p:xfrm>
         <a:graphic xmlns:a="http://schemas.openxmlformats.org/drawingml/2006/main">
           <a:graphicData uri="http://schemas.openxmlformats.org/drawingml/2006/chart">
-            <c:chart xmlns:r="http://schemas.openxmlformats.org/officeDocument/2006/relationships" xmlns:c="http://schemas.openxmlformats.org/drawingml/2006/chart" r:id="Rc34ec8bfc6b84876"/>
+            <c:chart xmlns:r="http://schemas.openxmlformats.org/officeDocument/2006/relationships" xmlns:c="http://schemas.openxmlformats.org/drawingml/2006/chart" r:id="R78d376bb9d16437e"/>
           </a:graphicData>
         </a:graphic>
       </p:graphicFrame>
@@ -13783,7 +13783,7 @@
           <p:cNvPr id="7" name="Chart">
             <a:extLst xmlns:a="http://schemas.openxmlformats.org/drawingml/2006/main">
               <a:ext uri="{FF2B5EF4-FFF2-40B4-BE49-F238E27FC236}">
-                <a16:creationId xmlns:a16="http://schemas.microsoft.com/office/drawing/2014/main" id="{3FD541E8-3A45-4099-9C1D-DC0F2C35DAEB}"/>
+                <a16:creationId xmlns:a16="http://schemas.microsoft.com/office/drawing/2014/main" id="{3DA2A730-636A-42F8-88B2-BE3A0A7986E9}"/>
               </a:ext>
             </a:extLst>
           </p:cNvPr>
@@ -13796,7 +13796,7 @@
         </p:xfrm>
         <a:graphic xmlns:a="http://schemas.openxmlformats.org/drawingml/2006/main">
           <a:graphicData uri="http://schemas.openxmlformats.org/drawingml/2006/chart">
-            <c:chart xmlns:r="http://schemas.openxmlformats.org/officeDocument/2006/relationships" xmlns:c="http://schemas.openxmlformats.org/drawingml/2006/chart" r:id="Re824dc36afd04e8b"/>
+            <c:chart xmlns:r="http://schemas.openxmlformats.org/officeDocument/2006/relationships" xmlns:c="http://schemas.openxmlformats.org/drawingml/2006/chart" r:id="R9a1313a6fe644599"/>
           </a:graphicData>
         </a:graphic>
       </p:graphicFrame>
@@ -14902,7 +14902,7 @@
           <p:cNvPr id="7" name="Chart">
             <a:extLst xmlns:a="http://schemas.openxmlformats.org/drawingml/2006/main">
               <a:ext uri="{FF2B5EF4-FFF2-40B4-BE49-F238E27FC236}">
-                <a16:creationId xmlns:a16="http://schemas.microsoft.com/office/drawing/2014/main" id="{D469FC99-D424-4403-B0AB-49D37FD817B3}"/>
+                <a16:creationId xmlns:a16="http://schemas.microsoft.com/office/drawing/2014/main" id="{BE0FA824-5354-49C7-A0AB-6AB9C5C854AE}"/>
               </a:ext>
             </a:extLst>
           </p:cNvPr>
@@ -14915,7 +14915,7 @@
         </p:xfrm>
         <a:graphic xmlns:a="http://schemas.openxmlformats.org/drawingml/2006/main">
           <a:graphicData uri="http://schemas.openxmlformats.org/drawingml/2006/chart">
-            <c:chart xmlns:r="http://schemas.openxmlformats.org/officeDocument/2006/relationships" xmlns:c="http://schemas.openxmlformats.org/drawingml/2006/chart" r:id="R7188b19dbfdd4615"/>
+            <c:chart xmlns:r="http://schemas.openxmlformats.org/officeDocument/2006/relationships" xmlns:c="http://schemas.openxmlformats.org/drawingml/2006/chart" r:id="Rb4cb7a71a38544c7"/>
           </a:graphicData>
         </a:graphic>
       </p:graphicFrame>
@@ -15752,10 +15752,10 @@
       </p:grpSpPr>
       <p:sp>
         <p:nvSpPr>
-          <p:cNvPr id="30" name="">
+          <p:cNvPr id="27" name="">
             <a:extLst xmlns:a="http://schemas.openxmlformats.org/drawingml/2006/main">
               <a:ext uri="{FF2B5EF4-FFF2-40B4-BE49-F238E27FC236}">
-                <a16:creationId xmlns:a16="http://schemas.microsoft.com/office/drawing/2014/main" id="{1D0812F8-88FE-448F-B647-A9AA7AC5622F}"/>
+                <a16:creationId xmlns:a16="http://schemas.microsoft.com/office/drawing/2014/main" id="{39FC07D8-4A67-46CF-90E5-566571889977}"/>
               </a:ext>
             </a:extLst>
           </p:cNvPr>
@@ -15823,7 +15823,7 @@
           <p:cNvPr id="2" name="">
             <a:extLst xmlns:a="http://schemas.openxmlformats.org/drawingml/2006/main">
               <a:ext uri="{FF2B5EF4-FFF2-40B4-BE49-F238E27FC236}">
-                <a16:creationId xmlns:a16="http://schemas.microsoft.com/office/drawing/2014/main" id="{4DC1F98D-89AD-49B0-AD27-31B74F47D543}"/>
+                <a16:creationId xmlns:a16="http://schemas.microsoft.com/office/drawing/2014/main" id="{DAAB8459-B98D-44D4-B254-998F5B0C0F11}"/>
               </a:ext>
             </a:extLst>
           </p:cNvPr>
@@ -15891,7 +15891,7 @@
           <p:cNvPr id="3" name="Quantidade de observações">
             <a:extLst xmlns:a="http://schemas.openxmlformats.org/drawingml/2006/main">
               <a:ext uri="{FF2B5EF4-FFF2-40B4-BE49-F238E27FC236}">
-                <a16:creationId xmlns:a16="http://schemas.microsoft.com/office/drawing/2014/main" id="{54787A93-9460-494E-9433-FA2C00E8EC01}"/>
+                <a16:creationId xmlns:a16="http://schemas.microsoft.com/office/drawing/2014/main" id="{36F8A0D9-1E1D-4183-B36E-B9ADFF5949AE}"/>
               </a:ext>
             </a:extLst>
           </p:cNvPr>
@@ -15923,7 +15923,7 @@
           <p:cNvPr id="4" name="Período de observação">
             <a:extLst xmlns:a="http://schemas.openxmlformats.org/drawingml/2006/main">
               <a:ext uri="{FF2B5EF4-FFF2-40B4-BE49-F238E27FC236}">
-                <a16:creationId xmlns:a16="http://schemas.microsoft.com/office/drawing/2014/main" id="{37BA034D-1C5C-4564-9D02-B92C57BF67F0}"/>
+                <a16:creationId xmlns:a16="http://schemas.microsoft.com/office/drawing/2014/main" id="{A8A0B190-6B21-4B17-B226-201AF27C7A2A}"/>
               </a:ext>
             </a:extLst>
           </p:cNvPr>
@@ -15955,7 +15955,7 @@
           <p:cNvPr id="5" name="Frequência temporal">
             <a:extLst xmlns:a="http://schemas.openxmlformats.org/drawingml/2006/main">
               <a:ext uri="{FF2B5EF4-FFF2-40B4-BE49-F238E27FC236}">
-                <a16:creationId xmlns:a16="http://schemas.microsoft.com/office/drawing/2014/main" id="{B567AD5E-639D-46B3-90DA-1BCA8714EECD}"/>
+                <a16:creationId xmlns:a16="http://schemas.microsoft.com/office/drawing/2014/main" id="{DEEF2480-59FF-4A58-B57E-CE289AF5308B}"/>
               </a:ext>
             </a:extLst>
           </p:cNvPr>
@@ -15987,7 +15987,7 @@
           <p:cNvPr id="6" name="">
             <a:extLst xmlns:a="http://schemas.openxmlformats.org/drawingml/2006/main">
               <a:ext uri="{FF2B5EF4-FFF2-40B4-BE49-F238E27FC236}">
-                <a16:creationId xmlns:a16="http://schemas.microsoft.com/office/drawing/2014/main" id="{58103F64-43E6-449D-9E1D-99A43A4AACDF}"/>
+                <a16:creationId xmlns:a16="http://schemas.microsoft.com/office/drawing/2014/main" id="{F36CC0F5-6B3D-4A42-8A44-36BA7E6E0C7A}"/>
               </a:ext>
             </a:extLst>
           </p:cNvPr>
@@ -16055,7 +16055,7 @@
           <p:cNvPr id="7" name="">
             <a:extLst xmlns:a="http://schemas.openxmlformats.org/drawingml/2006/main">
               <a:ext uri="{FF2B5EF4-FFF2-40B4-BE49-F238E27FC236}">
-                <a16:creationId xmlns:a16="http://schemas.microsoft.com/office/drawing/2014/main" id="{60E3A144-C020-4260-B75A-399A894F5D22}"/>
+                <a16:creationId xmlns:a16="http://schemas.microsoft.com/office/drawing/2014/main" id="{0B1DC9D0-EEDA-4B88-895E-1388A45EDF8D}"/>
               </a:ext>
             </a:extLst>
           </p:cNvPr>
@@ -16123,7 +16123,7 @@
           <p:cNvPr id="8" name="">
             <a:extLst xmlns:a="http://schemas.openxmlformats.org/drawingml/2006/main">
               <a:ext uri="{FF2B5EF4-FFF2-40B4-BE49-F238E27FC236}">
-                <a16:creationId xmlns:a16="http://schemas.microsoft.com/office/drawing/2014/main" id="{E7626ED7-3C74-45FE-B886-195F150C8503}"/>
+                <a16:creationId xmlns:a16="http://schemas.microsoft.com/office/drawing/2014/main" id="{8FC6A1D0-F4DB-4593-8128-3A434E98EFAC}"/>
               </a:ext>
             </a:extLst>
           </p:cNvPr>
@@ -16191,7 +16191,7 @@
           <p:cNvPr id="9" name="">
             <a:extLst xmlns:a="http://schemas.openxmlformats.org/drawingml/2006/main">
               <a:ext uri="{FF2B5EF4-FFF2-40B4-BE49-F238E27FC236}">
-                <a16:creationId xmlns:a16="http://schemas.microsoft.com/office/drawing/2014/main" id="{9C75C90B-AD75-4273-A72D-3E78335D6CC7}"/>
+                <a16:creationId xmlns:a16="http://schemas.microsoft.com/office/drawing/2014/main" id="{796E6EA4-FDDA-468A-93B1-CFC25EC43C44}"/>
               </a:ext>
             </a:extLst>
           </p:cNvPr>
@@ -16259,7 +16259,7 @@
           <p:cNvPr id="10" name="">
             <a:extLst xmlns:a="http://schemas.openxmlformats.org/drawingml/2006/main">
               <a:ext uri="{FF2B5EF4-FFF2-40B4-BE49-F238E27FC236}">
-                <a16:creationId xmlns:a16="http://schemas.microsoft.com/office/drawing/2014/main" id="{800FD950-988D-468E-8D5C-DDE0796DBE22}"/>
+                <a16:creationId xmlns:a16="http://schemas.microsoft.com/office/drawing/2014/main" id="{C9BFECF9-9F97-47A5-ADDC-6BD33061FADB}"/>
               </a:ext>
             </a:extLst>
           </p:cNvPr>
@@ -16327,7 +16327,7 @@
           <p:cNvPr id="11" name="">
             <a:extLst xmlns:a="http://schemas.openxmlformats.org/drawingml/2006/main">
               <a:ext uri="{FF2B5EF4-FFF2-40B4-BE49-F238E27FC236}">
-                <a16:creationId xmlns:a16="http://schemas.microsoft.com/office/drawing/2014/main" id="{C5FCCC24-F54D-4D6B-A9B9-FF76D0CBCD25}"/>
+                <a16:creationId xmlns:a16="http://schemas.microsoft.com/office/drawing/2014/main" id="{2EDE289E-5B31-416E-91F1-A2ABD03AE40C}"/>
               </a:ext>
             </a:extLst>
           </p:cNvPr>
@@ -16395,7 +16395,7 @@
           <p:cNvPr id="12" name="Estrutura e qualidade da base">
             <a:extLst xmlns:a="http://schemas.openxmlformats.org/drawingml/2006/main">
               <a:ext uri="{FF2B5EF4-FFF2-40B4-BE49-F238E27FC236}">
-                <a16:creationId xmlns:a16="http://schemas.microsoft.com/office/drawing/2014/main" id="{C883BFE9-A8AC-45D1-82F4-2957CBC5BCDD}"/>
+                <a16:creationId xmlns:a16="http://schemas.microsoft.com/office/drawing/2014/main" id="{EE33E4DA-55B5-4884-AD45-7D6CDBF4338E}"/>
               </a:ext>
             </a:extLst>
           </p:cNvPr>
@@ -16427,7 +16427,7 @@
           <p:cNvPr id="13" name="">
             <a:extLst xmlns:a="http://schemas.openxmlformats.org/drawingml/2006/main">
               <a:ext uri="{FF2B5EF4-FFF2-40B4-BE49-F238E27FC236}">
-                <a16:creationId xmlns:a16="http://schemas.microsoft.com/office/drawing/2014/main" id="{C7B03827-1F18-48EC-8FE8-E65C01217E5B}"/>
+                <a16:creationId xmlns:a16="http://schemas.microsoft.com/office/drawing/2014/main" id="{5CED7B65-9329-46DE-88ED-58DB7FCFD4E6}"/>
               </a:ext>
             </a:extLst>
           </p:cNvPr>
@@ -16495,7 +16495,7 @@
           <p:cNvPr id="14" name="Formato original">
             <a:extLst xmlns:a="http://schemas.openxmlformats.org/drawingml/2006/main">
               <a:ext uri="{FF2B5EF4-FFF2-40B4-BE49-F238E27FC236}">
-                <a16:creationId xmlns:a16="http://schemas.microsoft.com/office/drawing/2014/main" id="{05BCE7CF-ADD8-48D2-B8CA-AECC34E36593}"/>
+                <a16:creationId xmlns:a16="http://schemas.microsoft.com/office/drawing/2014/main" id="{12607929-D3FE-44F0-842D-A4A4C6645FE8}"/>
               </a:ext>
             </a:extLst>
           </p:cNvPr>
@@ -16527,7 +16527,7 @@
           <p:cNvPr id="15" name="Formato organizado">
             <a:extLst xmlns:a="http://schemas.openxmlformats.org/drawingml/2006/main">
               <a:ext uri="{FF2B5EF4-FFF2-40B4-BE49-F238E27FC236}">
-                <a16:creationId xmlns:a16="http://schemas.microsoft.com/office/drawing/2014/main" id="{05CC2234-9929-47EF-BF70-4F86522ECBE8}"/>
+                <a16:creationId xmlns:a16="http://schemas.microsoft.com/office/drawing/2014/main" id="{B1A6AB4C-BE6D-4A7D-B51D-D8C81E901FEC}"/>
               </a:ext>
             </a:extLst>
           </p:cNvPr>
@@ -16559,7 +16559,7 @@
           <p:cNvPr id="16" name="Transformação da tabela anual em série mensal">
             <a:extLst xmlns:a="http://schemas.openxmlformats.org/drawingml/2006/main">
               <a:ext uri="{FF2B5EF4-FFF2-40B4-BE49-F238E27FC236}">
-                <a16:creationId xmlns:a16="http://schemas.microsoft.com/office/drawing/2014/main" id="{B672B303-F0C0-4AB2-9709-7D5FF0334DFA}"/>
+                <a16:creationId xmlns:a16="http://schemas.microsoft.com/office/drawing/2014/main" id="{1E6F6512-3981-4207-9DC8-A701721229E5}"/>
               </a:ext>
             </a:extLst>
           </p:cNvPr>
@@ -16589,7 +16589,7 @@
           <p:cNvPr id="17" name="">
             <a:extLst xmlns:a="http://schemas.openxmlformats.org/drawingml/2006/main">
               <a:ext uri="{FF2B5EF4-FFF2-40B4-BE49-F238E27FC236}">
-                <a16:creationId xmlns:a16="http://schemas.microsoft.com/office/drawing/2014/main" id="{95C967BF-7501-42B4-903A-1F7D36525015}"/>
+                <a16:creationId xmlns:a16="http://schemas.microsoft.com/office/drawing/2014/main" id="{672A1160-1172-46C0-8EC2-5CF0D1B8F7BE}"/>
               </a:ext>
             </a:extLst>
           </p:cNvPr>
@@ -16657,7 +16657,7 @@
           <p:cNvPr id="18" name="">
             <a:extLst xmlns:a="http://schemas.openxmlformats.org/drawingml/2006/main">
               <a:ext uri="{FF2B5EF4-FFF2-40B4-BE49-F238E27FC236}">
-                <a16:creationId xmlns:a16="http://schemas.microsoft.com/office/drawing/2014/main" id="{61E52F26-C45A-4902-9D92-C1E256803B50}"/>
+                <a16:creationId xmlns:a16="http://schemas.microsoft.com/office/drawing/2014/main" id="{50307B54-ECE3-4F1E-A856-9E3D079ABAE8}"/>
               </a:ext>
             </a:extLst>
           </p:cNvPr>
@@ -16725,7 +16725,7 @@
           <p:cNvPr id="19" name="">
             <a:extLst xmlns:a="http://schemas.openxmlformats.org/drawingml/2006/main">
               <a:ext uri="{FF2B5EF4-FFF2-40B4-BE49-F238E27FC236}">
-                <a16:creationId xmlns:a16="http://schemas.microsoft.com/office/drawing/2014/main" id="{8EB05188-E41F-4EF0-881B-16C60A6994E5}"/>
+                <a16:creationId xmlns:a16="http://schemas.microsoft.com/office/drawing/2014/main" id="{1B0B2213-C19E-463A-9BDB-7129AA8D0F8C}"/>
               </a:ext>
             </a:extLst>
           </p:cNvPr>
@@ -16793,7 +16793,7 @@
           <p:cNvPr id="20" name="">
             <a:extLst xmlns:a="http://schemas.openxmlformats.org/drawingml/2006/main">
               <a:ext uri="{FF2B5EF4-FFF2-40B4-BE49-F238E27FC236}">
-                <a16:creationId xmlns:a16="http://schemas.microsoft.com/office/drawing/2014/main" id="{52900C9B-6708-4C37-9F54-924FFBBC1759}"/>
+                <a16:creationId xmlns:a16="http://schemas.microsoft.com/office/drawing/2014/main" id="{0145D069-C3B3-4131-9AE5-D0C31312C4C6}"/>
               </a:ext>
             </a:extLst>
           </p:cNvPr>
@@ -16861,7 +16861,7 @@
           <p:cNvPr id="21" name="">
             <a:extLst xmlns:a="http://schemas.openxmlformats.org/drawingml/2006/main">
               <a:ext uri="{FF2B5EF4-FFF2-40B4-BE49-F238E27FC236}">
-                <a16:creationId xmlns:a16="http://schemas.microsoft.com/office/drawing/2014/main" id="{DA2EBE47-F0AD-42F4-AC0D-13FF8BE54F2C}"/>
+                <a16:creationId xmlns:a16="http://schemas.microsoft.com/office/drawing/2014/main" id="{C8B7548C-94A1-43E7-B4AD-BE174CC32629}"/>
               </a:ext>
             </a:extLst>
           </p:cNvPr>
@@ -16952,7 +16952,7 @@
           <p:cNvPr id="22" name="Estatísticas descritivas da série completa">
             <a:extLst xmlns:a="http://schemas.openxmlformats.org/drawingml/2006/main">
               <a:ext uri="{FF2B5EF4-FFF2-40B4-BE49-F238E27FC236}">
-                <a16:creationId xmlns:a16="http://schemas.microsoft.com/office/drawing/2014/main" id="{3AB45C56-EF7C-4C9D-9744-861F38C4E4BC}"/>
+                <a16:creationId xmlns:a16="http://schemas.microsoft.com/office/drawing/2014/main" id="{A4F95604-12F5-4F0A-86A6-4CD4EAB080B7}"/>
               </a:ext>
             </a:extLst>
           </p:cNvPr>
@@ -16984,7 +16984,7 @@
           <p:cNvPr id="23" name="">
             <a:extLst xmlns:a="http://schemas.openxmlformats.org/drawingml/2006/main">
               <a:ext uri="{FF2B5EF4-FFF2-40B4-BE49-F238E27FC236}">
-                <a16:creationId xmlns:a16="http://schemas.microsoft.com/office/drawing/2014/main" id="{8EADAF9E-C32D-41F8-B240-B2FE38681CA1}"/>
+                <a16:creationId xmlns:a16="http://schemas.microsoft.com/office/drawing/2014/main" id="{A41CEC5D-4ECE-4899-ABB5-D15BF92602DC}"/>
               </a:ext>
             </a:extLst>
           </p:cNvPr>
@@ -17052,7 +17052,7 @@
           <p:cNvPr id="24" name="">
             <a:extLst xmlns:a="http://schemas.openxmlformats.org/drawingml/2006/main">
               <a:ext uri="{FF2B5EF4-FFF2-40B4-BE49-F238E27FC236}">
-                <a16:creationId xmlns:a16="http://schemas.microsoft.com/office/drawing/2014/main" id="{6A0ADDEA-FC66-4B43-A8F9-DE2282EE4BD2}"/>
+                <a16:creationId xmlns:a16="http://schemas.microsoft.com/office/drawing/2014/main" id="{94FC340D-6753-42CD-A339-6FF580F46104}"/>
               </a:ext>
             </a:extLst>
           </p:cNvPr>
@@ -17209,201 +17209,10 @@
       </p:sp>
       <p:sp>
         <p:nvSpPr>
-          <p:cNvPr id="25" name="Limitações da fonte">
+          <p:cNvPr id="25" name="">
             <a:extLst xmlns:a="http://schemas.openxmlformats.org/drawingml/2006/main">
               <a:ext uri="{FF2B5EF4-FFF2-40B4-BE49-F238E27FC236}">
-                <a16:creationId xmlns:a16="http://schemas.microsoft.com/office/drawing/2014/main" id="{FF710588-EF32-4DAB-92BE-18F0D6B413F2}"/>
-              </a:ext>
-            </a:extLst>
-          </p:cNvPr>
-          <p:cNvSpPr>
-            <a:spLocks xmlns:a="http://schemas.openxmlformats.org/drawingml/2006/main" noGrp="1"/>
-          </p:cNvSpPr>
-          <p:nvPr/>
-        </p:nvSpPr>
-        <p:spPr>
-          <a:xfrm xmlns:a="http://schemas.openxmlformats.org/drawingml/2006/main">
-            <a:off x="609600" y="5657850"/>
-            <a:ext cx="10972800" cy="666750"/>
-          </a:xfrm>
-          <a:prstGeom xmlns:a="http://schemas.openxmlformats.org/drawingml/2006/main" prst="roundRect">
-            <a:avLst>
-              <a:gd name="adj" fmla="val 25714"/>
-            </a:avLst>
-          </a:prstGeom>
-          <a:solidFill xmlns:a="http://schemas.openxmlformats.org/drawingml/2006/main">
-            <a:srgbClr val="D9AC69"/>
-          </a:solidFill>
-          <a:ln xmlns:a="http://schemas.openxmlformats.org/drawingml/2006/main" w="0">
-            <a:noFill/>
-          </a:ln>
-        </p:spPr>
-      </p:sp>
-      <p:sp>
-        <p:nvSpPr>
-          <p:cNvPr id="26" name="">
-            <a:extLst xmlns:a="http://schemas.openxmlformats.org/drawingml/2006/main">
-              <a:ext uri="{FF2B5EF4-FFF2-40B4-BE49-F238E27FC236}">
-                <a16:creationId xmlns:a16="http://schemas.microsoft.com/office/drawing/2014/main" id="{54A557F5-8B5C-4665-8159-C5223DB3B06C}"/>
-              </a:ext>
-            </a:extLst>
-          </p:cNvPr>
-          <p:cNvSpPr>
-            <a:spLocks xmlns:a="http://schemas.openxmlformats.org/drawingml/2006/main" noGrp="1"/>
-          </p:cNvSpPr>
-          <p:nvPr/>
-        </p:nvSpPr>
-        <p:spPr>
-          <a:xfrm xmlns:a="http://schemas.openxmlformats.org/drawingml/2006/main">
-            <a:off x="800100" y="5810250"/>
-            <a:ext cx="2190750" cy="381000"/>
-          </a:xfrm>
-          <a:prstGeom xmlns:a="http://schemas.openxmlformats.org/drawingml/2006/main" prst="rect">
-            <a:avLst/>
-          </a:prstGeom>
-          <a:noFill xmlns:a="http://schemas.openxmlformats.org/drawingml/2006/main"/>
-          <a:ln xmlns:a="http://schemas.openxmlformats.org/drawingml/2006/main" w="0">
-            <a:noFill/>
-          </a:ln>
-        </p:spPr>
-        <p:txBody>
-          <a:bodyPr xmlns:a="http://schemas.openxmlformats.org/drawingml/2006/main">
-            <a:noAutofit/>
-          </a:bodyPr>
-          <a:lstStyle xmlns:a="http://schemas.openxmlformats.org/drawingml/2006/main">
-            <a:defPPr>
-              <a:defRPr sz="1800" b="1">
-                <a:solidFill>
-                  <a:srgbClr val="102E3A"/>
-                </a:solidFill>
-                <a:latin typeface="Arial"/>
-                <a:ea typeface="Arial"/>
-                <a:cs typeface="Arial"/>
-              </a:defRPr>
-            </a:defPPr>
-          </a:lstStyle>
-          <a:p xmlns:a="http://schemas.openxmlformats.org/drawingml/2006/main">
-            <a:pPr>
-              <a:defRPr sz="1800" b="1">
-                <a:solidFill>
-                  <a:srgbClr val="102E3A"/>
-                </a:solidFill>
-                <a:latin typeface="Arial"/>
-                <a:ea typeface="Arial"/>
-                <a:cs typeface="Arial"/>
-              </a:defRPr>
-            </a:pPr>
-            <a:r>
-              <a:rPr sz="1800" b="1">
-                <a:solidFill>
-                  <a:srgbClr val="102E3A"/>
-                </a:solidFill>
-                <a:latin typeface="Arial"/>
-                <a:ea typeface="Arial"/>
-                <a:cs typeface="Arial"/>
-              </a:rPr>
-              <a:t>Limites da fonte</a:t>
-            </a:r>
-          </a:p>
-        </p:txBody>
-      </p:sp>
-      <p:sp>
-        <p:nvSpPr>
-          <p:cNvPr id="27" name="">
-            <a:extLst xmlns:a="http://schemas.openxmlformats.org/drawingml/2006/main">
-              <a:ext uri="{FF2B5EF4-FFF2-40B4-BE49-F238E27FC236}">
-                <a16:creationId xmlns:a16="http://schemas.microsoft.com/office/drawing/2014/main" id="{08F77D54-D271-4AC1-9CA9-E4EAC68300CA}"/>
-              </a:ext>
-            </a:extLst>
-          </p:cNvPr>
-          <p:cNvSpPr>
-            <a:spLocks xmlns:a="http://schemas.openxmlformats.org/drawingml/2006/main" noGrp="1"/>
-          </p:cNvSpPr>
-          <p:nvPr/>
-        </p:nvSpPr>
-        <p:spPr>
-          <a:xfrm xmlns:a="http://schemas.openxmlformats.org/drawingml/2006/main">
-            <a:off x="3076575" y="5734050"/>
-            <a:ext cx="8267700" cy="552450"/>
-          </a:xfrm>
-          <a:prstGeom xmlns:a="http://schemas.openxmlformats.org/drawingml/2006/main" prst="rect">
-            <a:avLst/>
-          </a:prstGeom>
-          <a:noFill xmlns:a="http://schemas.openxmlformats.org/drawingml/2006/main"/>
-          <a:ln xmlns:a="http://schemas.openxmlformats.org/drawingml/2006/main" w="0">
-            <a:noFill/>
-          </a:ln>
-        </p:spPr>
-        <p:txBody>
-          <a:bodyPr xmlns:a="http://schemas.openxmlformats.org/drawingml/2006/main">
-            <a:noAutofit/>
-          </a:bodyPr>
-          <a:lstStyle xmlns:a="http://schemas.openxmlformats.org/drawingml/2006/main">
-            <a:defPPr>
-              <a:defRPr sz="1650" b="0">
-                <a:solidFill>
-                  <a:srgbClr val="102E3A"/>
-                </a:solidFill>
-                <a:latin typeface="Arial"/>
-                <a:ea typeface="Arial"/>
-                <a:cs typeface="Arial"/>
-              </a:defRPr>
-            </a:defPPr>
-          </a:lstStyle>
-          <a:p xmlns:a="http://schemas.openxmlformats.org/drawingml/2006/main">
-            <a:pPr>
-              <a:defRPr sz="1650" b="0">
-                <a:solidFill>
-                  <a:srgbClr val="102E3A"/>
-                </a:solidFill>
-                <a:latin typeface="Arial"/>
-                <a:ea typeface="Arial"/>
-                <a:cs typeface="Arial"/>
-              </a:defRPr>
-            </a:pPr>
-            <a:r>
-              <a:rPr sz="1650" b="0">
-                <a:solidFill>
-                  <a:srgbClr val="102E3A"/>
-                </a:solidFill>
-                <a:latin typeface="Arial"/>
-                <a:ea typeface="Arial"/>
-                <a:cs typeface="Arial"/>
-              </a:rPr>
-              <a:t>Unidade e tipo de vazão não informados.</a:t>
-            </a:r>
-          </a:p>
-          <a:p xmlns:a="http://schemas.openxmlformats.org/drawingml/2006/main">
-            <a:pPr>
-              <a:defRPr sz="1650" b="0">
-                <a:solidFill>
-                  <a:srgbClr val="102E3A"/>
-                </a:solidFill>
-                <a:latin typeface="Arial"/>
-                <a:ea typeface="Arial"/>
-                <a:cs typeface="Arial"/>
-              </a:defRPr>
-            </a:pPr>
-            <a:r>
-              <a:rPr sz="1650" b="0">
-                <a:solidFill>
-                  <a:srgbClr val="102E3A"/>
-                </a:solidFill>
-                <a:latin typeface="Arial"/>
-                <a:ea typeface="Arial"/>
-                <a:cs typeface="Arial"/>
-              </a:rPr>
-              <a:t>A base termina em 2016, sem observações de 2017.</a:t>
-            </a:r>
-          </a:p>
-        </p:txBody>
-      </p:sp>
-      <p:sp>
-        <p:nvSpPr>
-          <p:cNvPr id="28" name="">
-            <a:extLst xmlns:a="http://schemas.openxmlformats.org/drawingml/2006/main">
-              <a:ext uri="{FF2B5EF4-FFF2-40B4-BE49-F238E27FC236}">
-                <a16:creationId xmlns:a16="http://schemas.microsoft.com/office/drawing/2014/main" id="{52859492-012B-46F2-B2DA-B2EA3C4925F1}"/>
+                <a16:creationId xmlns:a16="http://schemas.microsoft.com/office/drawing/2014/main" id="{355A68CA-B57A-4068-9FDD-C71B85452E27}"/>
               </a:ext>
             </a:extLst>
           </p:cNvPr>
@@ -17468,10 +17277,10 @@
       </p:sp>
       <p:sp>
         <p:nvSpPr>
-          <p:cNvPr id="29" name="">
+          <p:cNvPr id="26" name="">
             <a:extLst xmlns:a="http://schemas.openxmlformats.org/drawingml/2006/main">
               <a:ext uri="{FF2B5EF4-FFF2-40B4-BE49-F238E27FC236}">
-                <a16:creationId xmlns:a16="http://schemas.microsoft.com/office/drawing/2014/main" id="{6C68BFAB-9591-4A47-B812-D9A787A58347}"/>
+                <a16:creationId xmlns:a16="http://schemas.microsoft.com/office/drawing/2014/main" id="{DEAEEA4A-15F6-44DA-90D3-586D36FFFD7E}"/>
               </a:ext>
             </a:extLst>
           </p:cNvPr>
@@ -17684,7 +17493,7 @@
           <p:cNvPr id="7" name="Chart">
             <a:extLst xmlns:a="http://schemas.openxmlformats.org/drawingml/2006/main">
               <a:ext uri="{FF2B5EF4-FFF2-40B4-BE49-F238E27FC236}">
-                <a16:creationId xmlns:a16="http://schemas.microsoft.com/office/drawing/2014/main" id="{FCE826FD-7A26-4CB5-8498-F7321BBB6545}"/>
+                <a16:creationId xmlns:a16="http://schemas.microsoft.com/office/drawing/2014/main" id="{4EF0225D-901A-4A96-BC9F-AA1FDB2BE59A}"/>
               </a:ext>
             </a:extLst>
           </p:cNvPr>
@@ -17697,7 +17506,7 @@
         </p:xfrm>
         <a:graphic xmlns:a="http://schemas.openxmlformats.org/drawingml/2006/main">
           <a:graphicData uri="http://schemas.openxmlformats.org/drawingml/2006/chart">
-            <c:chart xmlns:r="http://schemas.openxmlformats.org/officeDocument/2006/relationships" xmlns:c="http://schemas.openxmlformats.org/drawingml/2006/chart" r:id="R8337ec6ee1b74a6c"/>
+            <c:chart xmlns:r="http://schemas.openxmlformats.org/officeDocument/2006/relationships" xmlns:c="http://schemas.openxmlformats.org/drawingml/2006/chart" r:id="Raa72f78479e24150"/>
           </a:graphicData>
         </a:graphic>
       </p:graphicFrame>
@@ -19571,7 +19380,7 @@
           <p:cNvPr id="7" name="Chart">
             <a:extLst xmlns:a="http://schemas.openxmlformats.org/drawingml/2006/main">
               <a:ext uri="{FF2B5EF4-FFF2-40B4-BE49-F238E27FC236}">
-                <a16:creationId xmlns:a16="http://schemas.microsoft.com/office/drawing/2014/main" id="{17F1D798-A2EF-4FAD-BC5C-98BCD93EE028}"/>
+                <a16:creationId xmlns:a16="http://schemas.microsoft.com/office/drawing/2014/main" id="{E88DFEDA-FE7C-49A1-B4C2-0EDF9644B897}"/>
               </a:ext>
             </a:extLst>
           </p:cNvPr>
@@ -19584,7 +19393,7 @@
         </p:xfrm>
         <a:graphic xmlns:a="http://schemas.openxmlformats.org/drawingml/2006/main">
           <a:graphicData uri="http://schemas.openxmlformats.org/drawingml/2006/chart">
-            <c:chart xmlns:r="http://schemas.openxmlformats.org/officeDocument/2006/relationships" xmlns:c="http://schemas.openxmlformats.org/drawingml/2006/chart" r:id="R19c0a88342f04a35"/>
+            <c:chart xmlns:r="http://schemas.openxmlformats.org/officeDocument/2006/relationships" xmlns:c="http://schemas.openxmlformats.org/drawingml/2006/chart" r:id="R33ef9f5bd66b418b"/>
           </a:graphicData>
         </a:graphic>
       </p:graphicFrame>
@@ -19796,7 +19605,7 @@
           <p:cNvPr id="7" name="Chart">
             <a:extLst xmlns:a="http://schemas.openxmlformats.org/drawingml/2006/main">
               <a:ext uri="{FF2B5EF4-FFF2-40B4-BE49-F238E27FC236}">
-                <a16:creationId xmlns:a16="http://schemas.microsoft.com/office/drawing/2014/main" id="{CC3169DE-C050-48D9-93D9-F30CCCD94044}"/>
+                <a16:creationId xmlns:a16="http://schemas.microsoft.com/office/drawing/2014/main" id="{63FCB30D-890A-40FA-A860-C04161E68ADD}"/>
               </a:ext>
             </a:extLst>
           </p:cNvPr>
@@ -19809,7 +19618,7 @@
         </p:xfrm>
         <a:graphic xmlns:a="http://schemas.openxmlformats.org/drawingml/2006/main">
           <a:graphicData uri="http://schemas.openxmlformats.org/drawingml/2006/chart">
-            <c:chart xmlns:r="http://schemas.openxmlformats.org/officeDocument/2006/relationships" xmlns:c="http://schemas.openxmlformats.org/drawingml/2006/chart" r:id="Re2299b3416b742a4"/>
+            <c:chart xmlns:r="http://schemas.openxmlformats.org/officeDocument/2006/relationships" xmlns:c="http://schemas.openxmlformats.org/drawingml/2006/chart" r:id="Rbacb8a508dac442e"/>
           </a:graphicData>
         </a:graphic>
       </p:graphicFrame>

</xml_diff>